<commit_message>
Add draw.io architecture diagram and a $0 on-prem cost option
- docs/diagrams: build_diagram.py generates architecture.drawio (editable
  draw.io source) and architecture.svg (rendered, with the source embedded so
  it round-trips in draw.io). Embed the SVG in design.md, replacing the ASCII art.
- presentation: cost slide now shows three options — commercial vs. AWS vs.
  repurposing an existing on-prem server at $0 hosting; regenerate the .pptx.

Co-Authored-By: Claude Opus 4.8 <noreply@anthropic.com>
</commit_message>
<xml_diff>
--- a/presentation/Northbridge_EndpointManagement_ExecBrief.pptx
+++ b/presentation/Northbridge_EndpointManagement_ExecBrief.pptx
@@ -585,7 +585,7 @@
           <a:lstStyle/>
           <a:p>
             <a:r>
-              <a:t>Be transparent: the numbers are illustrative ranges, not quotes. The honest trade-off is licensing dollars vs. internal staff time. Even costing our time, the savings are large — and the data stays in-house.</a:t>
+              <a:t>Three ways to pay for this. The numbers are illustrative ranges, not quotes. Option 3 is the kicker for a cost-conscious board: if we have a server with spare capacity, hosting is effectively free — we only spend a little internal time. Even on AWS, we're an order of magnitude below commercial per-seat pricing, and in every case the data stays in-house.</a:t>
             </a:r>
           </a:p>
         </p:txBody>
@@ -4879,8 +4879,8 @@
         </p:nvSpPr>
         <p:spPr>
           <a:xfrm>
-            <a:off x="822960" y="1920240"/>
-            <a:ext cx="5120640" cy="3291840"/>
+            <a:off x="548640" y="1874519"/>
+            <a:ext cx="3474720" cy="3429000"/>
           </a:xfrm>
           <a:prstGeom prst="rect">
             <a:avLst/>
@@ -4923,8 +4923,8 @@
         </p:nvSpPr>
         <p:spPr>
           <a:xfrm>
-            <a:off x="822960" y="1920240"/>
-            <a:ext cx="5120640" cy="109728"/>
+            <a:off x="548640" y="1874519"/>
+            <a:ext cx="3474720" cy="109728"/>
           </a:xfrm>
           <a:prstGeom prst="rect">
             <a:avLst/>
@@ -4967,8 +4967,8 @@
         </p:nvSpPr>
         <p:spPr>
           <a:xfrm>
-            <a:off x="1097280" y="2194560"/>
-            <a:ext cx="4572000" cy="2834640"/>
+            <a:off x="804672" y="2167127"/>
+            <a:ext cx="2962656" cy="2971800"/>
           </a:xfrm>
           <a:prstGeom prst="rect">
             <a:avLst/>
@@ -4986,17 +4986,74 @@
                 <a:spcPts val="0"/>
               </a:spcBef>
               <a:spcAft>
+                <a:spcPts val="1200"/>
+              </a:spcAft>
+            </a:pPr>
+            <a:r>
+              <a:rPr sz="1600" b="1">
+                <a:solidFill>
+                  <a:srgbClr val="0B2545"/>
+                </a:solidFill>
+                <a:latin typeface="Calibri"/>
+              </a:rPr>
+              <a:t>Commercial tools</a:t>
+            </a:r>
+          </a:p>
+          <a:p>
+            <a:pPr algn="l">
+              <a:spcBef>
+                <a:spcPts val="0"/>
+              </a:spcBef>
+              <a:spcAft>
+                <a:spcPts val="1400"/>
+              </a:spcAft>
+            </a:pPr>
+            <a:r>
+              <a:rPr sz="2100" b="1">
+                <a:solidFill>
+                  <a:srgbClr val="C0392B"/>
+                </a:solidFill>
+                <a:latin typeface="Calibri Light"/>
+              </a:rPr>
+              <a:t>$3–7 / device / mo</a:t>
+            </a:r>
+          </a:p>
+          <a:p>
+            <a:pPr algn="l">
+              <a:spcBef>
+                <a:spcPts val="0"/>
+              </a:spcBef>
+              <a:spcAft>
+                <a:spcPts val="300"/>
+              </a:spcAft>
+            </a:pPr>
+            <a:r>
+              <a:rPr sz="1300" b="0">
+                <a:solidFill>
+                  <a:srgbClr val="5A6B7B"/>
+                </a:solidFill>
+                <a:latin typeface="Calibri"/>
+              </a:rPr>
+              <a:t>~500 devices  ≈</a:t>
+            </a:r>
+          </a:p>
+          <a:p>
+            <a:pPr algn="l">
+              <a:spcBef>
+                <a:spcPts val="0"/>
+              </a:spcBef>
+              <a:spcAft>
                 <a:spcPts val="1000"/>
               </a:spcAft>
             </a:pPr>
             <a:r>
-              <a:rPr sz="1800" b="1">
-                <a:solidFill>
-                  <a:srgbClr val="0B2545"/>
-                </a:solidFill>
-                <a:latin typeface="Calibri"/>
-              </a:rPr>
-              <a:t>Commercial tools</a:t>
+              <a:rPr sz="1300" b="0">
+                <a:solidFill>
+                  <a:srgbClr val="5A6B7B"/>
+                </a:solidFill>
+                <a:latin typeface="Calibri"/>
+              </a:rPr>
+              <a:t>$18,000–42,000 / year</a:t>
             </a:r>
           </a:p>
           <a:p>
@@ -5005,17 +5062,17 @@
                 <a:spcPts val="0"/>
               </a:spcBef>
               <a:spcAft>
-                <a:spcPts val="1000"/>
-              </a:spcAft>
-            </a:pPr>
-            <a:r>
-              <a:rPr sz="1600" b="1">
-                <a:solidFill>
-                  <a:srgbClr val="C0392B"/>
-                </a:solidFill>
-                <a:latin typeface="Calibri"/>
-              </a:rPr>
-              <a:t>$3–7 per device, per month</a:t>
+                <a:spcPts val="300"/>
+              </a:spcAft>
+            </a:pPr>
+            <a:r>
+              <a:rPr sz="1300" b="0">
+                <a:solidFill>
+                  <a:srgbClr val="5A6B7B"/>
+                </a:solidFill>
+                <a:latin typeface="Calibri"/>
+              </a:rPr>
+              <a:t>Ongoing per-seat fees,</a:t>
             </a:r>
           </a:p>
           <a:p>
@@ -5024,36 +5081,17 @@
                 <a:spcPts val="0"/>
               </a:spcBef>
               <a:spcAft>
-                <a:spcPts val="1000"/>
-              </a:spcAft>
-            </a:pPr>
-            <a:r>
-              <a:rPr sz="1500" b="0">
+                <a:spcPts val="300"/>
+              </a:spcAft>
+            </a:pPr>
+            <a:r>
+              <a:rPr sz="1300" b="0">
                 <a:solidFill>
                   <a:srgbClr val="5A6B7B"/>
                 </a:solidFill>
                 <a:latin typeface="Calibri"/>
               </a:rPr>
-              <a:t>~500 devices  ≈  $18,000–42,000 / year</a:t>
-            </a:r>
-          </a:p>
-          <a:p>
-            <a:pPr algn="l">
-              <a:spcBef>
-                <a:spcPts val="0"/>
-              </a:spcBef>
-              <a:spcAft>
-                <a:spcPts val="800"/>
-              </a:spcAft>
-            </a:pPr>
-            <a:r>
-              <a:rPr sz="1300" b="0">
-                <a:solidFill>
-                  <a:srgbClr val="5A6B7B"/>
-                </a:solidFill>
-                <a:latin typeface="Calibri"/>
-              </a:rPr>
-              <a:t>Ongoing, per-seat, and rising as we grow.</a:t>
+              <a:t>rising as we grow.</a:t>
             </a:r>
           </a:p>
         </p:txBody>
@@ -5066,8 +5104,8 @@
         </p:nvSpPr>
         <p:spPr>
           <a:xfrm>
-            <a:off x="6263640" y="1920240"/>
-            <a:ext cx="5120640" cy="3291840"/>
+            <a:off x="4352544" y="1874519"/>
+            <a:ext cx="3474720" cy="3429000"/>
           </a:xfrm>
           <a:prstGeom prst="rect">
             <a:avLst/>
@@ -5110,8 +5148,233 @@
         </p:nvSpPr>
         <p:spPr>
           <a:xfrm>
-            <a:off x="6263640" y="1920240"/>
-            <a:ext cx="5120640" cy="109728"/>
+            <a:off x="4352544" y="1874519"/>
+            <a:ext cx="3474720" cy="109728"/>
+          </a:xfrm>
+          <a:prstGeom prst="rect">
+            <a:avLst/>
+          </a:prstGeom>
+          <a:solidFill>
+            <a:srgbClr val="13A89E"/>
+          </a:solidFill>
+          <a:ln>
+            <a:noFill/>
+          </a:ln>
+          <a:effectLst/>
+        </p:spPr>
+        <p:style>
+          <a:lnRef idx="1">
+            <a:schemeClr val="accent1"/>
+          </a:lnRef>
+          <a:fillRef idx="3">
+            <a:schemeClr val="accent1"/>
+          </a:fillRef>
+          <a:effectRef idx="2">
+            <a:schemeClr val="accent1"/>
+          </a:effectRef>
+          <a:fontRef idx="minor">
+            <a:schemeClr val="lt1"/>
+          </a:fontRef>
+        </p:style>
+        <p:txBody>
+          <a:bodyPr rtlCol="0" anchor="ctr"/>
+          <a:lstStyle/>
+          <a:p>
+            <a:pPr algn="ctr"/>
+          </a:p>
+        </p:txBody>
+      </p:sp>
+      <p:sp>
+        <p:nvSpPr>
+          <p:cNvPr id="10" name="TextBox 9"/>
+          <p:cNvSpPr txBox="1"/>
+          <p:nvPr/>
+        </p:nvSpPr>
+        <p:spPr>
+          <a:xfrm>
+            <a:off x="4608576" y="2167127"/>
+            <a:ext cx="2962656" cy="2971800"/>
+          </a:xfrm>
+          <a:prstGeom prst="rect">
+            <a:avLst/>
+          </a:prstGeom>
+          <a:noFill/>
+        </p:spPr>
+        <p:txBody>
+          <a:bodyPr wrap="square" anchor="t">
+            <a:spAutoFit/>
+          </a:bodyPr>
+          <a:lstStyle/>
+          <a:p>
+            <a:pPr algn="l">
+              <a:spcBef>
+                <a:spcPts val="0"/>
+              </a:spcBef>
+              <a:spcAft>
+                <a:spcPts val="1200"/>
+              </a:spcAft>
+            </a:pPr>
+            <a:r>
+              <a:rPr sz="1600" b="1">
+                <a:solidFill>
+                  <a:srgbClr val="0B2545"/>
+                </a:solidFill>
+                <a:latin typeface="Calibri"/>
+              </a:rPr>
+              <a:t>This solution — AWS</a:t>
+            </a:r>
+          </a:p>
+          <a:p>
+            <a:pPr algn="l">
+              <a:spcBef>
+                <a:spcPts val="0"/>
+              </a:spcBef>
+              <a:spcAft>
+                <a:spcPts val="1400"/>
+              </a:spcAft>
+            </a:pPr>
+            <a:r>
+              <a:rPr sz="2100" b="1">
+                <a:solidFill>
+                  <a:srgbClr val="13A89E"/>
+                </a:solidFill>
+                <a:latin typeface="Calibri Light"/>
+              </a:rPr>
+              <a:t>~$100 / month</a:t>
+            </a:r>
+          </a:p>
+          <a:p>
+            <a:pPr algn="l">
+              <a:spcBef>
+                <a:spcPts val="0"/>
+              </a:spcBef>
+              <a:spcAft>
+                <a:spcPts val="300"/>
+              </a:spcAft>
+            </a:pPr>
+            <a:r>
+              <a:rPr sz="1300" b="0">
+                <a:solidFill>
+                  <a:srgbClr val="5A6B7B"/>
+                </a:solidFill>
+                <a:latin typeface="Calibri"/>
+              </a:rPr>
+              <a:t>≈ $1,200 / year</a:t>
+            </a:r>
+          </a:p>
+          <a:p>
+            <a:pPr algn="l">
+              <a:spcBef>
+                <a:spcPts val="0"/>
+              </a:spcBef>
+              <a:spcAft>
+                <a:spcPts val="1000"/>
+              </a:spcAft>
+            </a:pPr>
+            <a:r>
+              <a:rPr sz="1300" b="0">
+                <a:solidFill>
+                  <a:srgbClr val="5A6B7B"/>
+                </a:solidFill>
+                <a:latin typeface="Calibri"/>
+              </a:rPr>
+              <a:t>+ existing IT staff time</a:t>
+            </a:r>
+          </a:p>
+          <a:p>
+            <a:pPr algn="l">
+              <a:spcBef>
+                <a:spcPts val="0"/>
+              </a:spcBef>
+              <a:spcAft>
+                <a:spcPts val="300"/>
+              </a:spcAft>
+            </a:pPr>
+            <a:r>
+              <a:rPr sz="1300" b="0">
+                <a:solidFill>
+                  <a:srgbClr val="5A6B7B"/>
+                </a:solidFill>
+                <a:latin typeface="Calibri"/>
+              </a:rPr>
+              <a:t>No per-seat fees;</a:t>
+            </a:r>
+          </a:p>
+          <a:p>
+            <a:pPr algn="l">
+              <a:spcBef>
+                <a:spcPts val="0"/>
+              </a:spcBef>
+              <a:spcAft>
+                <a:spcPts val="300"/>
+              </a:spcAft>
+            </a:pPr>
+            <a:r>
+              <a:rPr sz="1300" b="0">
+                <a:solidFill>
+                  <a:srgbClr val="5A6B7B"/>
+                </a:solidFill>
+                <a:latin typeface="Calibri"/>
+              </a:rPr>
+              <a:t>scales to 500+ at flat cost.</a:t>
+            </a:r>
+          </a:p>
+        </p:txBody>
+      </p:sp>
+      <p:sp>
+        <p:nvSpPr>
+          <p:cNvPr id="11" name="Rectangle 10"/>
+          <p:cNvSpPr/>
+          <p:nvPr/>
+        </p:nvSpPr>
+        <p:spPr>
+          <a:xfrm>
+            <a:off x="8156448" y="1874519"/>
+            <a:ext cx="3474720" cy="3429000"/>
+          </a:xfrm>
+          <a:prstGeom prst="rect">
+            <a:avLst/>
+          </a:prstGeom>
+          <a:solidFill>
+            <a:srgbClr val="F2F5F8"/>
+          </a:solidFill>
+          <a:ln>
+            <a:noFill/>
+          </a:ln>
+          <a:effectLst/>
+        </p:spPr>
+        <p:style>
+          <a:lnRef idx="1">
+            <a:schemeClr val="accent1"/>
+          </a:lnRef>
+          <a:fillRef idx="3">
+            <a:schemeClr val="accent1"/>
+          </a:fillRef>
+          <a:effectRef idx="2">
+            <a:schemeClr val="accent1"/>
+          </a:effectRef>
+          <a:fontRef idx="minor">
+            <a:schemeClr val="lt1"/>
+          </a:fontRef>
+        </p:style>
+        <p:txBody>
+          <a:bodyPr rtlCol="0" anchor="ctr"/>
+          <a:lstStyle/>
+          <a:p>
+            <a:pPr algn="ctr"/>
+          </a:p>
+        </p:txBody>
+      </p:sp>
+      <p:sp>
+        <p:nvSpPr>
+          <p:cNvPr id="12" name="Rectangle 11"/>
+          <p:cNvSpPr/>
+          <p:nvPr/>
+        </p:nvSpPr>
+        <p:spPr>
+          <a:xfrm>
+            <a:off x="8156448" y="1874519"/>
+            <a:ext cx="3474720" cy="109728"/>
           </a:xfrm>
           <a:prstGeom prst="rect">
             <a:avLst/>
@@ -5148,14 +5411,14 @@
       </p:sp>
       <p:sp>
         <p:nvSpPr>
-          <p:cNvPr id="10" name="TextBox 9"/>
+          <p:cNvPr id="13" name="TextBox 12"/>
           <p:cNvSpPr txBox="1"/>
           <p:nvPr/>
         </p:nvSpPr>
         <p:spPr>
           <a:xfrm>
-            <a:off x="6537960" y="2194560"/>
-            <a:ext cx="4572000" cy="2834640"/>
+            <a:off x="8412480" y="2167127"/>
+            <a:ext cx="2962656" cy="2971800"/>
           </a:xfrm>
           <a:prstGeom prst="rect">
             <a:avLst/>
@@ -5173,17 +5436,74 @@
                 <a:spcPts val="0"/>
               </a:spcBef>
               <a:spcAft>
+                <a:spcPts val="1200"/>
+              </a:spcAft>
+            </a:pPr>
+            <a:r>
+              <a:rPr sz="1600" b="1">
+                <a:solidFill>
+                  <a:srgbClr val="0B2545"/>
+                </a:solidFill>
+                <a:latin typeface="Calibri"/>
+              </a:rPr>
+              <a:t>This solution — on-prem</a:t>
+            </a:r>
+          </a:p>
+          <a:p>
+            <a:pPr algn="l">
+              <a:spcBef>
+                <a:spcPts val="0"/>
+              </a:spcBef>
+              <a:spcAft>
+                <a:spcPts val="1400"/>
+              </a:spcAft>
+            </a:pPr>
+            <a:r>
+              <a:rPr sz="2100" b="1">
+                <a:solidFill>
+                  <a:srgbClr val="2E8B57"/>
+                </a:solidFill>
+                <a:latin typeface="Calibri Light"/>
+              </a:rPr>
+              <a:t>$0 hosting</a:t>
+            </a:r>
+          </a:p>
+          <a:p>
+            <a:pPr algn="l">
+              <a:spcBef>
+                <a:spcPts val="0"/>
+              </a:spcBef>
+              <a:spcAft>
+                <a:spcPts val="300"/>
+              </a:spcAft>
+            </a:pPr>
+            <a:r>
+              <a:rPr sz="1300" b="0">
+                <a:solidFill>
+                  <a:srgbClr val="5A6B7B"/>
+                </a:solidFill>
+                <a:latin typeface="Calibri"/>
+              </a:rPr>
+              <a:t>Repurpose a server</a:t>
+            </a:r>
+          </a:p>
+          <a:p>
+            <a:pPr algn="l">
+              <a:spcBef>
+                <a:spcPts val="0"/>
+              </a:spcBef>
+              <a:spcAft>
                 <a:spcPts val="1000"/>
               </a:spcAft>
             </a:pPr>
             <a:r>
-              <a:rPr sz="1800" b="1">
-                <a:solidFill>
-                  <a:srgbClr val="0B2545"/>
-                </a:solidFill>
-                <a:latin typeface="Calibri"/>
-              </a:rPr>
-              <a:t>This solution</a:t>
+              <a:rPr sz="1300" b="0">
+                <a:solidFill>
+                  <a:srgbClr val="5A6B7B"/>
+                </a:solidFill>
+                <a:latin typeface="Calibri"/>
+              </a:rPr>
+              <a:t>we already own</a:t>
             </a:r>
           </a:p>
           <a:p>
@@ -5192,17 +5512,17 @@
                 <a:spcPts val="0"/>
               </a:spcBef>
               <a:spcAft>
-                <a:spcPts val="1000"/>
-              </a:spcAft>
-            </a:pPr>
-            <a:r>
-              <a:rPr sz="1600" b="1">
-                <a:solidFill>
-                  <a:srgbClr val="2E8B57"/>
-                </a:solidFill>
-                <a:latin typeface="Calibri"/>
-              </a:rPr>
-              <a:t>~$100 / month hosting</a:t>
+                <a:spcPts val="300"/>
+              </a:spcAft>
+            </a:pPr>
+            <a:r>
+              <a:rPr sz="1300" b="0">
+                <a:solidFill>
+                  <a:srgbClr val="5A6B7B"/>
+                </a:solidFill>
+                <a:latin typeface="Calibri"/>
+              </a:rPr>
+              <a:t>No new hardware or licensing</a:t>
             </a:r>
           </a:p>
           <a:p>
@@ -5211,50 +5531,31 @@
                 <a:spcPts val="0"/>
               </a:spcBef>
               <a:spcAft>
-                <a:spcPts val="1000"/>
-              </a:spcAft>
-            </a:pPr>
-            <a:r>
-              <a:rPr sz="1500" b="0">
+                <a:spcPts val="300"/>
+              </a:spcAft>
+            </a:pPr>
+            <a:r>
+              <a:rPr sz="1300" b="0">
                 <a:solidFill>
                   <a:srgbClr val="5A6B7B"/>
                 </a:solidFill>
                 <a:latin typeface="Calibri"/>
               </a:rPr>
-              <a:t>≈ $1,200 / year  +  existing IT staff time</a:t>
-            </a:r>
-          </a:p>
-          <a:p>
-            <a:pPr algn="l">
-              <a:spcBef>
-                <a:spcPts val="0"/>
-              </a:spcBef>
-              <a:spcAft>
-                <a:spcPts val="800"/>
-              </a:spcAft>
-            </a:pPr>
-            <a:r>
-              <a:rPr sz="1300" b="0">
-                <a:solidFill>
-                  <a:srgbClr val="5A6B7B"/>
-                </a:solidFill>
-                <a:latin typeface="Calibri"/>
-              </a:rPr>
-              <a:t>No per-seat fees. Scales to 500+ at the same low cost.</a:t>
-            </a:r>
-          </a:p>
-        </p:txBody>
-      </p:sp>
-      <p:sp>
-        <p:nvSpPr>
-          <p:cNvPr id="11" name="TextBox 10"/>
+              <a:t>— just our IT staff time.</a:t>
+            </a:r>
+          </a:p>
+        </p:txBody>
+      </p:sp>
+      <p:sp>
+        <p:nvSpPr>
+          <p:cNvPr id="14" name="TextBox 13"/>
           <p:cNvSpPr txBox="1"/>
           <p:nvPr/>
         </p:nvSpPr>
         <p:spPr>
           <a:xfrm>
-            <a:off x="822960" y="5440680"/>
-            <a:ext cx="10515600" cy="822960"/>
+            <a:off x="548640" y="5486400"/>
+            <a:ext cx="11064240" cy="822960"/>
           </a:xfrm>
           <a:prstGeom prst="rect">
             <a:avLst/>
@@ -5282,14 +5583,14 @@
                 </a:solidFill>
                 <a:latin typeface="Calibri"/>
               </a:rPr>
-              <a:t>Illustrative figures. The trade is software licensing cost for a modest amount of our own engineering time — and we keep full control of our data.</a:t>
-            </a:r>
-          </a:p>
-        </p:txBody>
-      </p:sp>
-      <p:sp>
-        <p:nvSpPr>
-          <p:cNvPr id="12" name="TextBox 11"/>
+              <a:t>Illustrative figures. We trade software licensing cost for a modest amount of our own IT time — and we keep full control of our data. Repurposing existing on-prem hardware removes even the hosting cost.</a:t>
+            </a:r>
+          </a:p>
+        </p:txBody>
+      </p:sp>
+      <p:sp>
+        <p:nvSpPr>
+          <p:cNvPr id="15" name="TextBox 14"/>
           <p:cNvSpPr txBox="1"/>
           <p:nvPr/>
         </p:nvSpPr>
@@ -5331,7 +5632,7 @@
       </p:sp>
       <p:sp>
         <p:nvSpPr>
-          <p:cNvPr id="13" name="TextBox 12"/>
+          <p:cNvPr id="16" name="TextBox 15"/>
           <p:cNvSpPr txBox="1"/>
           <p:nvPr/>
         </p:nvSpPr>

</xml_diff>

<commit_message>
Regenerate exec deck (3-option cost slide incl. $0 on-prem)
Co-Authored-By: Claude Opus 4.8 <noreply@anthropic.com>
</commit_message>
<xml_diff>
--- a/presentation/Northbridge_EndpointManagement_ExecBrief.pptx
+++ b/presentation/Northbridge_EndpointManagement_ExecBrief.pptx
@@ -4,23 +4,26 @@
   <p:sldMasterIdLst>
     <p:sldMasterId id="2147483648" r:id="rId1"/>
   </p:sldMasterIdLst>
+  <p:notesMasterIdLst>
+    <p:notesMasterId r:id="rId16"/>
+  </p:notesMasterIdLst>
   <p:sldIdLst>
-    <p:sldId id="256" r:id="rId7"/>
-    <p:sldId id="257" r:id="rId9"/>
-    <p:sldId id="258" r:id="rId10"/>
-    <p:sldId id="259" r:id="rId11"/>
-    <p:sldId id="260" r:id="rId12"/>
-    <p:sldId id="261" r:id="rId13"/>
-    <p:sldId id="262" r:id="rId14"/>
-    <p:sldId id="263" r:id="rId15"/>
-    <p:sldId id="264" r:id="rId16"/>
-    <p:sldId id="265" r:id="rId17"/>
-    <p:sldId id="266" r:id="rId18"/>
-    <p:sldId id="267" r:id="rId19"/>
-    <p:sldId id="268" r:id="rId20"/>
-    <p:sldId id="269" r:id="rId21"/>
+    <p:sldId id="256" r:id="rId2"/>
+    <p:sldId id="257" r:id="rId3"/>
+    <p:sldId id="258" r:id="rId4"/>
+    <p:sldId id="259" r:id="rId5"/>
+    <p:sldId id="260" r:id="rId6"/>
+    <p:sldId id="261" r:id="rId7"/>
+    <p:sldId id="262" r:id="rId8"/>
+    <p:sldId id="263" r:id="rId9"/>
+    <p:sldId id="264" r:id="rId10"/>
+    <p:sldId id="265" r:id="rId11"/>
+    <p:sldId id="266" r:id="rId12"/>
+    <p:sldId id="267" r:id="rId13"/>
+    <p:sldId id="268" r:id="rId14"/>
+    <p:sldId id="269" r:id="rId15"/>
   </p:sldIdLst>
-  <p:sldSz cx="12191695" cy="6858000" type="screen4x3"/>
+  <p:sldSz cx="12192000" cy="6858000"/>
   <p:notesSz cx="6858000" cy="9144000"/>
   <p:defaultTextStyle>
     <a:defPPr>
@@ -117,11 +120,27 @@
       </a:defRPr>
     </a:lvl9pPr>
   </p:defaultTextStyle>
+  <p:extLst>
+    <p:ext uri="{EFAFB233-063F-42B5-8137-9DF3F51BA10A}">
+      <p15:sldGuideLst xmlns:p15="http://schemas.microsoft.com/office/powerpoint/2012/main">
+        <p15:guide id="1" orient="horz" pos="2160">
+          <p15:clr>
+            <a:srgbClr val="A4A3A4"/>
+          </p15:clr>
+        </p15:guide>
+        <p15:guide id="2" pos="2880">
+          <p15:clr>
+            <a:srgbClr val="A4A3A4"/>
+          </p15:clr>
+        </p15:guide>
+      </p15:sldGuideLst>
+    </p:ext>
+  </p:extLst>
 </p:presentation>
 </file>
 
 <file path=ppt/notesMasters/notesMaster1.xml><?xml version="1.0" encoding="utf-8"?>
-<p:notesMaster xmlns:a="http://schemas.openxmlformats.org/drawingml/2006/main" xmlns:p="http://schemas.openxmlformats.org/presentationml/2006/main" xmlns:r="http://schemas.openxmlformats.org/officeDocument/2006/relationships">
+<p:notesMaster xmlns:a="http://schemas.openxmlformats.org/drawingml/2006/main" xmlns:r="http://schemas.openxmlformats.org/officeDocument/2006/relationships" xmlns:p="http://schemas.openxmlformats.org/presentationml/2006/main">
   <p:cSld>
     <p:bg>
       <p:bgRef idx="1001">
@@ -142,241 +161,16 @@
           <a:chExt cx="0" cy="0"/>
         </a:xfrm>
       </p:grpSpPr>
-      <p:sp>
-        <p:nvSpPr>
-          <p:cNvPr id="2" name="Header Placeholder 1"/>
-          <p:cNvSpPr>
-            <a:spLocks noGrp="1"/>
-          </p:cNvSpPr>
-          <p:nvPr>
-            <p:ph type="hdr" sz="quarter"/>
-          </p:nvPr>
-        </p:nvSpPr>
-        <p:spPr>
-          <a:xfrm>
-            <a:off x="0" y="0"/>
-            <a:ext cx="2971800" cy="457200"/>
-          </a:xfrm>
-          <a:prstGeom prst="rect">
-            <a:avLst/>
-          </a:prstGeom>
-        </p:spPr>
-        <p:txBody>
-          <a:bodyPr vert="horz" lIns="91440" tIns="45720" rIns="91440" bIns="45720" rtlCol="0"/>
-          <a:lstStyle>
-            <a:lvl1pPr algn="l">
-              <a:defRPr sz="1200"/>
-            </a:lvl1pPr>
-          </a:lstStyle>
-          <a:p>
-            <a:endParaRPr lang="en-US"/>
-          </a:p>
-        </p:txBody>
-      </p:sp>
-      <p:sp>
-        <p:nvSpPr>
-          <p:cNvPr id="3" name="Date Placeholder 2"/>
-          <p:cNvSpPr>
-            <a:spLocks noGrp="1"/>
-          </p:cNvSpPr>
-          <p:nvPr>
-            <p:ph type="dt" idx="1"/>
-          </p:nvPr>
-        </p:nvSpPr>
-        <p:spPr>
-          <a:xfrm>
-            <a:off x="3884613" y="0"/>
-            <a:ext cx="2971800" cy="457200"/>
-          </a:xfrm>
-          <a:prstGeom prst="rect">
-            <a:avLst/>
-          </a:prstGeom>
-        </p:spPr>
-        <p:txBody>
-          <a:bodyPr vert="horz" lIns="91440" tIns="45720" rIns="91440" bIns="45720" rtlCol="0"/>
-          <a:lstStyle>
-            <a:lvl1pPr algn="r">
-              <a:defRPr sz="1200"/>
-            </a:lvl1pPr>
-          </a:lstStyle>
-          <a:p>
-            <a:fld id="{0F89C1C7-3DCD-1040-A9CF-14679D8B5DDD}" type="datetimeFigureOut">
-              <a:rPr lang="en-US" smtClean="0"/>
-              <a:t>10/17/16</a:t>
-            </a:fld>
-            <a:endParaRPr lang="en-US"/>
-          </a:p>
-        </p:txBody>
-      </p:sp>
-      <p:sp>
-        <p:nvSpPr>
-          <p:cNvPr id="4" name="Slide Image Placeholder 3"/>
-          <p:cNvSpPr>
-            <a:spLocks noGrp="1" noRot="1" noChangeAspect="1"/>
-          </p:cNvSpPr>
-          <p:nvPr>
-            <p:ph type="sldImg" idx="2"/>
-          </p:nvPr>
-        </p:nvSpPr>
-        <p:spPr>
-          <a:xfrm>
-            <a:off x="1143000" y="685800"/>
-            <a:ext cx="4572000" cy="3429000"/>
-          </a:xfrm>
-          <a:prstGeom prst="rect">
-            <a:avLst/>
-          </a:prstGeom>
-          <a:noFill/>
-          <a:ln w="12700">
-            <a:solidFill>
-              <a:prstClr val="black"/>
-            </a:solidFill>
-          </a:ln>
-        </p:spPr>
-        <p:txBody>
-          <a:bodyPr vert="horz" lIns="91440" tIns="45720" rIns="91440" bIns="45720" rtlCol="0" anchor="ctr"/>
-          <a:lstStyle/>
-          <a:p>
-            <a:endParaRPr lang="en-US"/>
-          </a:p>
-        </p:txBody>
-      </p:sp>
-      <p:sp>
-        <p:nvSpPr>
-          <p:cNvPr id="5" name="Notes Placeholder 4"/>
-          <p:cNvSpPr>
-            <a:spLocks noGrp="1"/>
-          </p:cNvSpPr>
-          <p:nvPr>
-            <p:ph type="body" sz="quarter" idx="3"/>
-          </p:nvPr>
-        </p:nvSpPr>
-        <p:spPr>
-          <a:xfrm>
-            <a:off x="685800" y="4343400"/>
-            <a:ext cx="5486400" cy="4114800"/>
-          </a:xfrm>
-          <a:prstGeom prst="rect">
-            <a:avLst/>
-          </a:prstGeom>
-        </p:spPr>
-        <p:txBody>
-          <a:bodyPr vert="horz" lIns="91440" tIns="45720" rIns="91440" bIns="45720" rtlCol="0"/>
-          <a:lstStyle/>
-          <a:p>
-            <a:pPr lvl="0"/>
-            <a:r>
-              <a:rPr lang="en-US" smtClean="0"/>
-              <a:t>Click to edit Master text styles</a:t>
-            </a:r>
-          </a:p>
-          <a:p>
-            <a:pPr lvl="1"/>
-            <a:r>
-              <a:rPr lang="en-US" smtClean="0"/>
-              <a:t>Second level</a:t>
-            </a:r>
-          </a:p>
-          <a:p>
-            <a:pPr lvl="2"/>
-            <a:r>
-              <a:rPr lang="en-US" smtClean="0"/>
-              <a:t>Third level</a:t>
-            </a:r>
-          </a:p>
-          <a:p>
-            <a:pPr lvl="3"/>
-            <a:r>
-              <a:rPr lang="en-US" smtClean="0"/>
-              <a:t>Fourth level</a:t>
-            </a:r>
-          </a:p>
-          <a:p>
-            <a:pPr lvl="4"/>
-            <a:r>
-              <a:rPr lang="en-US" smtClean="0"/>
-              <a:t>Fifth level</a:t>
-            </a:r>
-            <a:endParaRPr lang="en-US"/>
-          </a:p>
-        </p:txBody>
-      </p:sp>
-      <p:sp>
-        <p:nvSpPr>
-          <p:cNvPr id="6" name="Footer Placeholder 5"/>
-          <p:cNvSpPr>
-            <a:spLocks noGrp="1"/>
-          </p:cNvSpPr>
-          <p:nvPr>
-            <p:ph type="ftr" sz="quarter" idx="4"/>
-          </p:nvPr>
-        </p:nvSpPr>
-        <p:spPr>
-          <a:xfrm>
-            <a:off x="0" y="8685213"/>
-            <a:ext cx="2971800" cy="457200"/>
-          </a:xfrm>
-          <a:prstGeom prst="rect">
-            <a:avLst/>
-          </a:prstGeom>
-        </p:spPr>
-        <p:txBody>
-          <a:bodyPr vert="horz" lIns="91440" tIns="45720" rIns="91440" bIns="45720" rtlCol="0" anchor="b"/>
-          <a:lstStyle>
-            <a:lvl1pPr algn="l">
-              <a:defRPr sz="1200"/>
-            </a:lvl1pPr>
-          </a:lstStyle>
-          <a:p>
-            <a:endParaRPr lang="en-US"/>
-          </a:p>
-        </p:txBody>
-      </p:sp>
-      <p:sp>
-        <p:nvSpPr>
-          <p:cNvPr id="7" name="Slide Number Placeholder 6"/>
-          <p:cNvSpPr>
-            <a:spLocks noGrp="1"/>
-          </p:cNvSpPr>
-          <p:nvPr>
-            <p:ph type="sldNum" sz="quarter" idx="5"/>
-          </p:nvPr>
-        </p:nvSpPr>
-        <p:spPr>
-          <a:xfrm>
-            <a:off x="3884613" y="8685213"/>
-            <a:ext cx="2971800" cy="457200"/>
-          </a:xfrm>
-          <a:prstGeom prst="rect">
-            <a:avLst/>
-          </a:prstGeom>
-        </p:spPr>
-        <p:txBody>
-          <a:bodyPr vert="horz" lIns="91440" tIns="45720" rIns="91440" bIns="45720" rtlCol="0" anchor="b"/>
-          <a:lstStyle>
-            <a:lvl1pPr algn="r">
-              <a:defRPr sz="1200"/>
-            </a:lvl1pPr>
-          </a:lstStyle>
-          <a:p>
-            <a:fld id="{BB5E49A5-4136-284D-997B-48E1D791AD67}" type="slidenum">
-              <a:rPr lang="en-US" smtClean="0"/>
-              <a:t>‹#›</a:t>
-            </a:fld>
-            <a:endParaRPr lang="en-US"/>
-          </a:p>
-        </p:txBody>
-      </p:sp>
     </p:spTree>
     <p:extLst>
       <p:ext uri="{BB962C8B-B14F-4D97-AF65-F5344CB8AC3E}">
-        <p14:creationId xmlns:p14="http://schemas.microsoft.com/office/powerpoint/2010/main" val="2623252185"/>
+        <p14:creationId xmlns:p14="http://schemas.microsoft.com/office/powerpoint/2010/main" val="3412434972"/>
       </p:ext>
     </p:extLst>
   </p:cSld>
   <p:clrMap bg1="lt1" tx1="dk1" bg2="lt2" tx2="dk2" accent1="accent1" accent2="accent2" accent3="accent3" accent4="accent4" accent5="accent5" accent6="accent6" hlink="hlink" folHlink="folHlink"/>
   <p:notesStyle>
-    <a:lvl1pPr marL="0" algn="l" defTabSz="457200" rtl="0" eaLnBrk="1" latinLnBrk="0" hangingPunct="1">
+    <a:lvl1pPr marL="0" algn="l" defTabSz="914400" rtl="0" eaLnBrk="1" latinLnBrk="0" hangingPunct="1">
       <a:defRPr sz="1200" kern="1200">
         <a:solidFill>
           <a:schemeClr val="tx1"/>
@@ -386,7 +180,7 @@
         <a:cs typeface="+mn-cs"/>
       </a:defRPr>
     </a:lvl1pPr>
-    <a:lvl2pPr marL="457200" algn="l" defTabSz="457200" rtl="0" eaLnBrk="1" latinLnBrk="0" hangingPunct="1">
+    <a:lvl2pPr marL="457200" algn="l" defTabSz="914400" rtl="0" eaLnBrk="1" latinLnBrk="0" hangingPunct="1">
       <a:defRPr sz="1200" kern="1200">
         <a:solidFill>
           <a:schemeClr val="tx1"/>
@@ -396,7 +190,7 @@
         <a:cs typeface="+mn-cs"/>
       </a:defRPr>
     </a:lvl2pPr>
-    <a:lvl3pPr marL="914400" algn="l" defTabSz="457200" rtl="0" eaLnBrk="1" latinLnBrk="0" hangingPunct="1">
+    <a:lvl3pPr marL="914400" algn="l" defTabSz="914400" rtl="0" eaLnBrk="1" latinLnBrk="0" hangingPunct="1">
       <a:defRPr sz="1200" kern="1200">
         <a:solidFill>
           <a:schemeClr val="tx1"/>
@@ -406,7 +200,7 @@
         <a:cs typeface="+mn-cs"/>
       </a:defRPr>
     </a:lvl3pPr>
-    <a:lvl4pPr marL="1371600" algn="l" defTabSz="457200" rtl="0" eaLnBrk="1" latinLnBrk="0" hangingPunct="1">
+    <a:lvl4pPr marL="1371600" algn="l" defTabSz="914400" rtl="0" eaLnBrk="1" latinLnBrk="0" hangingPunct="1">
       <a:defRPr sz="1200" kern="1200">
         <a:solidFill>
           <a:schemeClr val="tx1"/>
@@ -416,7 +210,7 @@
         <a:cs typeface="+mn-cs"/>
       </a:defRPr>
     </a:lvl4pPr>
-    <a:lvl5pPr marL="1828800" algn="l" defTabSz="457200" rtl="0" eaLnBrk="1" latinLnBrk="0" hangingPunct="1">
+    <a:lvl5pPr marL="1828800" algn="l" defTabSz="914400" rtl="0" eaLnBrk="1" latinLnBrk="0" hangingPunct="1">
       <a:defRPr sz="1200" kern="1200">
         <a:solidFill>
           <a:schemeClr val="tx1"/>
@@ -426,7 +220,7 @@
         <a:cs typeface="+mn-cs"/>
       </a:defRPr>
     </a:lvl5pPr>
-    <a:lvl6pPr marL="2286000" algn="l" defTabSz="457200" rtl="0" eaLnBrk="1" latinLnBrk="0" hangingPunct="1">
+    <a:lvl6pPr marL="2286000" algn="l" defTabSz="914400" rtl="0" eaLnBrk="1" latinLnBrk="0" hangingPunct="1">
       <a:defRPr sz="1200" kern="1200">
         <a:solidFill>
           <a:schemeClr val="tx1"/>
@@ -436,7 +230,7 @@
         <a:cs typeface="+mn-cs"/>
       </a:defRPr>
     </a:lvl6pPr>
-    <a:lvl7pPr marL="2743200" algn="l" defTabSz="457200" rtl="0" eaLnBrk="1" latinLnBrk="0" hangingPunct="1">
+    <a:lvl7pPr marL="2743200" algn="l" defTabSz="914400" rtl="0" eaLnBrk="1" latinLnBrk="0" hangingPunct="1">
       <a:defRPr sz="1200" kern="1200">
         <a:solidFill>
           <a:schemeClr val="tx1"/>
@@ -446,7 +240,7 @@
         <a:cs typeface="+mn-cs"/>
       </a:defRPr>
     </a:lvl7pPr>
-    <a:lvl8pPr marL="3200400" algn="l" defTabSz="457200" rtl="0" eaLnBrk="1" latinLnBrk="0" hangingPunct="1">
+    <a:lvl8pPr marL="3200400" algn="l" defTabSz="914400" rtl="0" eaLnBrk="1" latinLnBrk="0" hangingPunct="1">
       <a:defRPr sz="1200" kern="1200">
         <a:solidFill>
           <a:schemeClr val="tx1"/>
@@ -456,7 +250,7 @@
         <a:cs typeface="+mn-cs"/>
       </a:defRPr>
     </a:lvl8pPr>
-    <a:lvl9pPr marL="3657600" algn="l" defTabSz="457200" rtl="0" eaLnBrk="1" latinLnBrk="0" hangingPunct="1">
+    <a:lvl9pPr marL="3657600" algn="l" defTabSz="914400" rtl="0" eaLnBrk="1" latinLnBrk="0" hangingPunct="1">
       <a:defRPr sz="1200" kern="1200">
         <a:solidFill>
           <a:schemeClr val="tx1"/>
@@ -471,7 +265,7 @@
 </file>
 
 <file path=ppt/notesSlides/notesSlide1.xml><?xml version="1.0" encoding="utf-8"?>
-<p:notes xmlns:a="http://schemas.openxmlformats.org/drawingml/2006/main" xmlns:p="http://schemas.openxmlformats.org/presentationml/2006/main" xmlns:r="http://schemas.openxmlformats.org/officeDocument/2006/relationships">
+<p:notes xmlns:a="http://schemas.openxmlformats.org/drawingml/2006/main" xmlns:r="http://schemas.openxmlformats.org/officeDocument/2006/relationships" xmlns:p="http://schemas.openxmlformats.org/presentationml/2006/main">
   <p:cSld>
     <p:spTree>
       <p:nvGrpSpPr>
@@ -491,7 +285,7 @@
         <p:nvSpPr>
           <p:cNvPr id="2" name="Slide Image Placeholder 1"/>
           <p:cNvSpPr>
-            <a:spLocks noGrp="1"/>
+            <a:spLocks noGrp="1" noRot="1" noChangeAspect="1"/>
           </p:cNvSpPr>
           <p:nvPr>
             <p:ph type="sldImg" idx="2"/>
@@ -506,7 +300,7 @@
             <a:spLocks noGrp="1"/>
           </p:cNvSpPr>
           <p:nvPr>
-            <p:ph type="body" idx="3" sz="quarter"/>
+            <p:ph type="body" sz="quarter" idx="3"/>
           </p:nvPr>
         </p:nvSpPr>
         <p:spPr/>
@@ -527,7 +321,7 @@
             <a:spLocks noGrp="1"/>
           </p:cNvSpPr>
           <p:nvPr>
-            <p:ph type="sldNum" idx="5" sz="quarter"/>
+            <p:ph type="sldNum" sz="quarter" idx="5"/>
           </p:nvPr>
         </p:nvSpPr>
         <p:spPr/>
@@ -541,7 +335,7 @@
 </file>
 
 <file path=ppt/notesSlides/notesSlide10.xml><?xml version="1.0" encoding="utf-8"?>
-<p:notes xmlns:a="http://schemas.openxmlformats.org/drawingml/2006/main" xmlns:p="http://schemas.openxmlformats.org/presentationml/2006/main" xmlns:r="http://schemas.openxmlformats.org/officeDocument/2006/relationships">
+<p:notes xmlns:a="http://schemas.openxmlformats.org/drawingml/2006/main" xmlns:r="http://schemas.openxmlformats.org/officeDocument/2006/relationships" xmlns:p="http://schemas.openxmlformats.org/presentationml/2006/main">
   <p:cSld>
     <p:spTree>
       <p:nvGrpSpPr>
@@ -561,7 +355,7 @@
         <p:nvSpPr>
           <p:cNvPr id="2" name="Slide Image Placeholder 1"/>
           <p:cNvSpPr>
-            <a:spLocks noGrp="1"/>
+            <a:spLocks noGrp="1" noRot="1" noChangeAspect="1"/>
           </p:cNvSpPr>
           <p:nvPr>
             <p:ph type="sldImg" idx="2"/>
@@ -576,7 +370,7 @@
             <a:spLocks noGrp="1"/>
           </p:cNvSpPr>
           <p:nvPr>
-            <p:ph type="body" idx="3" sz="quarter"/>
+            <p:ph type="body" sz="quarter" idx="3"/>
           </p:nvPr>
         </p:nvSpPr>
         <p:spPr/>
@@ -597,7 +391,7 @@
             <a:spLocks noGrp="1"/>
           </p:cNvSpPr>
           <p:nvPr>
-            <p:ph type="sldNum" idx="5" sz="quarter"/>
+            <p:ph type="sldNum" sz="quarter" idx="5"/>
           </p:nvPr>
         </p:nvSpPr>
         <p:spPr/>
@@ -611,7 +405,7 @@
 </file>
 
 <file path=ppt/notesSlides/notesSlide11.xml><?xml version="1.0" encoding="utf-8"?>
-<p:notes xmlns:a="http://schemas.openxmlformats.org/drawingml/2006/main" xmlns:p="http://schemas.openxmlformats.org/presentationml/2006/main" xmlns:r="http://schemas.openxmlformats.org/officeDocument/2006/relationships">
+<p:notes xmlns:a="http://schemas.openxmlformats.org/drawingml/2006/main" xmlns:r="http://schemas.openxmlformats.org/officeDocument/2006/relationships" xmlns:p="http://schemas.openxmlformats.org/presentationml/2006/main">
   <p:cSld>
     <p:spTree>
       <p:nvGrpSpPr>
@@ -631,7 +425,7 @@
         <p:nvSpPr>
           <p:cNvPr id="2" name="Slide Image Placeholder 1"/>
           <p:cNvSpPr>
-            <a:spLocks noGrp="1"/>
+            <a:spLocks noGrp="1" noRot="1" noChangeAspect="1"/>
           </p:cNvSpPr>
           <p:nvPr>
             <p:ph type="sldImg" idx="2"/>
@@ -646,7 +440,7 @@
             <a:spLocks noGrp="1"/>
           </p:cNvSpPr>
           <p:nvPr>
-            <p:ph type="body" idx="3" sz="quarter"/>
+            <p:ph type="body" sz="quarter" idx="3"/>
           </p:nvPr>
         </p:nvSpPr>
         <p:spPr/>
@@ -667,7 +461,7 @@
             <a:spLocks noGrp="1"/>
           </p:cNvSpPr>
           <p:nvPr>
-            <p:ph type="sldNum" idx="5" sz="quarter"/>
+            <p:ph type="sldNum" sz="quarter" idx="5"/>
           </p:nvPr>
         </p:nvSpPr>
         <p:spPr/>
@@ -681,7 +475,7 @@
 </file>
 
 <file path=ppt/notesSlides/notesSlide12.xml><?xml version="1.0" encoding="utf-8"?>
-<p:notes xmlns:a="http://schemas.openxmlformats.org/drawingml/2006/main" xmlns:p="http://schemas.openxmlformats.org/presentationml/2006/main" xmlns:r="http://schemas.openxmlformats.org/officeDocument/2006/relationships">
+<p:notes xmlns:a="http://schemas.openxmlformats.org/drawingml/2006/main" xmlns:r="http://schemas.openxmlformats.org/officeDocument/2006/relationships" xmlns:p="http://schemas.openxmlformats.org/presentationml/2006/main">
   <p:cSld>
     <p:spTree>
       <p:nvGrpSpPr>
@@ -701,7 +495,7 @@
         <p:nvSpPr>
           <p:cNvPr id="2" name="Slide Image Placeholder 1"/>
           <p:cNvSpPr>
-            <a:spLocks noGrp="1"/>
+            <a:spLocks noGrp="1" noRot="1" noChangeAspect="1"/>
           </p:cNvSpPr>
           <p:nvPr>
             <p:ph type="sldImg" idx="2"/>
@@ -716,7 +510,7 @@
             <a:spLocks noGrp="1"/>
           </p:cNvSpPr>
           <p:nvPr>
-            <p:ph type="body" idx="3" sz="quarter"/>
+            <p:ph type="body" sz="quarter" idx="3"/>
           </p:nvPr>
         </p:nvSpPr>
         <p:spPr/>
@@ -737,7 +531,7 @@
             <a:spLocks noGrp="1"/>
           </p:cNvSpPr>
           <p:nvPr>
-            <p:ph type="sldNum" idx="5" sz="quarter"/>
+            <p:ph type="sldNum" sz="quarter" idx="5"/>
           </p:nvPr>
         </p:nvSpPr>
         <p:spPr/>
@@ -751,7 +545,7 @@
 </file>
 
 <file path=ppt/notesSlides/notesSlide13.xml><?xml version="1.0" encoding="utf-8"?>
-<p:notes xmlns:a="http://schemas.openxmlformats.org/drawingml/2006/main" xmlns:p="http://schemas.openxmlformats.org/presentationml/2006/main" xmlns:r="http://schemas.openxmlformats.org/officeDocument/2006/relationships">
+<p:notes xmlns:a="http://schemas.openxmlformats.org/drawingml/2006/main" xmlns:r="http://schemas.openxmlformats.org/officeDocument/2006/relationships" xmlns:p="http://schemas.openxmlformats.org/presentationml/2006/main">
   <p:cSld>
     <p:spTree>
       <p:nvGrpSpPr>
@@ -771,7 +565,7 @@
         <p:nvSpPr>
           <p:cNvPr id="2" name="Slide Image Placeholder 1"/>
           <p:cNvSpPr>
-            <a:spLocks noGrp="1"/>
+            <a:spLocks noGrp="1" noRot="1" noChangeAspect="1"/>
           </p:cNvSpPr>
           <p:nvPr>
             <p:ph type="sldImg" idx="2"/>
@@ -786,7 +580,7 @@
             <a:spLocks noGrp="1"/>
           </p:cNvSpPr>
           <p:nvPr>
-            <p:ph type="body" idx="3" sz="quarter"/>
+            <p:ph type="body" sz="quarter" idx="3"/>
           </p:nvPr>
         </p:nvSpPr>
         <p:spPr/>
@@ -807,7 +601,7 @@
             <a:spLocks noGrp="1"/>
           </p:cNvSpPr>
           <p:nvPr>
-            <p:ph type="sldNum" idx="5" sz="quarter"/>
+            <p:ph type="sldNum" sz="quarter" idx="5"/>
           </p:nvPr>
         </p:nvSpPr>
         <p:spPr/>
@@ -821,7 +615,7 @@
 </file>
 
 <file path=ppt/notesSlides/notesSlide14.xml><?xml version="1.0" encoding="utf-8"?>
-<p:notes xmlns:a="http://schemas.openxmlformats.org/drawingml/2006/main" xmlns:p="http://schemas.openxmlformats.org/presentationml/2006/main" xmlns:r="http://schemas.openxmlformats.org/officeDocument/2006/relationships">
+<p:notes xmlns:a="http://schemas.openxmlformats.org/drawingml/2006/main" xmlns:r="http://schemas.openxmlformats.org/officeDocument/2006/relationships" xmlns:p="http://schemas.openxmlformats.org/presentationml/2006/main">
   <p:cSld>
     <p:spTree>
       <p:nvGrpSpPr>
@@ -841,7 +635,7 @@
         <p:nvSpPr>
           <p:cNvPr id="2" name="Slide Image Placeholder 1"/>
           <p:cNvSpPr>
-            <a:spLocks noGrp="1"/>
+            <a:spLocks noGrp="1" noRot="1" noChangeAspect="1"/>
           </p:cNvSpPr>
           <p:nvPr>
             <p:ph type="sldImg" idx="2"/>
@@ -856,7 +650,7 @@
             <a:spLocks noGrp="1"/>
           </p:cNvSpPr>
           <p:nvPr>
-            <p:ph type="body" idx="3" sz="quarter"/>
+            <p:ph type="body" sz="quarter" idx="3"/>
           </p:nvPr>
         </p:nvSpPr>
         <p:spPr/>
@@ -877,7 +671,7 @@
             <a:spLocks noGrp="1"/>
           </p:cNvSpPr>
           <p:nvPr>
-            <p:ph type="sldNum" idx="5" sz="quarter"/>
+            <p:ph type="sldNum" sz="quarter" idx="5"/>
           </p:nvPr>
         </p:nvSpPr>
         <p:spPr/>
@@ -891,7 +685,7 @@
 </file>
 
 <file path=ppt/notesSlides/notesSlide2.xml><?xml version="1.0" encoding="utf-8"?>
-<p:notes xmlns:a="http://schemas.openxmlformats.org/drawingml/2006/main" xmlns:p="http://schemas.openxmlformats.org/presentationml/2006/main" xmlns:r="http://schemas.openxmlformats.org/officeDocument/2006/relationships">
+<p:notes xmlns:a="http://schemas.openxmlformats.org/drawingml/2006/main" xmlns:r="http://schemas.openxmlformats.org/officeDocument/2006/relationships" xmlns:p="http://schemas.openxmlformats.org/presentationml/2006/main">
   <p:cSld>
     <p:spTree>
       <p:nvGrpSpPr>
@@ -911,7 +705,7 @@
         <p:nvSpPr>
           <p:cNvPr id="2" name="Slide Image Placeholder 1"/>
           <p:cNvSpPr>
-            <a:spLocks noGrp="1"/>
+            <a:spLocks noGrp="1" noRot="1" noChangeAspect="1"/>
           </p:cNvSpPr>
           <p:nvPr>
             <p:ph type="sldImg" idx="2"/>
@@ -926,7 +720,7 @@
             <a:spLocks noGrp="1"/>
           </p:cNvSpPr>
           <p:nvPr>
-            <p:ph type="body" idx="3" sz="quarter"/>
+            <p:ph type="body" sz="quarter" idx="3"/>
           </p:nvPr>
         </p:nvSpPr>
         <p:spPr/>
@@ -947,7 +741,7 @@
             <a:spLocks noGrp="1"/>
           </p:cNvSpPr>
           <p:nvPr>
-            <p:ph type="sldNum" idx="5" sz="quarter"/>
+            <p:ph type="sldNum" sz="quarter" idx="5"/>
           </p:nvPr>
         </p:nvSpPr>
         <p:spPr/>
@@ -961,7 +755,7 @@
 </file>
 
 <file path=ppt/notesSlides/notesSlide3.xml><?xml version="1.0" encoding="utf-8"?>
-<p:notes xmlns:a="http://schemas.openxmlformats.org/drawingml/2006/main" xmlns:p="http://schemas.openxmlformats.org/presentationml/2006/main" xmlns:r="http://schemas.openxmlformats.org/officeDocument/2006/relationships">
+<p:notes xmlns:a="http://schemas.openxmlformats.org/drawingml/2006/main" xmlns:r="http://schemas.openxmlformats.org/officeDocument/2006/relationships" xmlns:p="http://schemas.openxmlformats.org/presentationml/2006/main">
   <p:cSld>
     <p:spTree>
       <p:nvGrpSpPr>
@@ -981,7 +775,7 @@
         <p:nvSpPr>
           <p:cNvPr id="2" name="Slide Image Placeholder 1"/>
           <p:cNvSpPr>
-            <a:spLocks noGrp="1"/>
+            <a:spLocks noGrp="1" noRot="1" noChangeAspect="1"/>
           </p:cNvSpPr>
           <p:nvPr>
             <p:ph type="sldImg" idx="2"/>
@@ -996,7 +790,7 @@
             <a:spLocks noGrp="1"/>
           </p:cNvSpPr>
           <p:nvPr>
-            <p:ph type="body" idx="3" sz="quarter"/>
+            <p:ph type="body" sz="quarter" idx="3"/>
           </p:nvPr>
         </p:nvSpPr>
         <p:spPr/>
@@ -1017,7 +811,7 @@
             <a:spLocks noGrp="1"/>
           </p:cNvSpPr>
           <p:nvPr>
-            <p:ph type="sldNum" idx="5" sz="quarter"/>
+            <p:ph type="sldNum" sz="quarter" idx="5"/>
           </p:nvPr>
         </p:nvSpPr>
         <p:spPr/>
@@ -1031,7 +825,7 @@
 </file>
 
 <file path=ppt/notesSlides/notesSlide4.xml><?xml version="1.0" encoding="utf-8"?>
-<p:notes xmlns:a="http://schemas.openxmlformats.org/drawingml/2006/main" xmlns:p="http://schemas.openxmlformats.org/presentationml/2006/main" xmlns:r="http://schemas.openxmlformats.org/officeDocument/2006/relationships">
+<p:notes xmlns:a="http://schemas.openxmlformats.org/drawingml/2006/main" xmlns:r="http://schemas.openxmlformats.org/officeDocument/2006/relationships" xmlns:p="http://schemas.openxmlformats.org/presentationml/2006/main">
   <p:cSld>
     <p:spTree>
       <p:nvGrpSpPr>
@@ -1051,7 +845,7 @@
         <p:nvSpPr>
           <p:cNvPr id="2" name="Slide Image Placeholder 1"/>
           <p:cNvSpPr>
-            <a:spLocks noGrp="1"/>
+            <a:spLocks noGrp="1" noRot="1" noChangeAspect="1"/>
           </p:cNvSpPr>
           <p:nvPr>
             <p:ph type="sldImg" idx="2"/>
@@ -1066,7 +860,7 @@
             <a:spLocks noGrp="1"/>
           </p:cNvSpPr>
           <p:nvPr>
-            <p:ph type="body" idx="3" sz="quarter"/>
+            <p:ph type="body" sz="quarter" idx="3"/>
           </p:nvPr>
         </p:nvSpPr>
         <p:spPr/>
@@ -1087,7 +881,7 @@
             <a:spLocks noGrp="1"/>
           </p:cNvSpPr>
           <p:nvPr>
-            <p:ph type="sldNum" idx="5" sz="quarter"/>
+            <p:ph type="sldNum" sz="quarter" idx="5"/>
           </p:nvPr>
         </p:nvSpPr>
         <p:spPr/>
@@ -1101,7 +895,7 @@
 </file>
 
 <file path=ppt/notesSlides/notesSlide5.xml><?xml version="1.0" encoding="utf-8"?>
-<p:notes xmlns:a="http://schemas.openxmlformats.org/drawingml/2006/main" xmlns:p="http://schemas.openxmlformats.org/presentationml/2006/main" xmlns:r="http://schemas.openxmlformats.org/officeDocument/2006/relationships">
+<p:notes xmlns:a="http://schemas.openxmlformats.org/drawingml/2006/main" xmlns:r="http://schemas.openxmlformats.org/officeDocument/2006/relationships" xmlns:p="http://schemas.openxmlformats.org/presentationml/2006/main">
   <p:cSld>
     <p:spTree>
       <p:nvGrpSpPr>
@@ -1121,7 +915,7 @@
         <p:nvSpPr>
           <p:cNvPr id="2" name="Slide Image Placeholder 1"/>
           <p:cNvSpPr>
-            <a:spLocks noGrp="1"/>
+            <a:spLocks noGrp="1" noRot="1" noChangeAspect="1"/>
           </p:cNvSpPr>
           <p:nvPr>
             <p:ph type="sldImg" idx="2"/>
@@ -1136,7 +930,7 @@
             <a:spLocks noGrp="1"/>
           </p:cNvSpPr>
           <p:nvPr>
-            <p:ph type="body" idx="3" sz="quarter"/>
+            <p:ph type="body" sz="quarter" idx="3"/>
           </p:nvPr>
         </p:nvSpPr>
         <p:spPr/>
@@ -1157,7 +951,7 @@
             <a:spLocks noGrp="1"/>
           </p:cNvSpPr>
           <p:nvPr>
-            <p:ph type="sldNum" idx="5" sz="quarter"/>
+            <p:ph type="sldNum" sz="quarter" idx="5"/>
           </p:nvPr>
         </p:nvSpPr>
         <p:spPr/>
@@ -1171,7 +965,7 @@
 </file>
 
 <file path=ppt/notesSlides/notesSlide6.xml><?xml version="1.0" encoding="utf-8"?>
-<p:notes xmlns:a="http://schemas.openxmlformats.org/drawingml/2006/main" xmlns:p="http://schemas.openxmlformats.org/presentationml/2006/main" xmlns:r="http://schemas.openxmlformats.org/officeDocument/2006/relationships">
+<p:notes xmlns:a="http://schemas.openxmlformats.org/drawingml/2006/main" xmlns:r="http://schemas.openxmlformats.org/officeDocument/2006/relationships" xmlns:p="http://schemas.openxmlformats.org/presentationml/2006/main">
   <p:cSld>
     <p:spTree>
       <p:nvGrpSpPr>
@@ -1191,7 +985,7 @@
         <p:nvSpPr>
           <p:cNvPr id="2" name="Slide Image Placeholder 1"/>
           <p:cNvSpPr>
-            <a:spLocks noGrp="1"/>
+            <a:spLocks noGrp="1" noRot="1" noChangeAspect="1"/>
           </p:cNvSpPr>
           <p:nvPr>
             <p:ph type="sldImg" idx="2"/>
@@ -1206,7 +1000,7 @@
             <a:spLocks noGrp="1"/>
           </p:cNvSpPr>
           <p:nvPr>
-            <p:ph type="body" idx="3" sz="quarter"/>
+            <p:ph type="body" sz="quarter" idx="3"/>
           </p:nvPr>
         </p:nvSpPr>
         <p:spPr/>
@@ -1227,7 +1021,7 @@
             <a:spLocks noGrp="1"/>
           </p:cNvSpPr>
           <p:nvPr>
-            <p:ph type="sldNum" idx="5" sz="quarter"/>
+            <p:ph type="sldNum" sz="quarter" idx="5"/>
           </p:nvPr>
         </p:nvSpPr>
         <p:spPr/>
@@ -1241,7 +1035,7 @@
 </file>
 
 <file path=ppt/notesSlides/notesSlide7.xml><?xml version="1.0" encoding="utf-8"?>
-<p:notes xmlns:a="http://schemas.openxmlformats.org/drawingml/2006/main" xmlns:p="http://schemas.openxmlformats.org/presentationml/2006/main" xmlns:r="http://schemas.openxmlformats.org/officeDocument/2006/relationships">
+<p:notes xmlns:a="http://schemas.openxmlformats.org/drawingml/2006/main" xmlns:r="http://schemas.openxmlformats.org/officeDocument/2006/relationships" xmlns:p="http://schemas.openxmlformats.org/presentationml/2006/main">
   <p:cSld>
     <p:spTree>
       <p:nvGrpSpPr>
@@ -1261,7 +1055,7 @@
         <p:nvSpPr>
           <p:cNvPr id="2" name="Slide Image Placeholder 1"/>
           <p:cNvSpPr>
-            <a:spLocks noGrp="1"/>
+            <a:spLocks noGrp="1" noRot="1" noChangeAspect="1"/>
           </p:cNvSpPr>
           <p:nvPr>
             <p:ph type="sldImg" idx="2"/>
@@ -1276,7 +1070,7 @@
             <a:spLocks noGrp="1"/>
           </p:cNvSpPr>
           <p:nvPr>
-            <p:ph type="body" idx="3" sz="quarter"/>
+            <p:ph type="body" sz="quarter" idx="3"/>
           </p:nvPr>
         </p:nvSpPr>
         <p:spPr/>
@@ -1297,7 +1091,7 @@
             <a:spLocks noGrp="1"/>
           </p:cNvSpPr>
           <p:nvPr>
-            <p:ph type="sldNum" idx="5" sz="quarter"/>
+            <p:ph type="sldNum" sz="quarter" idx="5"/>
           </p:nvPr>
         </p:nvSpPr>
         <p:spPr/>
@@ -1311,7 +1105,7 @@
 </file>
 
 <file path=ppt/notesSlides/notesSlide8.xml><?xml version="1.0" encoding="utf-8"?>
-<p:notes xmlns:a="http://schemas.openxmlformats.org/drawingml/2006/main" xmlns:p="http://schemas.openxmlformats.org/presentationml/2006/main" xmlns:r="http://schemas.openxmlformats.org/officeDocument/2006/relationships">
+<p:notes xmlns:a="http://schemas.openxmlformats.org/drawingml/2006/main" xmlns:r="http://schemas.openxmlformats.org/officeDocument/2006/relationships" xmlns:p="http://schemas.openxmlformats.org/presentationml/2006/main">
   <p:cSld>
     <p:spTree>
       <p:nvGrpSpPr>
@@ -1331,7 +1125,7 @@
         <p:nvSpPr>
           <p:cNvPr id="2" name="Slide Image Placeholder 1"/>
           <p:cNvSpPr>
-            <a:spLocks noGrp="1"/>
+            <a:spLocks noGrp="1" noRot="1" noChangeAspect="1"/>
           </p:cNvSpPr>
           <p:nvPr>
             <p:ph type="sldImg" idx="2"/>
@@ -1346,7 +1140,7 @@
             <a:spLocks noGrp="1"/>
           </p:cNvSpPr>
           <p:nvPr>
-            <p:ph type="body" idx="3" sz="quarter"/>
+            <p:ph type="body" sz="quarter" idx="3"/>
           </p:nvPr>
         </p:nvSpPr>
         <p:spPr/>
@@ -1367,7 +1161,7 @@
             <a:spLocks noGrp="1"/>
           </p:cNvSpPr>
           <p:nvPr>
-            <p:ph type="sldNum" idx="5" sz="quarter"/>
+            <p:ph type="sldNum" sz="quarter" idx="5"/>
           </p:nvPr>
         </p:nvSpPr>
         <p:spPr/>
@@ -1381,7 +1175,7 @@
 </file>
 
 <file path=ppt/notesSlides/notesSlide9.xml><?xml version="1.0" encoding="utf-8"?>
-<p:notes xmlns:a="http://schemas.openxmlformats.org/drawingml/2006/main" xmlns:p="http://schemas.openxmlformats.org/presentationml/2006/main" xmlns:r="http://schemas.openxmlformats.org/officeDocument/2006/relationships">
+<p:notes xmlns:a="http://schemas.openxmlformats.org/drawingml/2006/main" xmlns:r="http://schemas.openxmlformats.org/officeDocument/2006/relationships" xmlns:p="http://schemas.openxmlformats.org/presentationml/2006/main">
   <p:cSld>
     <p:spTree>
       <p:nvGrpSpPr>
@@ -1401,7 +1195,7 @@
         <p:nvSpPr>
           <p:cNvPr id="2" name="Slide Image Placeholder 1"/>
           <p:cNvSpPr>
-            <a:spLocks noGrp="1"/>
+            <a:spLocks noGrp="1" noRot="1" noChangeAspect="1"/>
           </p:cNvSpPr>
           <p:nvPr>
             <p:ph type="sldImg" idx="2"/>
@@ -1416,7 +1210,7 @@
             <a:spLocks noGrp="1"/>
           </p:cNvSpPr>
           <p:nvPr>
-            <p:ph type="body" idx="3" sz="quarter"/>
+            <p:ph type="body" sz="quarter" idx="3"/>
           </p:nvPr>
         </p:nvSpPr>
         <p:spPr/>
@@ -1437,7 +1231,7 @@
             <a:spLocks noGrp="1"/>
           </p:cNvSpPr>
           <p:nvPr>
-            <p:ph type="sldNum" idx="5" sz="quarter"/>
+            <p:ph type="sldNum" sz="quarter" idx="5"/>
           </p:nvPr>
         </p:nvSpPr>
         <p:spPr/>
@@ -1488,10 +1282,9 @@
           <a:lstStyle/>
           <a:p>
             <a:r>
-              <a:rPr lang="en-US" smtClean="0"/>
+              <a:rPr lang="en-US"/>
               <a:t>Click to edit Master title style</a:t>
             </a:r>
-            <a:endParaRPr lang="en-US"/>
           </a:p>
         </p:txBody>
       </p:sp>
@@ -1607,10 +1400,9 @@
           </a:lstStyle>
           <a:p>
             <a:r>
-              <a:rPr lang="en-US" smtClean="0"/>
+              <a:rPr lang="en-US"/>
               <a:t>Click to edit Master subtitle style</a:t>
             </a:r>
-            <a:endParaRPr lang="en-US"/>
           </a:p>
         </p:txBody>
       </p:sp>
@@ -1631,7 +1423,7 @@
           <a:p>
             <a:fld id="{5BCAD085-E8A6-8845-BD4E-CB4CCA059FC4}" type="datetimeFigureOut">
               <a:rPr lang="en-US" smtClean="0"/>
-              <a:t>1/27/13</a:t>
+              <a:t>6/21/26</a:t>
             </a:fld>
             <a:endParaRPr lang="en-US"/>
           </a:p>
@@ -1725,10 +1517,9 @@
           <a:lstStyle/>
           <a:p>
             <a:r>
-              <a:rPr lang="en-US" smtClean="0"/>
+              <a:rPr lang="en-US"/>
               <a:t>Click to edit Master title style</a:t>
             </a:r>
-            <a:endParaRPr lang="en-US"/>
           </a:p>
         </p:txBody>
       </p:sp>
@@ -1749,38 +1540,37 @@
           <a:p>
             <a:pPr lvl="0"/>
             <a:r>
-              <a:rPr lang="en-US" smtClean="0"/>
+              <a:rPr lang="en-US"/>
               <a:t>Click to edit Master text styles</a:t>
             </a:r>
           </a:p>
           <a:p>
             <a:pPr lvl="1"/>
             <a:r>
-              <a:rPr lang="en-US" smtClean="0"/>
+              <a:rPr lang="en-US"/>
               <a:t>Second level</a:t>
             </a:r>
           </a:p>
           <a:p>
             <a:pPr lvl="2"/>
             <a:r>
-              <a:rPr lang="en-US" smtClean="0"/>
+              <a:rPr lang="en-US"/>
               <a:t>Third level</a:t>
             </a:r>
           </a:p>
           <a:p>
             <a:pPr lvl="3"/>
             <a:r>
-              <a:rPr lang="en-US" smtClean="0"/>
+              <a:rPr lang="en-US"/>
               <a:t>Fourth level</a:t>
             </a:r>
           </a:p>
           <a:p>
             <a:pPr lvl="4"/>
             <a:r>
-              <a:rPr lang="en-US" smtClean="0"/>
+              <a:rPr lang="en-US"/>
               <a:t>Fifth level</a:t>
             </a:r>
-            <a:endParaRPr lang="en-US"/>
           </a:p>
         </p:txBody>
       </p:sp>
@@ -1801,7 +1591,7 @@
           <a:p>
             <a:fld id="{5BCAD085-E8A6-8845-BD4E-CB4CCA059FC4}" type="datetimeFigureOut">
               <a:rPr lang="en-US" smtClean="0"/>
-              <a:t>1/27/13</a:t>
+              <a:t>6/21/26</a:t>
             </a:fld>
             <a:endParaRPr lang="en-US"/>
           </a:p>
@@ -1900,10 +1690,9 @@
           <a:lstStyle/>
           <a:p>
             <a:r>
-              <a:rPr lang="en-US" smtClean="0"/>
+              <a:rPr lang="en-US"/>
               <a:t>Click to edit Master title style</a:t>
             </a:r>
-            <a:endParaRPr lang="en-US"/>
           </a:p>
         </p:txBody>
       </p:sp>
@@ -1929,38 +1718,37 @@
           <a:p>
             <a:pPr lvl="0"/>
             <a:r>
-              <a:rPr lang="en-US" smtClean="0"/>
+              <a:rPr lang="en-US"/>
               <a:t>Click to edit Master text styles</a:t>
             </a:r>
           </a:p>
           <a:p>
             <a:pPr lvl="1"/>
             <a:r>
-              <a:rPr lang="en-US" smtClean="0"/>
+              <a:rPr lang="en-US"/>
               <a:t>Second level</a:t>
             </a:r>
           </a:p>
           <a:p>
             <a:pPr lvl="2"/>
             <a:r>
-              <a:rPr lang="en-US" smtClean="0"/>
+              <a:rPr lang="en-US"/>
               <a:t>Third level</a:t>
             </a:r>
           </a:p>
           <a:p>
             <a:pPr lvl="3"/>
             <a:r>
-              <a:rPr lang="en-US" smtClean="0"/>
+              <a:rPr lang="en-US"/>
               <a:t>Fourth level</a:t>
             </a:r>
           </a:p>
           <a:p>
             <a:pPr lvl="4"/>
             <a:r>
-              <a:rPr lang="en-US" smtClean="0"/>
+              <a:rPr lang="en-US"/>
               <a:t>Fifth level</a:t>
             </a:r>
-            <a:endParaRPr lang="en-US"/>
           </a:p>
         </p:txBody>
       </p:sp>
@@ -1981,7 +1769,7 @@
           <a:p>
             <a:fld id="{5BCAD085-E8A6-8845-BD4E-CB4CCA059FC4}" type="datetimeFigureOut">
               <a:rPr lang="en-US" smtClean="0"/>
-              <a:t>1/27/13</a:t>
+              <a:t>6/21/26</a:t>
             </a:fld>
             <a:endParaRPr lang="en-US"/>
           </a:p>
@@ -2075,10 +1863,9 @@
           <a:lstStyle/>
           <a:p>
             <a:r>
-              <a:rPr lang="en-US" smtClean="0"/>
+              <a:rPr lang="en-US"/>
               <a:t>Click to edit Master title style</a:t>
             </a:r>
-            <a:endParaRPr lang="en-US"/>
           </a:p>
         </p:txBody>
       </p:sp>
@@ -2099,38 +1886,37 @@
           <a:p>
             <a:pPr lvl="0"/>
             <a:r>
-              <a:rPr lang="en-US" smtClean="0"/>
+              <a:rPr lang="en-US"/>
               <a:t>Click to edit Master text styles</a:t>
             </a:r>
           </a:p>
           <a:p>
             <a:pPr lvl="1"/>
             <a:r>
-              <a:rPr lang="en-US" smtClean="0"/>
+              <a:rPr lang="en-US"/>
               <a:t>Second level</a:t>
             </a:r>
           </a:p>
           <a:p>
             <a:pPr lvl="2"/>
             <a:r>
-              <a:rPr lang="en-US" smtClean="0"/>
+              <a:rPr lang="en-US"/>
               <a:t>Third level</a:t>
             </a:r>
           </a:p>
           <a:p>
             <a:pPr lvl="3"/>
             <a:r>
-              <a:rPr lang="en-US" smtClean="0"/>
+              <a:rPr lang="en-US"/>
               <a:t>Fourth level</a:t>
             </a:r>
           </a:p>
           <a:p>
             <a:pPr lvl="4"/>
             <a:r>
-              <a:rPr lang="en-US" smtClean="0"/>
+              <a:rPr lang="en-US"/>
               <a:t>Fifth level</a:t>
             </a:r>
-            <a:endParaRPr lang="en-US"/>
           </a:p>
         </p:txBody>
       </p:sp>
@@ -2151,7 +1937,7 @@
           <a:p>
             <a:fld id="{5BCAD085-E8A6-8845-BD4E-CB4CCA059FC4}" type="datetimeFigureOut">
               <a:rPr lang="en-US" smtClean="0"/>
-              <a:t>1/27/13</a:t>
+              <a:t>6/21/26</a:t>
             </a:fld>
             <a:endParaRPr lang="en-US"/>
           </a:p>
@@ -2254,10 +2040,9 @@
           </a:lstStyle>
           <a:p>
             <a:r>
-              <a:rPr lang="en-US" smtClean="0"/>
+              <a:rPr lang="en-US"/>
               <a:t>Click to edit Master title style</a:t>
             </a:r>
-            <a:endParaRPr lang="en-US"/>
           </a:p>
         </p:txBody>
       </p:sp>
@@ -2374,7 +2159,7 @@
           <a:p>
             <a:pPr lvl="0"/>
             <a:r>
-              <a:rPr lang="en-US" smtClean="0"/>
+              <a:rPr lang="en-US"/>
               <a:t>Click to edit Master text styles</a:t>
             </a:r>
           </a:p>
@@ -2397,7 +2182,7 @@
           <a:p>
             <a:fld id="{5BCAD085-E8A6-8845-BD4E-CB4CCA059FC4}" type="datetimeFigureOut">
               <a:rPr lang="en-US" smtClean="0"/>
-              <a:t>1/27/13</a:t>
+              <a:t>6/21/26</a:t>
             </a:fld>
             <a:endParaRPr lang="en-US"/>
           </a:p>
@@ -2491,10 +2276,9 @@
           <a:lstStyle/>
           <a:p>
             <a:r>
-              <a:rPr lang="en-US" smtClean="0"/>
+              <a:rPr lang="en-US"/>
               <a:t>Click to edit Master title style</a:t>
             </a:r>
-            <a:endParaRPr lang="en-US"/>
           </a:p>
         </p:txBody>
       </p:sp>
@@ -2548,38 +2332,37 @@
           <a:p>
             <a:pPr lvl="0"/>
             <a:r>
-              <a:rPr lang="en-US" smtClean="0"/>
+              <a:rPr lang="en-US"/>
               <a:t>Click to edit Master text styles</a:t>
             </a:r>
           </a:p>
           <a:p>
             <a:pPr lvl="1"/>
             <a:r>
-              <a:rPr lang="en-US" smtClean="0"/>
+              <a:rPr lang="en-US"/>
               <a:t>Second level</a:t>
             </a:r>
           </a:p>
           <a:p>
             <a:pPr lvl="2"/>
             <a:r>
-              <a:rPr lang="en-US" smtClean="0"/>
+              <a:rPr lang="en-US"/>
               <a:t>Third level</a:t>
             </a:r>
           </a:p>
           <a:p>
             <a:pPr lvl="3"/>
             <a:r>
-              <a:rPr lang="en-US" smtClean="0"/>
+              <a:rPr lang="en-US"/>
               <a:t>Fourth level</a:t>
             </a:r>
           </a:p>
           <a:p>
             <a:pPr lvl="4"/>
             <a:r>
-              <a:rPr lang="en-US" smtClean="0"/>
+              <a:rPr lang="en-US"/>
               <a:t>Fifth level</a:t>
             </a:r>
-            <a:endParaRPr lang="en-US"/>
           </a:p>
         </p:txBody>
       </p:sp>
@@ -2633,38 +2416,37 @@
           <a:p>
             <a:pPr lvl="0"/>
             <a:r>
-              <a:rPr lang="en-US" smtClean="0"/>
+              <a:rPr lang="en-US"/>
               <a:t>Click to edit Master text styles</a:t>
             </a:r>
           </a:p>
           <a:p>
             <a:pPr lvl="1"/>
             <a:r>
-              <a:rPr lang="en-US" smtClean="0"/>
+              <a:rPr lang="en-US"/>
               <a:t>Second level</a:t>
             </a:r>
           </a:p>
           <a:p>
             <a:pPr lvl="2"/>
             <a:r>
-              <a:rPr lang="en-US" smtClean="0"/>
+              <a:rPr lang="en-US"/>
               <a:t>Third level</a:t>
             </a:r>
           </a:p>
           <a:p>
             <a:pPr lvl="3"/>
             <a:r>
-              <a:rPr lang="en-US" smtClean="0"/>
+              <a:rPr lang="en-US"/>
               <a:t>Fourth level</a:t>
             </a:r>
           </a:p>
           <a:p>
             <a:pPr lvl="4"/>
             <a:r>
-              <a:rPr lang="en-US" smtClean="0"/>
+              <a:rPr lang="en-US"/>
               <a:t>Fifth level</a:t>
             </a:r>
-            <a:endParaRPr lang="en-US"/>
           </a:p>
         </p:txBody>
       </p:sp>
@@ -2685,7 +2467,7 @@
           <a:p>
             <a:fld id="{5BCAD085-E8A6-8845-BD4E-CB4CCA059FC4}" type="datetimeFigureOut">
               <a:rPr lang="en-US" smtClean="0"/>
-              <a:t>1/27/13</a:t>
+              <a:t>6/21/26</a:t>
             </a:fld>
             <a:endParaRPr lang="en-US"/>
           </a:p>
@@ -2783,10 +2565,9 @@
           </a:lstStyle>
           <a:p>
             <a:r>
-              <a:rPr lang="en-US" smtClean="0"/>
+              <a:rPr lang="en-US"/>
               <a:t>Click to edit Master title style</a:t>
             </a:r>
-            <a:endParaRPr lang="en-US"/>
           </a:p>
         </p:txBody>
       </p:sp>
@@ -2849,7 +2630,7 @@
           <a:p>
             <a:pPr lvl="0"/>
             <a:r>
-              <a:rPr lang="en-US" smtClean="0"/>
+              <a:rPr lang="en-US"/>
               <a:t>Click to edit Master text styles</a:t>
             </a:r>
           </a:p>
@@ -2905,38 +2686,37 @@
           <a:p>
             <a:pPr lvl="0"/>
             <a:r>
-              <a:rPr lang="en-US" smtClean="0"/>
+              <a:rPr lang="en-US"/>
               <a:t>Click to edit Master text styles</a:t>
             </a:r>
           </a:p>
           <a:p>
             <a:pPr lvl="1"/>
             <a:r>
-              <a:rPr lang="en-US" smtClean="0"/>
+              <a:rPr lang="en-US"/>
               <a:t>Second level</a:t>
             </a:r>
           </a:p>
           <a:p>
             <a:pPr lvl="2"/>
             <a:r>
-              <a:rPr lang="en-US" smtClean="0"/>
+              <a:rPr lang="en-US"/>
               <a:t>Third level</a:t>
             </a:r>
           </a:p>
           <a:p>
             <a:pPr lvl="3"/>
             <a:r>
-              <a:rPr lang="en-US" smtClean="0"/>
+              <a:rPr lang="en-US"/>
               <a:t>Fourth level</a:t>
             </a:r>
           </a:p>
           <a:p>
             <a:pPr lvl="4"/>
             <a:r>
-              <a:rPr lang="en-US" smtClean="0"/>
+              <a:rPr lang="en-US"/>
               <a:t>Fifth level</a:t>
             </a:r>
-            <a:endParaRPr lang="en-US"/>
           </a:p>
         </p:txBody>
       </p:sp>
@@ -2999,7 +2779,7 @@
           <a:p>
             <a:pPr lvl="0"/>
             <a:r>
-              <a:rPr lang="en-US" smtClean="0"/>
+              <a:rPr lang="en-US"/>
               <a:t>Click to edit Master text styles</a:t>
             </a:r>
           </a:p>
@@ -3055,38 +2835,37 @@
           <a:p>
             <a:pPr lvl="0"/>
             <a:r>
-              <a:rPr lang="en-US" smtClean="0"/>
+              <a:rPr lang="en-US"/>
               <a:t>Click to edit Master text styles</a:t>
             </a:r>
           </a:p>
           <a:p>
             <a:pPr lvl="1"/>
             <a:r>
-              <a:rPr lang="en-US" smtClean="0"/>
+              <a:rPr lang="en-US"/>
               <a:t>Second level</a:t>
             </a:r>
           </a:p>
           <a:p>
             <a:pPr lvl="2"/>
             <a:r>
-              <a:rPr lang="en-US" smtClean="0"/>
+              <a:rPr lang="en-US"/>
               <a:t>Third level</a:t>
             </a:r>
           </a:p>
           <a:p>
             <a:pPr lvl="3"/>
             <a:r>
-              <a:rPr lang="en-US" smtClean="0"/>
+              <a:rPr lang="en-US"/>
               <a:t>Fourth level</a:t>
             </a:r>
           </a:p>
           <a:p>
             <a:pPr lvl="4"/>
             <a:r>
-              <a:rPr lang="en-US" smtClean="0"/>
+              <a:rPr lang="en-US"/>
               <a:t>Fifth level</a:t>
             </a:r>
-            <a:endParaRPr lang="en-US"/>
           </a:p>
         </p:txBody>
       </p:sp>
@@ -3107,7 +2886,7 @@
           <a:p>
             <a:fld id="{5BCAD085-E8A6-8845-BD4E-CB4CCA059FC4}" type="datetimeFigureOut">
               <a:rPr lang="en-US" smtClean="0"/>
-              <a:t>1/27/13</a:t>
+              <a:t>6/21/26</a:t>
             </a:fld>
             <a:endParaRPr lang="en-US"/>
           </a:p>
@@ -3201,10 +2980,9 @@
           <a:lstStyle/>
           <a:p>
             <a:r>
-              <a:rPr lang="en-US" smtClean="0"/>
+              <a:rPr lang="en-US"/>
               <a:t>Click to edit Master title style</a:t>
             </a:r>
-            <a:endParaRPr lang="en-US"/>
           </a:p>
         </p:txBody>
       </p:sp>
@@ -3225,7 +3003,7 @@
           <a:p>
             <a:fld id="{5BCAD085-E8A6-8845-BD4E-CB4CCA059FC4}" type="datetimeFigureOut">
               <a:rPr lang="en-US" smtClean="0"/>
-              <a:t>1/27/13</a:t>
+              <a:t>6/21/26</a:t>
             </a:fld>
             <a:endParaRPr lang="en-US"/>
           </a:p>
@@ -3320,7 +3098,7 @@
           <a:p>
             <a:fld id="{5BCAD085-E8A6-8845-BD4E-CB4CCA059FC4}" type="datetimeFigureOut">
               <a:rPr lang="en-US" smtClean="0"/>
-              <a:t>1/27/13</a:t>
+              <a:t>6/21/26</a:t>
             </a:fld>
             <a:endParaRPr lang="en-US"/>
           </a:p>
@@ -3423,10 +3201,9 @@
           </a:lstStyle>
           <a:p>
             <a:r>
-              <a:rPr lang="en-US" smtClean="0"/>
+              <a:rPr lang="en-US"/>
               <a:t>Click to edit Master title style</a:t>
             </a:r>
-            <a:endParaRPr lang="en-US"/>
           </a:p>
         </p:txBody>
       </p:sp>
@@ -3480,38 +3257,37 @@
           <a:p>
             <a:pPr lvl="0"/>
             <a:r>
-              <a:rPr lang="en-US" smtClean="0"/>
+              <a:rPr lang="en-US"/>
               <a:t>Click to edit Master text styles</a:t>
             </a:r>
           </a:p>
           <a:p>
             <a:pPr lvl="1"/>
             <a:r>
-              <a:rPr lang="en-US" smtClean="0"/>
+              <a:rPr lang="en-US"/>
               <a:t>Second level</a:t>
             </a:r>
           </a:p>
           <a:p>
             <a:pPr lvl="2"/>
             <a:r>
-              <a:rPr lang="en-US" smtClean="0"/>
+              <a:rPr lang="en-US"/>
               <a:t>Third level</a:t>
             </a:r>
           </a:p>
           <a:p>
             <a:pPr lvl="3"/>
             <a:r>
-              <a:rPr lang="en-US" smtClean="0"/>
+              <a:rPr lang="en-US"/>
               <a:t>Fourth level</a:t>
             </a:r>
           </a:p>
           <a:p>
             <a:pPr lvl="4"/>
             <a:r>
-              <a:rPr lang="en-US" smtClean="0"/>
+              <a:rPr lang="en-US"/>
               <a:t>Fifth level</a:t>
             </a:r>
-            <a:endParaRPr lang="en-US"/>
           </a:p>
         </p:txBody>
       </p:sp>
@@ -3574,7 +3350,7 @@
           <a:p>
             <a:pPr lvl="0"/>
             <a:r>
-              <a:rPr lang="en-US" smtClean="0"/>
+              <a:rPr lang="en-US"/>
               <a:t>Click to edit Master text styles</a:t>
             </a:r>
           </a:p>
@@ -3597,7 +3373,7 @@
           <a:p>
             <a:fld id="{5BCAD085-E8A6-8845-BD4E-CB4CCA059FC4}" type="datetimeFigureOut">
               <a:rPr lang="en-US" smtClean="0"/>
-              <a:t>1/27/13</a:t>
+              <a:t>6/21/26</a:t>
             </a:fld>
             <a:endParaRPr lang="en-US"/>
           </a:p>
@@ -3700,10 +3476,9 @@
           </a:lstStyle>
           <a:p>
             <a:r>
-              <a:rPr lang="en-US" smtClean="0"/>
+              <a:rPr lang="en-US"/>
               <a:t>Click to edit Master title style</a:t>
             </a:r>
-            <a:endParaRPr lang="en-US"/>
           </a:p>
         </p:txBody>
       </p:sp>
@@ -3827,7 +3602,7 @@
           <a:p>
             <a:pPr lvl="0"/>
             <a:r>
-              <a:rPr lang="en-US" smtClean="0"/>
+              <a:rPr lang="en-US"/>
               <a:t>Click to edit Master text styles</a:t>
             </a:r>
           </a:p>
@@ -3850,7 +3625,7 @@
           <a:p>
             <a:fld id="{5BCAD085-E8A6-8845-BD4E-CB4CCA059FC4}" type="datetimeFigureOut">
               <a:rPr lang="en-US" smtClean="0"/>
-              <a:t>1/27/13</a:t>
+              <a:t>6/21/26</a:t>
             </a:fld>
             <a:endParaRPr lang="en-US"/>
           </a:p>
@@ -3959,10 +3734,9 @@
           <a:lstStyle/>
           <a:p>
             <a:r>
-              <a:rPr lang="en-US" smtClean="0"/>
+              <a:rPr lang="en-US"/>
               <a:t>Click to edit Master title style</a:t>
             </a:r>
-            <a:endParaRPr lang="en-US"/>
           </a:p>
         </p:txBody>
       </p:sp>
@@ -3993,38 +3767,37 @@
           <a:p>
             <a:pPr lvl="0"/>
             <a:r>
-              <a:rPr lang="en-US" smtClean="0"/>
+              <a:rPr lang="en-US"/>
               <a:t>Click to edit Master text styles</a:t>
             </a:r>
           </a:p>
           <a:p>
             <a:pPr lvl="1"/>
             <a:r>
-              <a:rPr lang="en-US" smtClean="0"/>
+              <a:rPr lang="en-US"/>
               <a:t>Second level</a:t>
             </a:r>
           </a:p>
           <a:p>
             <a:pPr lvl="2"/>
             <a:r>
-              <a:rPr lang="en-US" smtClean="0"/>
+              <a:rPr lang="en-US"/>
               <a:t>Third level</a:t>
             </a:r>
           </a:p>
           <a:p>
             <a:pPr lvl="3"/>
             <a:r>
-              <a:rPr lang="en-US" smtClean="0"/>
+              <a:rPr lang="en-US"/>
               <a:t>Fourth level</a:t>
             </a:r>
           </a:p>
           <a:p>
             <a:pPr lvl="4"/>
             <a:r>
-              <a:rPr lang="en-US" smtClean="0"/>
+              <a:rPr lang="en-US"/>
               <a:t>Fifth level</a:t>
             </a:r>
-            <a:endParaRPr lang="en-US"/>
           </a:p>
         </p:txBody>
       </p:sp>
@@ -4063,7 +3836,7 @@
           <a:p>
             <a:fld id="{5BCAD085-E8A6-8845-BD4E-CB4CCA059FC4}" type="datetimeFigureOut">
               <a:rPr lang="en-US" smtClean="0"/>
-              <a:t>1/27/13</a:t>
+              <a:t>6/21/26</a:t>
             </a:fld>
             <a:endParaRPr lang="en-US"/>
           </a:p>
@@ -4422,7 +4195,7 @@
 </file>
 
 <file path=ppt/slides/slide1.xml><?xml version="1.0" encoding="utf-8"?>
-<p:sld xmlns:a="http://schemas.openxmlformats.org/drawingml/2006/main" xmlns:p="http://schemas.openxmlformats.org/presentationml/2006/main" xmlns:r="http://schemas.openxmlformats.org/officeDocument/2006/relationships">
+<p:sld xmlns:a="http://schemas.openxmlformats.org/drawingml/2006/main" xmlns:r="http://schemas.openxmlformats.org/officeDocument/2006/relationships" xmlns:p="http://schemas.openxmlformats.org/presentationml/2006/main">
   <p:cSld>
     <p:spTree>
       <p:nvGrpSpPr>
@@ -4430,7 +4203,14 @@
         <p:cNvGrpSpPr/>
         <p:nvPr/>
       </p:nvGrpSpPr>
-      <p:grpSpPr/>
+      <p:grpSpPr>
+        <a:xfrm>
+          <a:off x="0" y="0"/>
+          <a:ext cx="0" cy="0"/>
+          <a:chOff x="0" y="0"/>
+          <a:chExt cx="0" cy="0"/>
+        </a:xfrm>
+      </p:grpSpPr>
       <p:sp>
         <p:nvSpPr>
           <p:cNvPr id="2" name="Rectangle 1"/>
@@ -4472,6 +4252,7 @@
           <a:lstStyle/>
           <a:p>
             <a:pPr algn="ctr"/>
+            <a:endParaRPr/>
           </a:p>
         </p:txBody>
       </p:sp>
@@ -4516,6 +4297,7 @@
           <a:lstStyle/>
           <a:p>
             <a:pPr algn="ctr"/>
+            <a:endParaRPr/>
           </a:p>
         </p:txBody>
       </p:sp>
@@ -4560,6 +4342,7 @@
           <a:lstStyle/>
           <a:p>
             <a:pPr algn="ctr"/>
+            <a:endParaRPr/>
           </a:p>
         </p:txBody>
       </p:sp>
@@ -4674,7 +4457,7 @@
               </a:spcAft>
             </a:pPr>
             <a:r>
-              <a:rPr sz="1500" b="1">
+              <a:rPr sz="1500" b="1" dirty="0">
                 <a:solidFill>
                   <a:srgbClr val="FFFFFF"/>
                 </a:solidFill>
@@ -4693,7 +4476,7 @@
               </a:spcAft>
             </a:pPr>
             <a:r>
-              <a:rPr sz="1300" b="0">
+              <a:rPr sz="1300" b="0" dirty="0">
                 <a:solidFill>
                   <a:srgbClr val="B8C4D0"/>
                 </a:solidFill>
@@ -4713,7 +4496,7 @@
 </file>
 
 <file path=ppt/slides/slide10.xml><?xml version="1.0" encoding="utf-8"?>
-<p:sld xmlns:a="http://schemas.openxmlformats.org/drawingml/2006/main" xmlns:p="http://schemas.openxmlformats.org/presentationml/2006/main" xmlns:r="http://schemas.openxmlformats.org/officeDocument/2006/relationships">
+<p:sld xmlns:a="http://schemas.openxmlformats.org/drawingml/2006/main" xmlns:r="http://schemas.openxmlformats.org/officeDocument/2006/relationships" xmlns:p="http://schemas.openxmlformats.org/presentationml/2006/main">
   <p:cSld>
     <p:spTree>
       <p:nvGrpSpPr>
@@ -4721,7 +4504,14 @@
         <p:cNvGrpSpPr/>
         <p:nvPr/>
       </p:nvGrpSpPr>
-      <p:grpSpPr/>
+      <p:grpSpPr>
+        <a:xfrm>
+          <a:off x="0" y="0"/>
+          <a:ext cx="0" cy="0"/>
+          <a:chOff x="0" y="0"/>
+          <a:chExt cx="0" cy="0"/>
+        </a:xfrm>
+      </p:grpSpPr>
       <p:sp>
         <p:nvSpPr>
           <p:cNvPr id="2" name="Rectangle 1"/>
@@ -4763,6 +4553,7 @@
           <a:lstStyle/>
           <a:p>
             <a:pPr algn="ctr"/>
+            <a:endParaRPr/>
           </a:p>
         </p:txBody>
       </p:sp>
@@ -4807,6 +4598,7 @@
           <a:lstStyle/>
           <a:p>
             <a:pPr algn="ctr"/>
+            <a:endParaRPr/>
           </a:p>
         </p:txBody>
       </p:sp>
@@ -4912,6 +4704,7 @@
           <a:lstStyle/>
           <a:p>
             <a:pPr algn="ctr"/>
+            <a:endParaRPr/>
           </a:p>
         </p:txBody>
       </p:sp>
@@ -4956,6 +4749,7 @@
           <a:lstStyle/>
           <a:p>
             <a:pPr algn="ctr"/>
+            <a:endParaRPr/>
           </a:p>
         </p:txBody>
       </p:sp>
@@ -5137,6 +4931,7 @@
           <a:lstStyle/>
           <a:p>
             <a:pPr algn="ctr"/>
+            <a:endParaRPr/>
           </a:p>
         </p:txBody>
       </p:sp>
@@ -5181,6 +4976,7 @@
           <a:lstStyle/>
           <a:p>
             <a:pPr algn="ctr"/>
+            <a:endParaRPr/>
           </a:p>
         </p:txBody>
       </p:sp>
@@ -5362,6 +5158,7 @@
           <a:lstStyle/>
           <a:p>
             <a:pPr algn="ctr"/>
+            <a:endParaRPr/>
           </a:p>
         </p:txBody>
       </p:sp>
@@ -5406,6 +5203,7 @@
           <a:lstStyle/>
           <a:p>
             <a:pPr algn="ctr"/>
+            <a:endParaRPr/>
           </a:p>
         </p:txBody>
       </p:sp>
@@ -5681,7 +5479,7 @@
 </file>
 
 <file path=ppt/slides/slide11.xml><?xml version="1.0" encoding="utf-8"?>
-<p:sld xmlns:a="http://schemas.openxmlformats.org/drawingml/2006/main" xmlns:p="http://schemas.openxmlformats.org/presentationml/2006/main" xmlns:r="http://schemas.openxmlformats.org/officeDocument/2006/relationships">
+<p:sld xmlns:a="http://schemas.openxmlformats.org/drawingml/2006/main" xmlns:r="http://schemas.openxmlformats.org/officeDocument/2006/relationships" xmlns:p="http://schemas.openxmlformats.org/presentationml/2006/main">
   <p:cSld>
     <p:spTree>
       <p:nvGrpSpPr>
@@ -5689,7 +5487,14 @@
         <p:cNvGrpSpPr/>
         <p:nvPr/>
       </p:nvGrpSpPr>
-      <p:grpSpPr/>
+      <p:grpSpPr>
+        <a:xfrm>
+          <a:off x="0" y="0"/>
+          <a:ext cx="0" cy="0"/>
+          <a:chOff x="0" y="0"/>
+          <a:chExt cx="0" cy="0"/>
+        </a:xfrm>
+      </p:grpSpPr>
       <p:sp>
         <p:nvSpPr>
           <p:cNvPr id="2" name="Rectangle 1"/>
@@ -5731,6 +5536,7 @@
           <a:lstStyle/>
           <a:p>
             <a:pPr algn="ctr"/>
+            <a:endParaRPr/>
           </a:p>
         </p:txBody>
       </p:sp>
@@ -5775,6 +5581,7 @@
           <a:lstStyle/>
           <a:p>
             <a:pPr algn="ctr"/>
+            <a:endParaRPr/>
           </a:p>
         </p:txBody>
       </p:sp>
@@ -5880,6 +5687,7 @@
           <a:lstStyle/>
           <a:p>
             <a:pPr algn="ctr"/>
+            <a:endParaRPr/>
           </a:p>
         </p:txBody>
       </p:sp>
@@ -5924,6 +5732,7 @@
           <a:lstStyle/>
           <a:p>
             <a:pPr algn="ctr"/>
+            <a:endParaRPr/>
           </a:p>
         </p:txBody>
       </p:sp>
@@ -6071,6 +5880,7 @@
           <a:lstStyle/>
           <a:p>
             <a:pPr algn="ctr"/>
+            <a:endParaRPr/>
           </a:p>
         </p:txBody>
       </p:sp>
@@ -6115,6 +5925,7 @@
           <a:lstStyle/>
           <a:p>
             <a:pPr algn="ctr"/>
+            <a:endParaRPr/>
           </a:p>
         </p:txBody>
       </p:sp>
@@ -6159,6 +5970,7 @@
           <a:lstStyle/>
           <a:p>
             <a:pPr algn="ctr"/>
+            <a:endParaRPr/>
           </a:p>
         </p:txBody>
       </p:sp>
@@ -6306,6 +6118,7 @@
           <a:lstStyle/>
           <a:p>
             <a:pPr algn="ctr"/>
+            <a:endParaRPr/>
           </a:p>
         </p:txBody>
       </p:sp>
@@ -6350,6 +6163,7 @@
           <a:lstStyle/>
           <a:p>
             <a:pPr algn="ctr"/>
+            <a:endParaRPr/>
           </a:p>
         </p:txBody>
       </p:sp>
@@ -6394,6 +6208,7 @@
           <a:lstStyle/>
           <a:p>
             <a:pPr algn="ctr"/>
+            <a:endParaRPr/>
           </a:p>
         </p:txBody>
       </p:sp>
@@ -6635,7 +6450,7 @@
 </file>
 
 <file path=ppt/slides/slide12.xml><?xml version="1.0" encoding="utf-8"?>
-<p:sld xmlns:a="http://schemas.openxmlformats.org/drawingml/2006/main" xmlns:p="http://schemas.openxmlformats.org/presentationml/2006/main" xmlns:r="http://schemas.openxmlformats.org/officeDocument/2006/relationships">
+<p:sld xmlns:a="http://schemas.openxmlformats.org/drawingml/2006/main" xmlns:r="http://schemas.openxmlformats.org/officeDocument/2006/relationships" xmlns:p="http://schemas.openxmlformats.org/presentationml/2006/main">
   <p:cSld>
     <p:spTree>
       <p:nvGrpSpPr>
@@ -6643,7 +6458,14 @@
         <p:cNvGrpSpPr/>
         <p:nvPr/>
       </p:nvGrpSpPr>
-      <p:grpSpPr/>
+      <p:grpSpPr>
+        <a:xfrm>
+          <a:off x="0" y="0"/>
+          <a:ext cx="0" cy="0"/>
+          <a:chOff x="0" y="0"/>
+          <a:chExt cx="0" cy="0"/>
+        </a:xfrm>
+      </p:grpSpPr>
       <p:sp>
         <p:nvSpPr>
           <p:cNvPr id="2" name="Rectangle 1"/>
@@ -6685,6 +6507,7 @@
           <a:lstStyle/>
           <a:p>
             <a:pPr algn="ctr"/>
+            <a:endParaRPr/>
           </a:p>
         </p:txBody>
       </p:sp>
@@ -6729,6 +6552,7 @@
           <a:lstStyle/>
           <a:p>
             <a:pPr algn="ctr"/>
+            <a:endParaRPr/>
           </a:p>
         </p:txBody>
       </p:sp>
@@ -6834,6 +6658,7 @@
           <a:lstStyle/>
           <a:p>
             <a:pPr algn="ctr"/>
+            <a:endParaRPr/>
           </a:p>
         </p:txBody>
       </p:sp>
@@ -6920,6 +6745,7 @@
           <a:lstStyle/>
           <a:p>
             <a:pPr algn="ctr"/>
+            <a:endParaRPr/>
           </a:p>
         </p:txBody>
       </p:sp>
@@ -7006,6 +6832,7 @@
           <a:lstStyle/>
           <a:p>
             <a:pPr algn="ctr"/>
+            <a:endParaRPr/>
           </a:p>
         </p:txBody>
       </p:sp>
@@ -7092,6 +6919,7 @@
           <a:lstStyle/>
           <a:p>
             <a:pPr algn="ctr"/>
+            <a:endParaRPr/>
           </a:p>
         </p:txBody>
       </p:sp>
@@ -7178,6 +7006,7 @@
           <a:lstStyle/>
           <a:p>
             <a:pPr algn="ctr"/>
+            <a:endParaRPr/>
           </a:p>
         </p:txBody>
       </p:sp>
@@ -7264,6 +7093,7 @@
           <a:lstStyle/>
           <a:p>
             <a:pPr algn="ctr"/>
+            <a:endParaRPr/>
           </a:p>
         </p:txBody>
       </p:sp>
@@ -7350,6 +7180,7 @@
           <a:lstStyle/>
           <a:p>
             <a:pPr algn="ctr"/>
+            <a:endParaRPr/>
           </a:p>
         </p:txBody>
       </p:sp>
@@ -7436,6 +7267,7 @@
           <a:lstStyle/>
           <a:p>
             <a:pPr algn="ctr"/>
+            <a:endParaRPr/>
           </a:p>
         </p:txBody>
       </p:sp>
@@ -7574,7 +7406,7 @@
 </file>
 
 <file path=ppt/slides/slide13.xml><?xml version="1.0" encoding="utf-8"?>
-<p:sld xmlns:a="http://schemas.openxmlformats.org/drawingml/2006/main" xmlns:p="http://schemas.openxmlformats.org/presentationml/2006/main" xmlns:r="http://schemas.openxmlformats.org/officeDocument/2006/relationships">
+<p:sld xmlns:a="http://schemas.openxmlformats.org/drawingml/2006/main" xmlns:r="http://schemas.openxmlformats.org/officeDocument/2006/relationships" xmlns:p="http://schemas.openxmlformats.org/presentationml/2006/main">
   <p:cSld>
     <p:spTree>
       <p:nvGrpSpPr>
@@ -7582,7 +7414,14 @@
         <p:cNvGrpSpPr/>
         <p:nvPr/>
       </p:nvGrpSpPr>
-      <p:grpSpPr/>
+      <p:grpSpPr>
+        <a:xfrm>
+          <a:off x="0" y="0"/>
+          <a:ext cx="0" cy="0"/>
+          <a:chOff x="0" y="0"/>
+          <a:chExt cx="0" cy="0"/>
+        </a:xfrm>
+      </p:grpSpPr>
       <p:sp>
         <p:nvSpPr>
           <p:cNvPr id="2" name="Rectangle 1"/>
@@ -7624,6 +7463,7 @@
           <a:lstStyle/>
           <a:p>
             <a:pPr algn="ctr"/>
+            <a:endParaRPr/>
           </a:p>
         </p:txBody>
       </p:sp>
@@ -7668,6 +7508,7 @@
           <a:lstStyle/>
           <a:p>
             <a:pPr algn="ctr"/>
+            <a:endParaRPr/>
           </a:p>
         </p:txBody>
       </p:sp>
@@ -7712,6 +7553,7 @@
           <a:lstStyle/>
           <a:p>
             <a:pPr algn="ctr"/>
+            <a:endParaRPr/>
           </a:p>
         </p:txBody>
       </p:sp>
@@ -8010,7 +7852,7 @@
 </file>
 
 <file path=ppt/slides/slide14.xml><?xml version="1.0" encoding="utf-8"?>
-<p:sld xmlns:a="http://schemas.openxmlformats.org/drawingml/2006/main" xmlns:p="http://schemas.openxmlformats.org/presentationml/2006/main" xmlns:r="http://schemas.openxmlformats.org/officeDocument/2006/relationships">
+<p:sld xmlns:a="http://schemas.openxmlformats.org/drawingml/2006/main" xmlns:r="http://schemas.openxmlformats.org/officeDocument/2006/relationships" xmlns:p="http://schemas.openxmlformats.org/presentationml/2006/main">
   <p:cSld>
     <p:spTree>
       <p:nvGrpSpPr>
@@ -8018,7 +7860,14 @@
         <p:cNvGrpSpPr/>
         <p:nvPr/>
       </p:nvGrpSpPr>
-      <p:grpSpPr/>
+      <p:grpSpPr>
+        <a:xfrm>
+          <a:off x="0" y="0"/>
+          <a:ext cx="0" cy="0"/>
+          <a:chOff x="0" y="0"/>
+          <a:chExt cx="0" cy="0"/>
+        </a:xfrm>
+      </p:grpSpPr>
       <p:sp>
         <p:nvSpPr>
           <p:cNvPr id="2" name="Rectangle 1"/>
@@ -8060,6 +7909,7 @@
           <a:lstStyle/>
           <a:p>
             <a:pPr algn="ctr"/>
+            <a:endParaRPr/>
           </a:p>
         </p:txBody>
       </p:sp>
@@ -8104,6 +7954,7 @@
           <a:lstStyle/>
           <a:p>
             <a:pPr algn="ctr"/>
+            <a:endParaRPr/>
           </a:p>
         </p:txBody>
       </p:sp>
@@ -8177,7 +8028,7 @@
 </file>
 
 <file path=ppt/slides/slide2.xml><?xml version="1.0" encoding="utf-8"?>
-<p:sld xmlns:a="http://schemas.openxmlformats.org/drawingml/2006/main" xmlns:p="http://schemas.openxmlformats.org/presentationml/2006/main" xmlns:r="http://schemas.openxmlformats.org/officeDocument/2006/relationships">
+<p:sld xmlns:a="http://schemas.openxmlformats.org/drawingml/2006/main" xmlns:r="http://schemas.openxmlformats.org/officeDocument/2006/relationships" xmlns:p="http://schemas.openxmlformats.org/presentationml/2006/main">
   <p:cSld>
     <p:spTree>
       <p:nvGrpSpPr>
@@ -8185,7 +8036,14 @@
         <p:cNvGrpSpPr/>
         <p:nvPr/>
       </p:nvGrpSpPr>
-      <p:grpSpPr/>
+      <p:grpSpPr>
+        <a:xfrm>
+          <a:off x="0" y="0"/>
+          <a:ext cx="0" cy="0"/>
+          <a:chOff x="0" y="0"/>
+          <a:chExt cx="0" cy="0"/>
+        </a:xfrm>
+      </p:grpSpPr>
       <p:sp>
         <p:nvSpPr>
           <p:cNvPr id="2" name="Rectangle 1"/>
@@ -8227,6 +8085,7 @@
           <a:lstStyle/>
           <a:p>
             <a:pPr algn="ctr"/>
+            <a:endParaRPr/>
           </a:p>
         </p:txBody>
       </p:sp>
@@ -8271,6 +8130,7 @@
           <a:lstStyle/>
           <a:p>
             <a:pPr algn="ctr"/>
+            <a:endParaRPr/>
           </a:p>
         </p:txBody>
       </p:sp>
@@ -8428,7 +8288,7 @@
 </file>
 
 <file path=ppt/slides/slide3.xml><?xml version="1.0" encoding="utf-8"?>
-<p:sld xmlns:a="http://schemas.openxmlformats.org/drawingml/2006/main" xmlns:p="http://schemas.openxmlformats.org/presentationml/2006/main" xmlns:r="http://schemas.openxmlformats.org/officeDocument/2006/relationships">
+<p:sld xmlns:a="http://schemas.openxmlformats.org/drawingml/2006/main" xmlns:r="http://schemas.openxmlformats.org/officeDocument/2006/relationships" xmlns:p="http://schemas.openxmlformats.org/presentationml/2006/main">
   <p:cSld>
     <p:spTree>
       <p:nvGrpSpPr>
@@ -8436,7 +8296,14 @@
         <p:cNvGrpSpPr/>
         <p:nvPr/>
       </p:nvGrpSpPr>
-      <p:grpSpPr/>
+      <p:grpSpPr>
+        <a:xfrm>
+          <a:off x="0" y="0"/>
+          <a:ext cx="0" cy="0"/>
+          <a:chOff x="0" y="0"/>
+          <a:chExt cx="0" cy="0"/>
+        </a:xfrm>
+      </p:grpSpPr>
       <p:sp>
         <p:nvSpPr>
           <p:cNvPr id="2" name="Rectangle 1"/>
@@ -8478,6 +8345,7 @@
           <a:lstStyle/>
           <a:p>
             <a:pPr algn="ctr"/>
+            <a:endParaRPr/>
           </a:p>
         </p:txBody>
       </p:sp>
@@ -8522,6 +8390,7 @@
           <a:lstStyle/>
           <a:p>
             <a:pPr algn="ctr"/>
+            <a:endParaRPr/>
           </a:p>
         </p:txBody>
       </p:sp>
@@ -8797,7 +8666,7 @@
 </file>
 
 <file path=ppt/slides/slide4.xml><?xml version="1.0" encoding="utf-8"?>
-<p:sld xmlns:a="http://schemas.openxmlformats.org/drawingml/2006/main" xmlns:p="http://schemas.openxmlformats.org/presentationml/2006/main" xmlns:r="http://schemas.openxmlformats.org/officeDocument/2006/relationships">
+<p:sld xmlns:a="http://schemas.openxmlformats.org/drawingml/2006/main" xmlns:r="http://schemas.openxmlformats.org/officeDocument/2006/relationships" xmlns:p="http://schemas.openxmlformats.org/presentationml/2006/main">
   <p:cSld>
     <p:spTree>
       <p:nvGrpSpPr>
@@ -8805,7 +8674,14 @@
         <p:cNvGrpSpPr/>
         <p:nvPr/>
       </p:nvGrpSpPr>
-      <p:grpSpPr/>
+      <p:grpSpPr>
+        <a:xfrm>
+          <a:off x="0" y="0"/>
+          <a:ext cx="0" cy="0"/>
+          <a:chOff x="0" y="0"/>
+          <a:chExt cx="0" cy="0"/>
+        </a:xfrm>
+      </p:grpSpPr>
       <p:sp>
         <p:nvSpPr>
           <p:cNvPr id="2" name="Rectangle 1"/>
@@ -8847,6 +8723,7 @@
           <a:lstStyle/>
           <a:p>
             <a:pPr algn="ctr"/>
+            <a:endParaRPr/>
           </a:p>
         </p:txBody>
       </p:sp>
@@ -8891,6 +8768,7 @@
           <a:lstStyle/>
           <a:p>
             <a:pPr algn="ctr"/>
+            <a:endParaRPr/>
           </a:p>
         </p:txBody>
       </p:sp>
@@ -8996,6 +8874,7 @@
           <a:lstStyle/>
           <a:p>
             <a:pPr algn="ctr"/>
+            <a:endParaRPr/>
           </a:p>
         </p:txBody>
       </p:sp>
@@ -9040,6 +8919,7 @@
           <a:lstStyle/>
           <a:p>
             <a:pPr algn="ctr"/>
+            <a:endParaRPr/>
           </a:p>
         </p:txBody>
       </p:sp>
@@ -9145,6 +9025,7 @@
           <a:lstStyle/>
           <a:p>
             <a:pPr algn="ctr"/>
+            <a:endParaRPr/>
           </a:p>
         </p:txBody>
       </p:sp>
@@ -9189,6 +9070,7 @@
           <a:lstStyle/>
           <a:p>
             <a:pPr algn="ctr"/>
+            <a:endParaRPr/>
           </a:p>
         </p:txBody>
       </p:sp>
@@ -9294,6 +9176,7 @@
           <a:lstStyle/>
           <a:p>
             <a:pPr algn="ctr"/>
+            <a:endParaRPr/>
           </a:p>
         </p:txBody>
       </p:sp>
@@ -9338,6 +9221,7 @@
           <a:lstStyle/>
           <a:p>
             <a:pPr algn="ctr"/>
+            <a:endParaRPr/>
           </a:p>
         </p:txBody>
       </p:sp>
@@ -9495,7 +9379,7 @@
 </file>
 
 <file path=ppt/slides/slide5.xml><?xml version="1.0" encoding="utf-8"?>
-<p:sld xmlns:a="http://schemas.openxmlformats.org/drawingml/2006/main" xmlns:p="http://schemas.openxmlformats.org/presentationml/2006/main" xmlns:r="http://schemas.openxmlformats.org/officeDocument/2006/relationships">
+<p:sld xmlns:a="http://schemas.openxmlformats.org/drawingml/2006/main" xmlns:r="http://schemas.openxmlformats.org/officeDocument/2006/relationships" xmlns:p="http://schemas.openxmlformats.org/presentationml/2006/main">
   <p:cSld>
     <p:spTree>
       <p:nvGrpSpPr>
@@ -9503,7 +9387,14 @@
         <p:cNvGrpSpPr/>
         <p:nvPr/>
       </p:nvGrpSpPr>
-      <p:grpSpPr/>
+      <p:grpSpPr>
+        <a:xfrm>
+          <a:off x="0" y="0"/>
+          <a:ext cx="0" cy="0"/>
+          <a:chOff x="0" y="0"/>
+          <a:chExt cx="0" cy="0"/>
+        </a:xfrm>
+      </p:grpSpPr>
       <p:sp>
         <p:nvSpPr>
           <p:cNvPr id="2" name="Rectangle 1"/>
@@ -9545,6 +9436,7 @@
           <a:lstStyle/>
           <a:p>
             <a:pPr algn="ctr"/>
+            <a:endParaRPr/>
           </a:p>
         </p:txBody>
       </p:sp>
@@ -9589,6 +9481,7 @@
           <a:lstStyle/>
           <a:p>
             <a:pPr algn="ctr"/>
+            <a:endParaRPr/>
           </a:p>
         </p:txBody>
       </p:sp>
@@ -9765,7 +9658,7 @@
 </file>
 
 <file path=ppt/slides/slide6.xml><?xml version="1.0" encoding="utf-8"?>
-<p:sld xmlns:a="http://schemas.openxmlformats.org/drawingml/2006/main" xmlns:p="http://schemas.openxmlformats.org/presentationml/2006/main" xmlns:r="http://schemas.openxmlformats.org/officeDocument/2006/relationships">
+<p:sld xmlns:a="http://schemas.openxmlformats.org/drawingml/2006/main" xmlns:r="http://schemas.openxmlformats.org/officeDocument/2006/relationships" xmlns:p="http://schemas.openxmlformats.org/presentationml/2006/main">
   <p:cSld>
     <p:spTree>
       <p:nvGrpSpPr>
@@ -9773,7 +9666,14 @@
         <p:cNvGrpSpPr/>
         <p:nvPr/>
       </p:nvGrpSpPr>
-      <p:grpSpPr/>
+      <p:grpSpPr>
+        <a:xfrm>
+          <a:off x="0" y="0"/>
+          <a:ext cx="0" cy="0"/>
+          <a:chOff x="0" y="0"/>
+          <a:chExt cx="0" cy="0"/>
+        </a:xfrm>
+      </p:grpSpPr>
       <p:sp>
         <p:nvSpPr>
           <p:cNvPr id="2" name="Rectangle 1"/>
@@ -9815,6 +9715,7 @@
           <a:lstStyle/>
           <a:p>
             <a:pPr algn="ctr"/>
+            <a:endParaRPr/>
           </a:p>
         </p:txBody>
       </p:sp>
@@ -9859,6 +9760,7 @@
           <a:lstStyle/>
           <a:p>
             <a:pPr algn="ctr"/>
+            <a:endParaRPr/>
           </a:p>
         </p:txBody>
       </p:sp>
@@ -9964,6 +9866,7 @@
           <a:lstStyle/>
           <a:p>
             <a:pPr algn="ctr"/>
+            <a:endParaRPr/>
           </a:p>
         </p:txBody>
       </p:sp>
@@ -10008,6 +9911,7 @@
           <a:lstStyle/>
           <a:p>
             <a:pPr algn="ctr"/>
+            <a:endParaRPr/>
           </a:p>
         </p:txBody>
       </p:sp>
@@ -10193,6 +10097,7 @@
           <a:lstStyle/>
           <a:p>
             <a:pPr algn="ctr"/>
+            <a:endParaRPr/>
           </a:p>
         </p:txBody>
       </p:sp>
@@ -10237,6 +10142,7 @@
           <a:lstStyle/>
           <a:p>
             <a:pPr algn="ctr"/>
+            <a:endParaRPr/>
           </a:p>
         </p:txBody>
       </p:sp>
@@ -10422,6 +10328,7 @@
           <a:lstStyle/>
           <a:p>
             <a:pPr algn="ctr"/>
+            <a:endParaRPr/>
           </a:p>
         </p:txBody>
       </p:sp>
@@ -10466,6 +10373,7 @@
           <a:lstStyle/>
           <a:p>
             <a:pPr algn="ctr"/>
+            <a:endParaRPr/>
           </a:p>
         </p:txBody>
       </p:sp>
@@ -10703,7 +10611,7 @@
 </file>
 
 <file path=ppt/slides/slide7.xml><?xml version="1.0" encoding="utf-8"?>
-<p:sld xmlns:a="http://schemas.openxmlformats.org/drawingml/2006/main" xmlns:p="http://schemas.openxmlformats.org/presentationml/2006/main" xmlns:r="http://schemas.openxmlformats.org/officeDocument/2006/relationships">
+<p:sld xmlns:a="http://schemas.openxmlformats.org/drawingml/2006/main" xmlns:r="http://schemas.openxmlformats.org/officeDocument/2006/relationships" xmlns:p="http://schemas.openxmlformats.org/presentationml/2006/main">
   <p:cSld>
     <p:spTree>
       <p:nvGrpSpPr>
@@ -10711,7 +10619,14 @@
         <p:cNvGrpSpPr/>
         <p:nvPr/>
       </p:nvGrpSpPr>
-      <p:grpSpPr/>
+      <p:grpSpPr>
+        <a:xfrm>
+          <a:off x="0" y="0"/>
+          <a:ext cx="0" cy="0"/>
+          <a:chOff x="0" y="0"/>
+          <a:chExt cx="0" cy="0"/>
+        </a:xfrm>
+      </p:grpSpPr>
       <p:sp>
         <p:nvSpPr>
           <p:cNvPr id="2" name="Rectangle 1"/>
@@ -10753,6 +10668,7 @@
           <a:lstStyle/>
           <a:p>
             <a:pPr algn="ctr"/>
+            <a:endParaRPr/>
           </a:p>
         </p:txBody>
       </p:sp>
@@ -10797,6 +10713,7 @@
           <a:lstStyle/>
           <a:p>
             <a:pPr algn="ctr"/>
+            <a:endParaRPr/>
           </a:p>
         </p:txBody>
       </p:sp>
@@ -10902,6 +10819,7 @@
           <a:lstStyle/>
           <a:p>
             <a:pPr algn="ctr"/>
+            <a:endParaRPr/>
           </a:p>
         </p:txBody>
       </p:sp>
@@ -10946,6 +10864,7 @@
           <a:lstStyle/>
           <a:p>
             <a:pPr algn="ctr"/>
+            <a:endParaRPr/>
           </a:p>
         </p:txBody>
       </p:sp>
@@ -11089,6 +11008,7 @@
           <a:lstStyle/>
           <a:p>
             <a:pPr algn="ctr"/>
+            <a:endParaRPr/>
           </a:p>
         </p:txBody>
       </p:sp>
@@ -11175,6 +11095,7 @@
           <a:lstStyle/>
           <a:p>
             <a:pPr algn="ctr"/>
+            <a:endParaRPr/>
           </a:p>
         </p:txBody>
       </p:sp>
@@ -11219,6 +11140,7 @@
           <a:lstStyle/>
           <a:p>
             <a:pPr algn="ctr"/>
+            <a:endParaRPr/>
           </a:p>
         </p:txBody>
       </p:sp>
@@ -11231,7 +11153,7 @@
         <p:spPr>
           <a:xfrm>
             <a:off x="5303520" y="2468880"/>
-            <a:ext cx="2651760" cy="2011680"/>
+            <a:ext cx="2651760" cy="1220847"/>
           </a:xfrm>
           <a:prstGeom prst="rect">
             <a:avLst/>
@@ -11253,14 +11175,29 @@
               </a:spcAft>
             </a:pPr>
             <a:r>
-              <a:rPr sz="1600" b="1">
+              <a:rPr sz="1600" b="1" dirty="0">
                 <a:solidFill>
                   <a:srgbClr val="FFFFFF"/>
                 </a:solidFill>
                 <a:latin typeface="Calibri"/>
               </a:rPr>
-              <a:t>Our cloud (AWS)</a:t>
-            </a:r>
+              <a:t>Our cloud</a:t>
+            </a:r>
+            <a:r>
+              <a:rPr lang="en-US" sz="1600" b="1" dirty="0">
+                <a:solidFill>
+                  <a:srgbClr val="FFFFFF"/>
+                </a:solidFill>
+                <a:latin typeface="Calibri"/>
+              </a:rPr>
+              <a:t> OR Datacenter</a:t>
+            </a:r>
+            <a:endParaRPr sz="1600" b="1" dirty="0">
+              <a:solidFill>
+                <a:srgbClr val="FFFFFF"/>
+              </a:solidFill>
+              <a:latin typeface="Calibri"/>
+            </a:endParaRPr>
           </a:p>
           <a:p>
             <a:pPr algn="l">
@@ -11272,7 +11209,7 @@
               </a:spcAft>
             </a:pPr>
             <a:r>
-              <a:rPr sz="1300" b="0">
+              <a:rPr sz="1300" b="0" dirty="0">
                 <a:solidFill>
                   <a:srgbClr val="C8D4E0"/>
                 </a:solidFill>
@@ -11291,7 +11228,7 @@
               </a:spcAft>
             </a:pPr>
             <a:r>
-              <a:rPr sz="1300" b="0">
+              <a:rPr sz="1300" b="0" dirty="0">
                 <a:solidFill>
                   <a:srgbClr val="C8D4E0"/>
                 </a:solidFill>
@@ -11310,7 +11247,7 @@
               </a:spcAft>
             </a:pPr>
             <a:r>
-              <a:rPr sz="1300" b="0">
+              <a:rPr sz="1300" b="0" dirty="0">
                 <a:solidFill>
                   <a:srgbClr val="C8D4E0"/>
                 </a:solidFill>
@@ -11362,6 +11299,7 @@
           <a:lstStyle/>
           <a:p>
             <a:pPr algn="ctr"/>
+            <a:endParaRPr/>
           </a:p>
         </p:txBody>
       </p:sp>
@@ -11406,6 +11344,7 @@
           <a:lstStyle/>
           <a:p>
             <a:pPr algn="ctr"/>
+            <a:endParaRPr/>
           </a:p>
         </p:txBody>
       </p:sp>
@@ -11450,6 +11389,7 @@
           <a:lstStyle/>
           <a:p>
             <a:pPr algn="ctr"/>
+            <a:endParaRPr/>
           </a:p>
         </p:txBody>
       </p:sp>
@@ -11687,7 +11627,7 @@
 </file>
 
 <file path=ppt/slides/slide8.xml><?xml version="1.0" encoding="utf-8"?>
-<p:sld xmlns:a="http://schemas.openxmlformats.org/drawingml/2006/main" xmlns:p="http://schemas.openxmlformats.org/presentationml/2006/main" xmlns:r="http://schemas.openxmlformats.org/officeDocument/2006/relationships">
+<p:sld xmlns:a="http://schemas.openxmlformats.org/drawingml/2006/main" xmlns:r="http://schemas.openxmlformats.org/officeDocument/2006/relationships" xmlns:p="http://schemas.openxmlformats.org/presentationml/2006/main">
   <p:cSld>
     <p:spTree>
       <p:nvGrpSpPr>
@@ -11695,7 +11635,14 @@
         <p:cNvGrpSpPr/>
         <p:nvPr/>
       </p:nvGrpSpPr>
-      <p:grpSpPr/>
+      <p:grpSpPr>
+        <a:xfrm>
+          <a:off x="0" y="0"/>
+          <a:ext cx="0" cy="0"/>
+          <a:chOff x="0" y="0"/>
+          <a:chExt cx="0" cy="0"/>
+        </a:xfrm>
+      </p:grpSpPr>
       <p:sp>
         <p:nvSpPr>
           <p:cNvPr id="2" name="Rectangle 1"/>
@@ -11737,6 +11684,7 @@
           <a:lstStyle/>
           <a:p>
             <a:pPr algn="ctr"/>
+            <a:endParaRPr/>
           </a:p>
         </p:txBody>
       </p:sp>
@@ -11781,6 +11729,7 @@
           <a:lstStyle/>
           <a:p>
             <a:pPr algn="ctr"/>
+            <a:endParaRPr/>
           </a:p>
         </p:txBody>
       </p:sp>
@@ -11886,6 +11835,7 @@
           <a:lstStyle/>
           <a:p>
             <a:pPr algn="ctr"/>
+            <a:endParaRPr/>
           </a:p>
         </p:txBody>
       </p:sp>
@@ -11930,6 +11880,7 @@
           <a:lstStyle/>
           <a:p>
             <a:pPr algn="ctr"/>
+            <a:endParaRPr/>
           </a:p>
         </p:txBody>
       </p:sp>
@@ -12073,6 +12024,7 @@
           <a:lstStyle/>
           <a:p>
             <a:pPr algn="ctr"/>
+            <a:endParaRPr/>
           </a:p>
         </p:txBody>
       </p:sp>
@@ -12117,6 +12069,7 @@
           <a:lstStyle/>
           <a:p>
             <a:pPr algn="ctr"/>
+            <a:endParaRPr/>
           </a:p>
         </p:txBody>
       </p:sp>
@@ -12260,6 +12213,7 @@
           <a:lstStyle/>
           <a:p>
             <a:pPr algn="ctr"/>
+            <a:endParaRPr/>
           </a:p>
         </p:txBody>
       </p:sp>
@@ -12304,6 +12258,7 @@
           <a:lstStyle/>
           <a:p>
             <a:pPr algn="ctr"/>
+            <a:endParaRPr/>
           </a:p>
         </p:txBody>
       </p:sp>
@@ -12541,7 +12496,7 @@
 </file>
 
 <file path=ppt/slides/slide9.xml><?xml version="1.0" encoding="utf-8"?>
-<p:sld xmlns:a="http://schemas.openxmlformats.org/drawingml/2006/main" xmlns:p="http://schemas.openxmlformats.org/presentationml/2006/main" xmlns:r="http://schemas.openxmlformats.org/officeDocument/2006/relationships">
+<p:sld xmlns:a="http://schemas.openxmlformats.org/drawingml/2006/main" xmlns:r="http://schemas.openxmlformats.org/officeDocument/2006/relationships" xmlns:p="http://schemas.openxmlformats.org/presentationml/2006/main">
   <p:cSld>
     <p:spTree>
       <p:nvGrpSpPr>
@@ -12549,7 +12504,14 @@
         <p:cNvGrpSpPr/>
         <p:nvPr/>
       </p:nvGrpSpPr>
-      <p:grpSpPr/>
+      <p:grpSpPr>
+        <a:xfrm>
+          <a:off x="0" y="0"/>
+          <a:ext cx="0" cy="0"/>
+          <a:chOff x="0" y="0"/>
+          <a:chExt cx="0" cy="0"/>
+        </a:xfrm>
+      </p:grpSpPr>
       <p:sp>
         <p:nvSpPr>
           <p:cNvPr id="2" name="Rectangle 1"/>
@@ -12591,6 +12553,7 @@
           <a:lstStyle/>
           <a:p>
             <a:pPr algn="ctr"/>
+            <a:endParaRPr/>
           </a:p>
         </p:txBody>
       </p:sp>
@@ -12635,6 +12598,7 @@
           <a:lstStyle/>
           <a:p>
             <a:pPr algn="ctr"/>
+            <a:endParaRPr/>
           </a:p>
         </p:txBody>
       </p:sp>
@@ -12740,6 +12704,7 @@
           <a:lstStyle/>
           <a:p>
             <a:pPr algn="ctr"/>
+            <a:endParaRPr/>
           </a:p>
         </p:txBody>
       </p:sp>
@@ -12868,6 +12833,7 @@
           <a:lstStyle/>
           <a:p>
             <a:pPr algn="ctr"/>
+            <a:endParaRPr/>
           </a:p>
         </p:txBody>
       </p:sp>
@@ -12996,6 +12962,7 @@
           <a:lstStyle/>
           <a:p>
             <a:pPr algn="ctr"/>
+            <a:endParaRPr/>
           </a:p>
         </p:txBody>
       </p:sp>
@@ -13124,6 +13091,7 @@
           <a:lstStyle/>
           <a:p>
             <a:pPr algn="ctr"/>
+            <a:endParaRPr/>
           </a:p>
         </p:txBody>
       </p:sp>
@@ -13252,6 +13220,7 @@
           <a:lstStyle/>
           <a:p>
             <a:pPr algn="ctr"/>
+            <a:endParaRPr/>
           </a:p>
         </p:txBody>
       </p:sp>
@@ -13380,6 +13349,7 @@
           <a:lstStyle/>
           <a:p>
             <a:pPr algn="ctr"/>
+            <a:endParaRPr/>
           </a:p>
         </p:txBody>
       </p:sp>
@@ -13508,6 +13478,7 @@
           <a:lstStyle/>
           <a:p>
             <a:pPr algn="ctr"/>
+            <a:endParaRPr/>
           </a:p>
         </p:txBody>
       </p:sp>
@@ -13636,6 +13607,7 @@
           <a:lstStyle/>
           <a:p>
             <a:pPr algn="ctr"/>
+            <a:endParaRPr/>
           </a:p>
         </p:txBody>
       </p:sp>
@@ -14146,44 +14118,44 @@
         <a:sysClr val="window" lastClr="FFFFFF"/>
       </a:lt1>
       <a:dk2>
-        <a:srgbClr val="1F497D"/>
+        <a:srgbClr val="0E2841"/>
       </a:dk2>
       <a:lt2>
-        <a:srgbClr val="EEECE1"/>
+        <a:srgbClr val="E8E8E8"/>
       </a:lt2>
       <a:accent1>
-        <a:srgbClr val="4F81BD"/>
+        <a:srgbClr val="156082"/>
       </a:accent1>
       <a:accent2>
-        <a:srgbClr val="C0504D"/>
+        <a:srgbClr val="E97132"/>
       </a:accent2>
       <a:accent3>
-        <a:srgbClr val="9BBB59"/>
+        <a:srgbClr val="196B24"/>
       </a:accent3>
       <a:accent4>
-        <a:srgbClr val="8064A2"/>
+        <a:srgbClr val="0F9ED5"/>
       </a:accent4>
       <a:accent5>
-        <a:srgbClr val="4BACC6"/>
+        <a:srgbClr val="A02B93"/>
       </a:accent5>
       <a:accent6>
-        <a:srgbClr val="F79646"/>
+        <a:srgbClr val="4EA72E"/>
       </a:accent6>
       <a:hlink>
-        <a:srgbClr val="0000FF"/>
+        <a:srgbClr val="467886"/>
       </a:hlink>
       <a:folHlink>
-        <a:srgbClr val="800080"/>
+        <a:srgbClr val="96607D"/>
       </a:folHlink>
     </a:clrScheme>
     <a:fontScheme name="Office">
       <a:majorFont>
-        <a:latin typeface="Calibri"/>
+        <a:latin typeface="Aptos Display" panose="02110004020202020204"/>
         <a:ea typeface=""/>
         <a:cs typeface=""/>
-        <a:font script="Jpan" typeface="ＭＳ Ｐゴシック"/>
+        <a:font script="Jpan" typeface="游ゴシック Light"/>
         <a:font script="Hang" typeface="맑은 고딕"/>
-        <a:font script="Hans" typeface="宋体"/>
+        <a:font script="Hans" typeface="等线 Light"/>
         <a:font script="Hant" typeface="新細明體"/>
         <a:font script="Arab" typeface="Times New Roman"/>
         <a:font script="Hebr" typeface="Times New Roman"/>
@@ -14211,14 +14183,31 @@
         <a:font script="Viet" typeface="Times New Roman"/>
         <a:font script="Uigh" typeface="Microsoft Uighur"/>
         <a:font script="Geor" typeface="Sylfaen"/>
+        <a:font script="Armn" typeface="Arial"/>
+        <a:font script="Bugi" typeface="Leelawadee UI"/>
+        <a:font script="Bopo" typeface="Microsoft JhengHei"/>
+        <a:font script="Java" typeface="Javanese Text"/>
+        <a:font script="Lisu" typeface="Segoe UI"/>
+        <a:font script="Mymr" typeface="Myanmar Text"/>
+        <a:font script="Nkoo" typeface="Ebrima"/>
+        <a:font script="Olck" typeface="Nirmala UI"/>
+        <a:font script="Osma" typeface="Ebrima"/>
+        <a:font script="Phag" typeface="Phagspa"/>
+        <a:font script="Syrn" typeface="Estrangelo Edessa"/>
+        <a:font script="Syrj" typeface="Estrangelo Edessa"/>
+        <a:font script="Syre" typeface="Estrangelo Edessa"/>
+        <a:font script="Sora" typeface="Nirmala UI"/>
+        <a:font script="Tale" typeface="Microsoft Tai Le"/>
+        <a:font script="Talu" typeface="Microsoft New Tai Lue"/>
+        <a:font script="Tfng" typeface="Ebrima"/>
       </a:majorFont>
       <a:minorFont>
-        <a:latin typeface="Calibri"/>
+        <a:latin typeface="Aptos" panose="02110004020202020204"/>
         <a:ea typeface=""/>
         <a:cs typeface=""/>
-        <a:font script="Jpan" typeface="ＭＳ Ｐゴシック"/>
+        <a:font script="Jpan" typeface="游ゴシック"/>
         <a:font script="Hang" typeface="맑은 고딕"/>
-        <a:font script="Hans" typeface="宋体"/>
+        <a:font script="Hans" typeface="等线"/>
         <a:font script="Hant" typeface="新細明體"/>
         <a:font script="Arab" typeface="Arial"/>
         <a:font script="Hebr" typeface="Arial"/>
@@ -14246,6 +14235,23 @@
         <a:font script="Viet" typeface="Arial"/>
         <a:font script="Uigh" typeface="Microsoft Uighur"/>
         <a:font script="Geor" typeface="Sylfaen"/>
+        <a:font script="Armn" typeface="Arial"/>
+        <a:font script="Bugi" typeface="Leelawadee UI"/>
+        <a:font script="Bopo" typeface="Microsoft JhengHei"/>
+        <a:font script="Java" typeface="Javanese Text"/>
+        <a:font script="Lisu" typeface="Segoe UI"/>
+        <a:font script="Mymr" typeface="Myanmar Text"/>
+        <a:font script="Nkoo" typeface="Ebrima"/>
+        <a:font script="Olck" typeface="Nirmala UI"/>
+        <a:font script="Osma" typeface="Ebrima"/>
+        <a:font script="Phag" typeface="Phagspa"/>
+        <a:font script="Syrn" typeface="Estrangelo Edessa"/>
+        <a:font script="Syrj" typeface="Estrangelo Edessa"/>
+        <a:font script="Syre" typeface="Estrangelo Edessa"/>
+        <a:font script="Sora" typeface="Nirmala UI"/>
+        <a:font script="Tale" typeface="Microsoft Tai Le"/>
+        <a:font script="Talu" typeface="Microsoft New Tai Lue"/>
+        <a:font script="Tfng" typeface="Ebrima"/>
       </a:minorFont>
     </a:fontScheme>
     <a:fmtScheme name="Office">
@@ -14257,180 +14263,136 @@
           <a:gsLst>
             <a:gs pos="0">
               <a:schemeClr val="phClr">
-                <a:tint val="50000"/>
-                <a:satMod val="300000"/>
+                <a:lumMod val="110000"/>
+                <a:satMod val="105000"/>
+                <a:tint val="67000"/>
               </a:schemeClr>
             </a:gs>
-            <a:gs pos="35000">
+            <a:gs pos="50000">
               <a:schemeClr val="phClr">
-                <a:tint val="37000"/>
-                <a:satMod val="300000"/>
+                <a:lumMod val="105000"/>
+                <a:satMod val="103000"/>
+                <a:tint val="73000"/>
               </a:schemeClr>
             </a:gs>
             <a:gs pos="100000">
               <a:schemeClr val="phClr">
-                <a:tint val="15000"/>
-                <a:satMod val="350000"/>
+                <a:lumMod val="105000"/>
+                <a:satMod val="109000"/>
+                <a:tint val="81000"/>
               </a:schemeClr>
             </a:gs>
           </a:gsLst>
-          <a:lin ang="16200000" scaled="1"/>
+          <a:lin ang="5400000" scaled="0"/>
         </a:gradFill>
         <a:gradFill rotWithShape="1">
           <a:gsLst>
             <a:gs pos="0">
               <a:schemeClr val="phClr">
-                <a:tint val="100000"/>
+                <a:satMod val="103000"/>
+                <a:lumMod val="102000"/>
+                <a:tint val="94000"/>
+              </a:schemeClr>
+            </a:gs>
+            <a:gs pos="50000">
+              <a:schemeClr val="phClr">
+                <a:satMod val="110000"/>
+                <a:lumMod val="100000"/>
                 <a:shade val="100000"/>
-                <a:satMod val="130000"/>
               </a:schemeClr>
             </a:gs>
             <a:gs pos="100000">
               <a:schemeClr val="phClr">
-                <a:tint val="50000"/>
-                <a:shade val="100000"/>
-                <a:satMod val="350000"/>
+                <a:lumMod val="99000"/>
+                <a:satMod val="120000"/>
+                <a:shade val="78000"/>
               </a:schemeClr>
             </a:gs>
           </a:gsLst>
-          <a:lin ang="16200000" scaled="0"/>
+          <a:lin ang="5400000" scaled="0"/>
         </a:gradFill>
       </a:fillStyleLst>
       <a:lnStyleLst>
-        <a:ln w="9525" cap="flat" cmpd="sng" algn="ctr">
+        <a:ln w="12700" cap="flat" cmpd="sng" algn="ctr">
           <a:solidFill>
-            <a:schemeClr val="phClr">
-              <a:shade val="95000"/>
-              <a:satMod val="105000"/>
-            </a:schemeClr>
+            <a:schemeClr val="phClr"/>
           </a:solidFill>
           <a:prstDash val="solid"/>
+          <a:miter lim="800000"/>
+        </a:ln>
+        <a:ln w="19050" cap="flat" cmpd="sng" algn="ctr">
+          <a:solidFill>
+            <a:schemeClr val="phClr"/>
+          </a:solidFill>
+          <a:prstDash val="solid"/>
+          <a:miter lim="800000"/>
         </a:ln>
         <a:ln w="25400" cap="flat" cmpd="sng" algn="ctr">
           <a:solidFill>
             <a:schemeClr val="phClr"/>
           </a:solidFill>
           <a:prstDash val="solid"/>
-        </a:ln>
-        <a:ln w="38100" cap="flat" cmpd="sng" algn="ctr">
-          <a:solidFill>
-            <a:schemeClr val="phClr"/>
-          </a:solidFill>
-          <a:prstDash val="solid"/>
+          <a:miter lim="800000"/>
         </a:ln>
       </a:lnStyleLst>
       <a:effectStyleLst>
         <a:effectStyle>
+          <a:effectLst/>
+        </a:effectStyle>
+        <a:effectStyle>
+          <a:effectLst/>
+        </a:effectStyle>
+        <a:effectStyle>
           <a:effectLst>
-            <a:outerShdw blurRad="40000" dist="20000" dir="5400000" rotWithShape="0">
+            <a:outerShdw blurRad="57150" dist="19050" dir="5400000" algn="ctr" rotWithShape="0">
               <a:srgbClr val="000000">
-                <a:alpha val="38000"/>
+                <a:alpha val="63000"/>
               </a:srgbClr>
             </a:outerShdw>
           </a:effectLst>
-        </a:effectStyle>
-        <a:effectStyle>
-          <a:effectLst>
-            <a:outerShdw blurRad="40000" dist="23000" dir="5400000" rotWithShape="0">
-              <a:srgbClr val="000000">
-                <a:alpha val="35000"/>
-              </a:srgbClr>
-            </a:outerShdw>
-          </a:effectLst>
-        </a:effectStyle>
-        <a:effectStyle>
-          <a:effectLst>
-            <a:outerShdw blurRad="40000" dist="23000" dir="5400000" rotWithShape="0">
-              <a:srgbClr val="000000">
-                <a:alpha val="35000"/>
-              </a:srgbClr>
-            </a:outerShdw>
-          </a:effectLst>
-          <a:scene3d>
-            <a:camera prst="orthographicFront">
-              <a:rot lat="0" lon="0" rev="0"/>
-            </a:camera>
-            <a:lightRig rig="threePt" dir="t">
-              <a:rot lat="0" lon="0" rev="1200000"/>
-            </a:lightRig>
-          </a:scene3d>
-          <a:sp3d>
-            <a:bevelT w="63500" h="25400"/>
-          </a:sp3d>
         </a:effectStyle>
       </a:effectStyleLst>
       <a:bgFillStyleLst>
         <a:solidFill>
           <a:schemeClr val="phClr"/>
         </a:solidFill>
+        <a:solidFill>
+          <a:schemeClr val="phClr">
+            <a:tint val="95000"/>
+            <a:satMod val="170000"/>
+          </a:schemeClr>
+        </a:solidFill>
         <a:gradFill rotWithShape="1">
           <a:gsLst>
             <a:gs pos="0">
               <a:schemeClr val="phClr">
-                <a:tint val="40000"/>
-                <a:satMod val="350000"/>
+                <a:tint val="93000"/>
+                <a:satMod val="150000"/>
+                <a:shade val="98000"/>
+                <a:lumMod val="102000"/>
               </a:schemeClr>
             </a:gs>
-            <a:gs pos="40000">
+            <a:gs pos="50000">
               <a:schemeClr val="phClr">
-                <a:tint val="45000"/>
-                <a:shade val="99000"/>
-                <a:satMod val="350000"/>
+                <a:tint val="98000"/>
+                <a:satMod val="130000"/>
+                <a:shade val="90000"/>
+                <a:lumMod val="103000"/>
               </a:schemeClr>
             </a:gs>
             <a:gs pos="100000">
               <a:schemeClr val="phClr">
-                <a:shade val="20000"/>
-                <a:satMod val="255000"/>
+                <a:shade val="63000"/>
+                <a:satMod val="120000"/>
               </a:schemeClr>
             </a:gs>
           </a:gsLst>
-          <a:path path="circle">
-            <a:fillToRect l="50000" t="-80000" r="50000" b="180000"/>
-          </a:path>
-        </a:gradFill>
-        <a:gradFill rotWithShape="1">
-          <a:gsLst>
-            <a:gs pos="0">
-              <a:schemeClr val="phClr">
-                <a:tint val="80000"/>
-                <a:satMod val="300000"/>
-              </a:schemeClr>
-            </a:gs>
-            <a:gs pos="100000">
-              <a:schemeClr val="phClr">
-                <a:shade val="30000"/>
-                <a:satMod val="200000"/>
-              </a:schemeClr>
-            </a:gs>
-          </a:gsLst>
-          <a:path path="circle">
-            <a:fillToRect l="50000" t="50000" r="50000" b="50000"/>
-          </a:path>
+          <a:lin ang="5400000" scaled="0"/>
         </a:gradFill>
       </a:bgFillStyleLst>
     </a:fmtScheme>
   </a:themeElements>
   <a:objectDefaults>
-    <a:spDef>
-      <a:spPr/>
-      <a:bodyPr/>
-      <a:lstStyle/>
-      <a:style>
-        <a:lnRef idx="1">
-          <a:schemeClr val="accent1"/>
-        </a:lnRef>
-        <a:fillRef idx="3">
-          <a:schemeClr val="accent1"/>
-        </a:fillRef>
-        <a:effectRef idx="2">
-          <a:schemeClr val="accent1"/>
-        </a:effectRef>
-        <a:fontRef idx="minor">
-          <a:schemeClr val="lt1"/>
-        </a:fontRef>
-      </a:style>
-    </a:spDef>
     <a:lnDef>
       <a:spPr/>
       <a:bodyPr/>
@@ -14452,5 +14414,10 @@
     </a:lnDef>
   </a:objectDefaults>
   <a:extraClrSchemeLst/>
+  <a:extLst>
+    <a:ext uri="{05A4C25C-085E-4340-85A3-A5531E510DB2}">
+      <thm15:themeFamily xmlns:thm15="http://schemas.microsoft.com/office/thememl/2012/main" name="Office Theme" id="{2E142A2C-CD16-42D6-873A-C26D2A0506FA}" vid="{1BDDFF52-6CD6-40A5-AB3C-68EB2F1E4D0A}"/>
+    </a:ext>
+  </a:extLst>
 </a:theme>
 </file>
</xml_diff>

<commit_message>
Reconcile scale to 10k across deck, requirements, and design
- Exec deck: current-state (~10k), economics slide (commercial ~$360-840k/yr vs
  our infra ~$18-42k/yr at 10k+HA), and phased plan (pilot 50 -> ~1k new machines
  zero-touch -> existing fleet -> 10k). Regenerated the .pptx.
- requirements.md: grounding scenario + NFR-1 to 10k phased; add UC-14 (zero-touch
  new-machine enroll) and UC-15 (bulk existing); move zero-touch into scope (was
  listed out-of-scope).
- design.md: purpose/constraints to 10k; new S14 'Scaling to ~10k & enrollment at
  scale' (Fleet scales out; TRMM multi-instance; HA; two enrollment tracks).

Co-Authored-By: Claude Opus 4.8 <noreply@anthropic.com>
</commit_message>
<xml_diff>
--- a/presentation/Northbridge_EndpointManagement_ExecBrief.pptx
+++ b/presentation/Northbridge_EndpointManagement_ExecBrief.pptx
@@ -4,26 +4,23 @@
   <p:sldMasterIdLst>
     <p:sldMasterId id="2147483648" r:id="rId1"/>
   </p:sldMasterIdLst>
-  <p:notesMasterIdLst>
-    <p:notesMasterId r:id="rId16"/>
-  </p:notesMasterIdLst>
   <p:sldIdLst>
-    <p:sldId id="256" r:id="rId2"/>
-    <p:sldId id="257" r:id="rId3"/>
-    <p:sldId id="258" r:id="rId4"/>
-    <p:sldId id="259" r:id="rId5"/>
-    <p:sldId id="260" r:id="rId6"/>
-    <p:sldId id="261" r:id="rId7"/>
-    <p:sldId id="262" r:id="rId8"/>
-    <p:sldId id="263" r:id="rId9"/>
-    <p:sldId id="264" r:id="rId10"/>
-    <p:sldId id="265" r:id="rId11"/>
-    <p:sldId id="266" r:id="rId12"/>
-    <p:sldId id="267" r:id="rId13"/>
-    <p:sldId id="268" r:id="rId14"/>
-    <p:sldId id="269" r:id="rId15"/>
+    <p:sldId id="256" r:id="rId7"/>
+    <p:sldId id="257" r:id="rId9"/>
+    <p:sldId id="258" r:id="rId10"/>
+    <p:sldId id="259" r:id="rId11"/>
+    <p:sldId id="260" r:id="rId12"/>
+    <p:sldId id="261" r:id="rId13"/>
+    <p:sldId id="262" r:id="rId14"/>
+    <p:sldId id="263" r:id="rId15"/>
+    <p:sldId id="264" r:id="rId16"/>
+    <p:sldId id="265" r:id="rId17"/>
+    <p:sldId id="266" r:id="rId18"/>
+    <p:sldId id="267" r:id="rId19"/>
+    <p:sldId id="268" r:id="rId20"/>
+    <p:sldId id="269" r:id="rId21"/>
   </p:sldIdLst>
-  <p:sldSz cx="12192000" cy="6858000"/>
+  <p:sldSz cx="12191695" cy="6858000" type="screen4x3"/>
   <p:notesSz cx="6858000" cy="9144000"/>
   <p:defaultTextStyle>
     <a:defPPr>
@@ -120,27 +117,11 @@
       </a:defRPr>
     </a:lvl9pPr>
   </p:defaultTextStyle>
-  <p:extLst>
-    <p:ext uri="{EFAFB233-063F-42B5-8137-9DF3F51BA10A}">
-      <p15:sldGuideLst xmlns:p15="http://schemas.microsoft.com/office/powerpoint/2012/main">
-        <p15:guide id="1" orient="horz" pos="2160">
-          <p15:clr>
-            <a:srgbClr val="A4A3A4"/>
-          </p15:clr>
-        </p15:guide>
-        <p15:guide id="2" pos="2880">
-          <p15:clr>
-            <a:srgbClr val="A4A3A4"/>
-          </p15:clr>
-        </p15:guide>
-      </p15:sldGuideLst>
-    </p:ext>
-  </p:extLst>
 </p:presentation>
 </file>
 
 <file path=ppt/notesMasters/notesMaster1.xml><?xml version="1.0" encoding="utf-8"?>
-<p:notesMaster xmlns:a="http://schemas.openxmlformats.org/drawingml/2006/main" xmlns:r="http://schemas.openxmlformats.org/officeDocument/2006/relationships" xmlns:p="http://schemas.openxmlformats.org/presentationml/2006/main">
+<p:notesMaster xmlns:a="http://schemas.openxmlformats.org/drawingml/2006/main" xmlns:p="http://schemas.openxmlformats.org/presentationml/2006/main" xmlns:r="http://schemas.openxmlformats.org/officeDocument/2006/relationships">
   <p:cSld>
     <p:bg>
       <p:bgRef idx="1001">
@@ -161,16 +142,241 @@
           <a:chExt cx="0" cy="0"/>
         </a:xfrm>
       </p:grpSpPr>
+      <p:sp>
+        <p:nvSpPr>
+          <p:cNvPr id="2" name="Header Placeholder 1"/>
+          <p:cNvSpPr>
+            <a:spLocks noGrp="1"/>
+          </p:cNvSpPr>
+          <p:nvPr>
+            <p:ph type="hdr" sz="quarter"/>
+          </p:nvPr>
+        </p:nvSpPr>
+        <p:spPr>
+          <a:xfrm>
+            <a:off x="0" y="0"/>
+            <a:ext cx="2971800" cy="457200"/>
+          </a:xfrm>
+          <a:prstGeom prst="rect">
+            <a:avLst/>
+          </a:prstGeom>
+        </p:spPr>
+        <p:txBody>
+          <a:bodyPr vert="horz" lIns="91440" tIns="45720" rIns="91440" bIns="45720" rtlCol="0"/>
+          <a:lstStyle>
+            <a:lvl1pPr algn="l">
+              <a:defRPr sz="1200"/>
+            </a:lvl1pPr>
+          </a:lstStyle>
+          <a:p>
+            <a:endParaRPr lang="en-US"/>
+          </a:p>
+        </p:txBody>
+      </p:sp>
+      <p:sp>
+        <p:nvSpPr>
+          <p:cNvPr id="3" name="Date Placeholder 2"/>
+          <p:cNvSpPr>
+            <a:spLocks noGrp="1"/>
+          </p:cNvSpPr>
+          <p:nvPr>
+            <p:ph type="dt" idx="1"/>
+          </p:nvPr>
+        </p:nvSpPr>
+        <p:spPr>
+          <a:xfrm>
+            <a:off x="3884613" y="0"/>
+            <a:ext cx="2971800" cy="457200"/>
+          </a:xfrm>
+          <a:prstGeom prst="rect">
+            <a:avLst/>
+          </a:prstGeom>
+        </p:spPr>
+        <p:txBody>
+          <a:bodyPr vert="horz" lIns="91440" tIns="45720" rIns="91440" bIns="45720" rtlCol="0"/>
+          <a:lstStyle>
+            <a:lvl1pPr algn="r">
+              <a:defRPr sz="1200"/>
+            </a:lvl1pPr>
+          </a:lstStyle>
+          <a:p>
+            <a:fld id="{0F89C1C7-3DCD-1040-A9CF-14679D8B5DDD}" type="datetimeFigureOut">
+              <a:rPr lang="en-US" smtClean="0"/>
+              <a:t>10/17/16</a:t>
+            </a:fld>
+            <a:endParaRPr lang="en-US"/>
+          </a:p>
+        </p:txBody>
+      </p:sp>
+      <p:sp>
+        <p:nvSpPr>
+          <p:cNvPr id="4" name="Slide Image Placeholder 3"/>
+          <p:cNvSpPr>
+            <a:spLocks noGrp="1" noRot="1" noChangeAspect="1"/>
+          </p:cNvSpPr>
+          <p:nvPr>
+            <p:ph type="sldImg" idx="2"/>
+          </p:nvPr>
+        </p:nvSpPr>
+        <p:spPr>
+          <a:xfrm>
+            <a:off x="1143000" y="685800"/>
+            <a:ext cx="4572000" cy="3429000"/>
+          </a:xfrm>
+          <a:prstGeom prst="rect">
+            <a:avLst/>
+          </a:prstGeom>
+          <a:noFill/>
+          <a:ln w="12700">
+            <a:solidFill>
+              <a:prstClr val="black"/>
+            </a:solidFill>
+          </a:ln>
+        </p:spPr>
+        <p:txBody>
+          <a:bodyPr vert="horz" lIns="91440" tIns="45720" rIns="91440" bIns="45720" rtlCol="0" anchor="ctr"/>
+          <a:lstStyle/>
+          <a:p>
+            <a:endParaRPr lang="en-US"/>
+          </a:p>
+        </p:txBody>
+      </p:sp>
+      <p:sp>
+        <p:nvSpPr>
+          <p:cNvPr id="5" name="Notes Placeholder 4"/>
+          <p:cNvSpPr>
+            <a:spLocks noGrp="1"/>
+          </p:cNvSpPr>
+          <p:nvPr>
+            <p:ph type="body" sz="quarter" idx="3"/>
+          </p:nvPr>
+        </p:nvSpPr>
+        <p:spPr>
+          <a:xfrm>
+            <a:off x="685800" y="4343400"/>
+            <a:ext cx="5486400" cy="4114800"/>
+          </a:xfrm>
+          <a:prstGeom prst="rect">
+            <a:avLst/>
+          </a:prstGeom>
+        </p:spPr>
+        <p:txBody>
+          <a:bodyPr vert="horz" lIns="91440" tIns="45720" rIns="91440" bIns="45720" rtlCol="0"/>
+          <a:lstStyle/>
+          <a:p>
+            <a:pPr lvl="0"/>
+            <a:r>
+              <a:rPr lang="en-US" smtClean="0"/>
+              <a:t>Click to edit Master text styles</a:t>
+            </a:r>
+          </a:p>
+          <a:p>
+            <a:pPr lvl="1"/>
+            <a:r>
+              <a:rPr lang="en-US" smtClean="0"/>
+              <a:t>Second level</a:t>
+            </a:r>
+          </a:p>
+          <a:p>
+            <a:pPr lvl="2"/>
+            <a:r>
+              <a:rPr lang="en-US" smtClean="0"/>
+              <a:t>Third level</a:t>
+            </a:r>
+          </a:p>
+          <a:p>
+            <a:pPr lvl="3"/>
+            <a:r>
+              <a:rPr lang="en-US" smtClean="0"/>
+              <a:t>Fourth level</a:t>
+            </a:r>
+          </a:p>
+          <a:p>
+            <a:pPr lvl="4"/>
+            <a:r>
+              <a:rPr lang="en-US" smtClean="0"/>
+              <a:t>Fifth level</a:t>
+            </a:r>
+            <a:endParaRPr lang="en-US"/>
+          </a:p>
+        </p:txBody>
+      </p:sp>
+      <p:sp>
+        <p:nvSpPr>
+          <p:cNvPr id="6" name="Footer Placeholder 5"/>
+          <p:cNvSpPr>
+            <a:spLocks noGrp="1"/>
+          </p:cNvSpPr>
+          <p:nvPr>
+            <p:ph type="ftr" sz="quarter" idx="4"/>
+          </p:nvPr>
+        </p:nvSpPr>
+        <p:spPr>
+          <a:xfrm>
+            <a:off x="0" y="8685213"/>
+            <a:ext cx="2971800" cy="457200"/>
+          </a:xfrm>
+          <a:prstGeom prst="rect">
+            <a:avLst/>
+          </a:prstGeom>
+        </p:spPr>
+        <p:txBody>
+          <a:bodyPr vert="horz" lIns="91440" tIns="45720" rIns="91440" bIns="45720" rtlCol="0" anchor="b"/>
+          <a:lstStyle>
+            <a:lvl1pPr algn="l">
+              <a:defRPr sz="1200"/>
+            </a:lvl1pPr>
+          </a:lstStyle>
+          <a:p>
+            <a:endParaRPr lang="en-US"/>
+          </a:p>
+        </p:txBody>
+      </p:sp>
+      <p:sp>
+        <p:nvSpPr>
+          <p:cNvPr id="7" name="Slide Number Placeholder 6"/>
+          <p:cNvSpPr>
+            <a:spLocks noGrp="1"/>
+          </p:cNvSpPr>
+          <p:nvPr>
+            <p:ph type="sldNum" sz="quarter" idx="5"/>
+          </p:nvPr>
+        </p:nvSpPr>
+        <p:spPr>
+          <a:xfrm>
+            <a:off x="3884613" y="8685213"/>
+            <a:ext cx="2971800" cy="457200"/>
+          </a:xfrm>
+          <a:prstGeom prst="rect">
+            <a:avLst/>
+          </a:prstGeom>
+        </p:spPr>
+        <p:txBody>
+          <a:bodyPr vert="horz" lIns="91440" tIns="45720" rIns="91440" bIns="45720" rtlCol="0" anchor="b"/>
+          <a:lstStyle>
+            <a:lvl1pPr algn="r">
+              <a:defRPr sz="1200"/>
+            </a:lvl1pPr>
+          </a:lstStyle>
+          <a:p>
+            <a:fld id="{BB5E49A5-4136-284D-997B-48E1D791AD67}" type="slidenum">
+              <a:rPr lang="en-US" smtClean="0"/>
+              <a:t>‹#›</a:t>
+            </a:fld>
+            <a:endParaRPr lang="en-US"/>
+          </a:p>
+        </p:txBody>
+      </p:sp>
     </p:spTree>
     <p:extLst>
       <p:ext uri="{BB962C8B-B14F-4D97-AF65-F5344CB8AC3E}">
-        <p14:creationId xmlns:p14="http://schemas.microsoft.com/office/powerpoint/2010/main" val="3412434972"/>
+        <p14:creationId xmlns:p14="http://schemas.microsoft.com/office/powerpoint/2010/main" val="2623252185"/>
       </p:ext>
     </p:extLst>
   </p:cSld>
   <p:clrMap bg1="lt1" tx1="dk1" bg2="lt2" tx2="dk2" accent1="accent1" accent2="accent2" accent3="accent3" accent4="accent4" accent5="accent5" accent6="accent6" hlink="hlink" folHlink="folHlink"/>
   <p:notesStyle>
-    <a:lvl1pPr marL="0" algn="l" defTabSz="914400" rtl="0" eaLnBrk="1" latinLnBrk="0" hangingPunct="1">
+    <a:lvl1pPr marL="0" algn="l" defTabSz="457200" rtl="0" eaLnBrk="1" latinLnBrk="0" hangingPunct="1">
       <a:defRPr sz="1200" kern="1200">
         <a:solidFill>
           <a:schemeClr val="tx1"/>
@@ -180,7 +386,7 @@
         <a:cs typeface="+mn-cs"/>
       </a:defRPr>
     </a:lvl1pPr>
-    <a:lvl2pPr marL="457200" algn="l" defTabSz="914400" rtl="0" eaLnBrk="1" latinLnBrk="0" hangingPunct="1">
+    <a:lvl2pPr marL="457200" algn="l" defTabSz="457200" rtl="0" eaLnBrk="1" latinLnBrk="0" hangingPunct="1">
       <a:defRPr sz="1200" kern="1200">
         <a:solidFill>
           <a:schemeClr val="tx1"/>
@@ -190,7 +396,7 @@
         <a:cs typeface="+mn-cs"/>
       </a:defRPr>
     </a:lvl2pPr>
-    <a:lvl3pPr marL="914400" algn="l" defTabSz="914400" rtl="0" eaLnBrk="1" latinLnBrk="0" hangingPunct="1">
+    <a:lvl3pPr marL="914400" algn="l" defTabSz="457200" rtl="0" eaLnBrk="1" latinLnBrk="0" hangingPunct="1">
       <a:defRPr sz="1200" kern="1200">
         <a:solidFill>
           <a:schemeClr val="tx1"/>
@@ -200,7 +406,7 @@
         <a:cs typeface="+mn-cs"/>
       </a:defRPr>
     </a:lvl3pPr>
-    <a:lvl4pPr marL="1371600" algn="l" defTabSz="914400" rtl="0" eaLnBrk="1" latinLnBrk="0" hangingPunct="1">
+    <a:lvl4pPr marL="1371600" algn="l" defTabSz="457200" rtl="0" eaLnBrk="1" latinLnBrk="0" hangingPunct="1">
       <a:defRPr sz="1200" kern="1200">
         <a:solidFill>
           <a:schemeClr val="tx1"/>
@@ -210,7 +416,7 @@
         <a:cs typeface="+mn-cs"/>
       </a:defRPr>
     </a:lvl4pPr>
-    <a:lvl5pPr marL="1828800" algn="l" defTabSz="914400" rtl="0" eaLnBrk="1" latinLnBrk="0" hangingPunct="1">
+    <a:lvl5pPr marL="1828800" algn="l" defTabSz="457200" rtl="0" eaLnBrk="1" latinLnBrk="0" hangingPunct="1">
       <a:defRPr sz="1200" kern="1200">
         <a:solidFill>
           <a:schemeClr val="tx1"/>
@@ -220,7 +426,7 @@
         <a:cs typeface="+mn-cs"/>
       </a:defRPr>
     </a:lvl5pPr>
-    <a:lvl6pPr marL="2286000" algn="l" defTabSz="914400" rtl="0" eaLnBrk="1" latinLnBrk="0" hangingPunct="1">
+    <a:lvl6pPr marL="2286000" algn="l" defTabSz="457200" rtl="0" eaLnBrk="1" latinLnBrk="0" hangingPunct="1">
       <a:defRPr sz="1200" kern="1200">
         <a:solidFill>
           <a:schemeClr val="tx1"/>
@@ -230,7 +436,7 @@
         <a:cs typeface="+mn-cs"/>
       </a:defRPr>
     </a:lvl6pPr>
-    <a:lvl7pPr marL="2743200" algn="l" defTabSz="914400" rtl="0" eaLnBrk="1" latinLnBrk="0" hangingPunct="1">
+    <a:lvl7pPr marL="2743200" algn="l" defTabSz="457200" rtl="0" eaLnBrk="1" latinLnBrk="0" hangingPunct="1">
       <a:defRPr sz="1200" kern="1200">
         <a:solidFill>
           <a:schemeClr val="tx1"/>
@@ -240,7 +446,7 @@
         <a:cs typeface="+mn-cs"/>
       </a:defRPr>
     </a:lvl7pPr>
-    <a:lvl8pPr marL="3200400" algn="l" defTabSz="914400" rtl="0" eaLnBrk="1" latinLnBrk="0" hangingPunct="1">
+    <a:lvl8pPr marL="3200400" algn="l" defTabSz="457200" rtl="0" eaLnBrk="1" latinLnBrk="0" hangingPunct="1">
       <a:defRPr sz="1200" kern="1200">
         <a:solidFill>
           <a:schemeClr val="tx1"/>
@@ -250,7 +456,7 @@
         <a:cs typeface="+mn-cs"/>
       </a:defRPr>
     </a:lvl8pPr>
-    <a:lvl9pPr marL="3657600" algn="l" defTabSz="914400" rtl="0" eaLnBrk="1" latinLnBrk="0" hangingPunct="1">
+    <a:lvl9pPr marL="3657600" algn="l" defTabSz="457200" rtl="0" eaLnBrk="1" latinLnBrk="0" hangingPunct="1">
       <a:defRPr sz="1200" kern="1200">
         <a:solidFill>
           <a:schemeClr val="tx1"/>
@@ -265,7 +471,7 @@
 </file>
 
 <file path=ppt/notesSlides/notesSlide1.xml><?xml version="1.0" encoding="utf-8"?>
-<p:notes xmlns:a="http://schemas.openxmlformats.org/drawingml/2006/main" xmlns:r="http://schemas.openxmlformats.org/officeDocument/2006/relationships" xmlns:p="http://schemas.openxmlformats.org/presentationml/2006/main">
+<p:notes xmlns:a="http://schemas.openxmlformats.org/drawingml/2006/main" xmlns:p="http://schemas.openxmlformats.org/presentationml/2006/main" xmlns:r="http://schemas.openxmlformats.org/officeDocument/2006/relationships">
   <p:cSld>
     <p:spTree>
       <p:nvGrpSpPr>
@@ -285,7 +491,7 @@
         <p:nvSpPr>
           <p:cNvPr id="2" name="Slide Image Placeholder 1"/>
           <p:cNvSpPr>
-            <a:spLocks noGrp="1" noRot="1" noChangeAspect="1"/>
+            <a:spLocks noGrp="1"/>
           </p:cNvSpPr>
           <p:nvPr>
             <p:ph type="sldImg" idx="2"/>
@@ -300,7 +506,7 @@
             <a:spLocks noGrp="1"/>
           </p:cNvSpPr>
           <p:nvPr>
-            <p:ph type="body" sz="quarter" idx="3"/>
+            <p:ph type="body" idx="3" sz="quarter"/>
           </p:nvPr>
         </p:nvSpPr>
         <p:spPr/>
@@ -321,7 +527,7 @@
             <a:spLocks noGrp="1"/>
           </p:cNvSpPr>
           <p:nvPr>
-            <p:ph type="sldNum" sz="quarter" idx="5"/>
+            <p:ph type="sldNum" idx="5" sz="quarter"/>
           </p:nvPr>
         </p:nvSpPr>
         <p:spPr/>
@@ -335,7 +541,7 @@
 </file>
 
 <file path=ppt/notesSlides/notesSlide10.xml><?xml version="1.0" encoding="utf-8"?>
-<p:notes xmlns:a="http://schemas.openxmlformats.org/drawingml/2006/main" xmlns:r="http://schemas.openxmlformats.org/officeDocument/2006/relationships" xmlns:p="http://schemas.openxmlformats.org/presentationml/2006/main">
+<p:notes xmlns:a="http://schemas.openxmlformats.org/drawingml/2006/main" xmlns:p="http://schemas.openxmlformats.org/presentationml/2006/main" xmlns:r="http://schemas.openxmlformats.org/officeDocument/2006/relationships">
   <p:cSld>
     <p:spTree>
       <p:nvGrpSpPr>
@@ -355,7 +561,7 @@
         <p:nvSpPr>
           <p:cNvPr id="2" name="Slide Image Placeholder 1"/>
           <p:cNvSpPr>
-            <a:spLocks noGrp="1" noRot="1" noChangeAspect="1"/>
+            <a:spLocks noGrp="1"/>
           </p:cNvSpPr>
           <p:nvPr>
             <p:ph type="sldImg" idx="2"/>
@@ -370,7 +576,7 @@
             <a:spLocks noGrp="1"/>
           </p:cNvSpPr>
           <p:nvPr>
-            <p:ph type="body" sz="quarter" idx="3"/>
+            <p:ph type="body" idx="3" sz="quarter"/>
           </p:nvPr>
         </p:nvSpPr>
         <p:spPr/>
@@ -379,7 +585,7 @@
           <a:lstStyle/>
           <a:p>
             <a:r>
-              <a:t>Three ways to pay for this. The numbers are illustrative ranges, not quotes. Option 3 is the kicker for a cost-conscious board: if we have a server with spare capacity, hosting is effectively free — we only spend a little internal time. Even on AWS, we're an order of magnitude below commercial per-seat pricing, and in every case the data stays in-house.</a:t>
+              <a:t>Reframe for ~10k with high availability. The commercial line is per-seat and enormous at scale (~$360-840k/yr). Our cost is infrastructure — even highly available it's ~$18-42k/yr, and it does NOT scale per-device, so the savings gap widens as the fleet grows. Numbers are illustrative ranges pending a formal sizing exercise; be honest about that if pressed.</a:t>
             </a:r>
           </a:p>
         </p:txBody>
@@ -391,7 +597,7 @@
             <a:spLocks noGrp="1"/>
           </p:cNvSpPr>
           <p:nvPr>
-            <p:ph type="sldNum" sz="quarter" idx="5"/>
+            <p:ph type="sldNum" idx="5" sz="quarter"/>
           </p:nvPr>
         </p:nvSpPr>
         <p:spPr/>
@@ -405,7 +611,7 @@
 </file>
 
 <file path=ppt/notesSlides/notesSlide11.xml><?xml version="1.0" encoding="utf-8"?>
-<p:notes xmlns:a="http://schemas.openxmlformats.org/drawingml/2006/main" xmlns:r="http://schemas.openxmlformats.org/officeDocument/2006/relationships" xmlns:p="http://schemas.openxmlformats.org/presentationml/2006/main">
+<p:notes xmlns:a="http://schemas.openxmlformats.org/drawingml/2006/main" xmlns:p="http://schemas.openxmlformats.org/presentationml/2006/main" xmlns:r="http://schemas.openxmlformats.org/officeDocument/2006/relationships">
   <p:cSld>
     <p:spTree>
       <p:nvGrpSpPr>
@@ -425,7 +631,7 @@
         <p:nvSpPr>
           <p:cNvPr id="2" name="Slide Image Placeholder 1"/>
           <p:cNvSpPr>
-            <a:spLocks noGrp="1" noRot="1" noChangeAspect="1"/>
+            <a:spLocks noGrp="1"/>
           </p:cNvSpPr>
           <p:nvPr>
             <p:ph type="sldImg" idx="2"/>
@@ -440,7 +646,7 @@
             <a:spLocks noGrp="1"/>
           </p:cNvSpPr>
           <p:nvPr>
-            <p:ph type="body" sz="quarter" idx="3"/>
+            <p:ph type="body" idx="3" sz="quarter"/>
           </p:nvPr>
         </p:nvSpPr>
         <p:spPr/>
@@ -461,7 +667,7 @@
             <a:spLocks noGrp="1"/>
           </p:cNvSpPr>
           <p:nvPr>
-            <p:ph type="sldNum" sz="quarter" idx="5"/>
+            <p:ph type="sldNum" idx="5" sz="quarter"/>
           </p:nvPr>
         </p:nvSpPr>
         <p:spPr/>
@@ -475,7 +681,7 @@
 </file>
 
 <file path=ppt/notesSlides/notesSlide12.xml><?xml version="1.0" encoding="utf-8"?>
-<p:notes xmlns:a="http://schemas.openxmlformats.org/drawingml/2006/main" xmlns:r="http://schemas.openxmlformats.org/officeDocument/2006/relationships" xmlns:p="http://schemas.openxmlformats.org/presentationml/2006/main">
+<p:notes xmlns:a="http://schemas.openxmlformats.org/drawingml/2006/main" xmlns:p="http://schemas.openxmlformats.org/presentationml/2006/main" xmlns:r="http://schemas.openxmlformats.org/officeDocument/2006/relationships">
   <p:cSld>
     <p:spTree>
       <p:nvGrpSpPr>
@@ -495,7 +701,7 @@
         <p:nvSpPr>
           <p:cNvPr id="2" name="Slide Image Placeholder 1"/>
           <p:cNvSpPr>
-            <a:spLocks noGrp="1" noRot="1" noChangeAspect="1"/>
+            <a:spLocks noGrp="1"/>
           </p:cNvSpPr>
           <p:nvPr>
             <p:ph type="sldImg" idx="2"/>
@@ -510,7 +716,7 @@
             <a:spLocks noGrp="1"/>
           </p:cNvSpPr>
           <p:nvPr>
-            <p:ph type="body" sz="quarter" idx="3"/>
+            <p:ph type="body" idx="3" sz="quarter"/>
           </p:nvPr>
         </p:nvSpPr>
         <p:spPr/>
@@ -531,7 +737,7 @@
             <a:spLocks noGrp="1"/>
           </p:cNvSpPr>
           <p:nvPr>
-            <p:ph type="sldNum" sz="quarter" idx="5"/>
+            <p:ph type="sldNum" idx="5" sz="quarter"/>
           </p:nvPr>
         </p:nvSpPr>
         <p:spPr/>
@@ -545,7 +751,7 @@
 </file>
 
 <file path=ppt/notesSlides/notesSlide13.xml><?xml version="1.0" encoding="utf-8"?>
-<p:notes xmlns:a="http://schemas.openxmlformats.org/drawingml/2006/main" xmlns:r="http://schemas.openxmlformats.org/officeDocument/2006/relationships" xmlns:p="http://schemas.openxmlformats.org/presentationml/2006/main">
+<p:notes xmlns:a="http://schemas.openxmlformats.org/drawingml/2006/main" xmlns:p="http://schemas.openxmlformats.org/presentationml/2006/main" xmlns:r="http://schemas.openxmlformats.org/officeDocument/2006/relationships">
   <p:cSld>
     <p:spTree>
       <p:nvGrpSpPr>
@@ -565,7 +771,7 @@
         <p:nvSpPr>
           <p:cNvPr id="2" name="Slide Image Placeholder 1"/>
           <p:cNvSpPr>
-            <a:spLocks noGrp="1" noRot="1" noChangeAspect="1"/>
+            <a:spLocks noGrp="1"/>
           </p:cNvSpPr>
           <p:nvPr>
             <p:ph type="sldImg" idx="2"/>
@@ -580,7 +786,7 @@
             <a:spLocks noGrp="1"/>
           </p:cNvSpPr>
           <p:nvPr>
-            <p:ph type="body" sz="quarter" idx="3"/>
+            <p:ph type="body" idx="3" sz="quarter"/>
           </p:nvPr>
         </p:nvSpPr>
         <p:spPr/>
@@ -601,7 +807,7 @@
             <a:spLocks noGrp="1"/>
           </p:cNvSpPr>
           <p:nvPr>
-            <p:ph type="sldNum" sz="quarter" idx="5"/>
+            <p:ph type="sldNum" idx="5" sz="quarter"/>
           </p:nvPr>
         </p:nvSpPr>
         <p:spPr/>
@@ -615,7 +821,7 @@
 </file>
 
 <file path=ppt/notesSlides/notesSlide14.xml><?xml version="1.0" encoding="utf-8"?>
-<p:notes xmlns:a="http://schemas.openxmlformats.org/drawingml/2006/main" xmlns:r="http://schemas.openxmlformats.org/officeDocument/2006/relationships" xmlns:p="http://schemas.openxmlformats.org/presentationml/2006/main">
+<p:notes xmlns:a="http://schemas.openxmlformats.org/drawingml/2006/main" xmlns:p="http://schemas.openxmlformats.org/presentationml/2006/main" xmlns:r="http://schemas.openxmlformats.org/officeDocument/2006/relationships">
   <p:cSld>
     <p:spTree>
       <p:nvGrpSpPr>
@@ -635,7 +841,7 @@
         <p:nvSpPr>
           <p:cNvPr id="2" name="Slide Image Placeholder 1"/>
           <p:cNvSpPr>
-            <a:spLocks noGrp="1" noRot="1" noChangeAspect="1"/>
+            <a:spLocks noGrp="1"/>
           </p:cNvSpPr>
           <p:nvPr>
             <p:ph type="sldImg" idx="2"/>
@@ -650,7 +856,7 @@
             <a:spLocks noGrp="1"/>
           </p:cNvSpPr>
           <p:nvPr>
-            <p:ph type="body" sz="quarter" idx="3"/>
+            <p:ph type="body" idx="3" sz="quarter"/>
           </p:nvPr>
         </p:nvSpPr>
         <p:spPr/>
@@ -671,7 +877,7 @@
             <a:spLocks noGrp="1"/>
           </p:cNvSpPr>
           <p:nvPr>
-            <p:ph type="sldNum" sz="quarter" idx="5"/>
+            <p:ph type="sldNum" idx="5" sz="quarter"/>
           </p:nvPr>
         </p:nvSpPr>
         <p:spPr/>
@@ -685,7 +891,7 @@
 </file>
 
 <file path=ppt/notesSlides/notesSlide2.xml><?xml version="1.0" encoding="utf-8"?>
-<p:notes xmlns:a="http://schemas.openxmlformats.org/drawingml/2006/main" xmlns:r="http://schemas.openxmlformats.org/officeDocument/2006/relationships" xmlns:p="http://schemas.openxmlformats.org/presentationml/2006/main">
+<p:notes xmlns:a="http://schemas.openxmlformats.org/drawingml/2006/main" xmlns:p="http://schemas.openxmlformats.org/presentationml/2006/main" xmlns:r="http://schemas.openxmlformats.org/officeDocument/2006/relationships">
   <p:cSld>
     <p:spTree>
       <p:nvGrpSpPr>
@@ -705,7 +911,7 @@
         <p:nvSpPr>
           <p:cNvPr id="2" name="Slide Image Placeholder 1"/>
           <p:cNvSpPr>
-            <a:spLocks noGrp="1" noRot="1" noChangeAspect="1"/>
+            <a:spLocks noGrp="1"/>
           </p:cNvSpPr>
           <p:nvPr>
             <p:ph type="sldImg" idx="2"/>
@@ -720,7 +926,7 @@
             <a:spLocks noGrp="1"/>
           </p:cNvSpPr>
           <p:nvPr>
-            <p:ph type="body" sz="quarter" idx="3"/>
+            <p:ph type="body" idx="3" sz="quarter"/>
           </p:nvPr>
         </p:nvSpPr>
         <p:spPr/>
@@ -741,7 +947,7 @@
             <a:spLocks noGrp="1"/>
           </p:cNvSpPr>
           <p:nvPr>
-            <p:ph type="sldNum" sz="quarter" idx="5"/>
+            <p:ph type="sldNum" idx="5" sz="quarter"/>
           </p:nvPr>
         </p:nvSpPr>
         <p:spPr/>
@@ -755,7 +961,7 @@
 </file>
 
 <file path=ppt/notesSlides/notesSlide3.xml><?xml version="1.0" encoding="utf-8"?>
-<p:notes xmlns:a="http://schemas.openxmlformats.org/drawingml/2006/main" xmlns:r="http://schemas.openxmlformats.org/officeDocument/2006/relationships" xmlns:p="http://schemas.openxmlformats.org/presentationml/2006/main">
+<p:notes xmlns:a="http://schemas.openxmlformats.org/drawingml/2006/main" xmlns:p="http://schemas.openxmlformats.org/presentationml/2006/main" xmlns:r="http://schemas.openxmlformats.org/officeDocument/2006/relationships">
   <p:cSld>
     <p:spTree>
       <p:nvGrpSpPr>
@@ -775,7 +981,7 @@
         <p:nvSpPr>
           <p:cNvPr id="2" name="Slide Image Placeholder 1"/>
           <p:cNvSpPr>
-            <a:spLocks noGrp="1" noRot="1" noChangeAspect="1"/>
+            <a:spLocks noGrp="1"/>
           </p:cNvSpPr>
           <p:nvPr>
             <p:ph type="sldImg" idx="2"/>
@@ -790,7 +996,7 @@
             <a:spLocks noGrp="1"/>
           </p:cNvSpPr>
           <p:nvPr>
-            <p:ph type="body" sz="quarter" idx="3"/>
+            <p:ph type="body" idx="3" sz="quarter"/>
           </p:nvPr>
         </p:nvSpPr>
         <p:spPr/>
@@ -811,7 +1017,7 @@
             <a:spLocks noGrp="1"/>
           </p:cNvSpPr>
           <p:nvPr>
-            <p:ph type="sldNum" sz="quarter" idx="5"/>
+            <p:ph type="sldNum" idx="5" sz="quarter"/>
           </p:nvPr>
         </p:nvSpPr>
         <p:spPr/>
@@ -825,7 +1031,7 @@
 </file>
 
 <file path=ppt/notesSlides/notesSlide4.xml><?xml version="1.0" encoding="utf-8"?>
-<p:notes xmlns:a="http://schemas.openxmlformats.org/drawingml/2006/main" xmlns:r="http://schemas.openxmlformats.org/officeDocument/2006/relationships" xmlns:p="http://schemas.openxmlformats.org/presentationml/2006/main">
+<p:notes xmlns:a="http://schemas.openxmlformats.org/drawingml/2006/main" xmlns:p="http://schemas.openxmlformats.org/presentationml/2006/main" xmlns:r="http://schemas.openxmlformats.org/officeDocument/2006/relationships">
   <p:cSld>
     <p:spTree>
       <p:nvGrpSpPr>
@@ -845,7 +1051,7 @@
         <p:nvSpPr>
           <p:cNvPr id="2" name="Slide Image Placeholder 1"/>
           <p:cNvSpPr>
-            <a:spLocks noGrp="1" noRot="1" noChangeAspect="1"/>
+            <a:spLocks noGrp="1"/>
           </p:cNvSpPr>
           <p:nvPr>
             <p:ph type="sldImg" idx="2"/>
@@ -860,7 +1066,7 @@
             <a:spLocks noGrp="1"/>
           </p:cNvSpPr>
           <p:nvPr>
-            <p:ph type="body" sz="quarter" idx="3"/>
+            <p:ph type="body" idx="3" sz="quarter"/>
           </p:nvPr>
         </p:nvSpPr>
         <p:spPr/>
@@ -881,7 +1087,7 @@
             <a:spLocks noGrp="1"/>
           </p:cNvSpPr>
           <p:nvPr>
-            <p:ph type="sldNum" sz="quarter" idx="5"/>
+            <p:ph type="sldNum" idx="5" sz="quarter"/>
           </p:nvPr>
         </p:nvSpPr>
         <p:spPr/>
@@ -895,7 +1101,7 @@
 </file>
 
 <file path=ppt/notesSlides/notesSlide5.xml><?xml version="1.0" encoding="utf-8"?>
-<p:notes xmlns:a="http://schemas.openxmlformats.org/drawingml/2006/main" xmlns:r="http://schemas.openxmlformats.org/officeDocument/2006/relationships" xmlns:p="http://schemas.openxmlformats.org/presentationml/2006/main">
+<p:notes xmlns:a="http://schemas.openxmlformats.org/drawingml/2006/main" xmlns:p="http://schemas.openxmlformats.org/presentationml/2006/main" xmlns:r="http://schemas.openxmlformats.org/officeDocument/2006/relationships">
   <p:cSld>
     <p:spTree>
       <p:nvGrpSpPr>
@@ -915,7 +1121,7 @@
         <p:nvSpPr>
           <p:cNvPr id="2" name="Slide Image Placeholder 1"/>
           <p:cNvSpPr>
-            <a:spLocks noGrp="1" noRot="1" noChangeAspect="1"/>
+            <a:spLocks noGrp="1"/>
           </p:cNvSpPr>
           <p:nvPr>
             <p:ph type="sldImg" idx="2"/>
@@ -930,7 +1136,7 @@
             <a:spLocks noGrp="1"/>
           </p:cNvSpPr>
           <p:nvPr>
-            <p:ph type="body" sz="quarter" idx="3"/>
+            <p:ph type="body" idx="3" sz="quarter"/>
           </p:nvPr>
         </p:nvSpPr>
         <p:spPr/>
@@ -951,7 +1157,7 @@
             <a:spLocks noGrp="1"/>
           </p:cNvSpPr>
           <p:nvPr>
-            <p:ph type="sldNum" sz="quarter" idx="5"/>
+            <p:ph type="sldNum" idx="5" sz="quarter"/>
           </p:nvPr>
         </p:nvSpPr>
         <p:spPr/>
@@ -965,7 +1171,7 @@
 </file>
 
 <file path=ppt/notesSlides/notesSlide6.xml><?xml version="1.0" encoding="utf-8"?>
-<p:notes xmlns:a="http://schemas.openxmlformats.org/drawingml/2006/main" xmlns:r="http://schemas.openxmlformats.org/officeDocument/2006/relationships" xmlns:p="http://schemas.openxmlformats.org/presentationml/2006/main">
+<p:notes xmlns:a="http://schemas.openxmlformats.org/drawingml/2006/main" xmlns:p="http://schemas.openxmlformats.org/presentationml/2006/main" xmlns:r="http://schemas.openxmlformats.org/officeDocument/2006/relationships">
   <p:cSld>
     <p:spTree>
       <p:nvGrpSpPr>
@@ -985,7 +1191,7 @@
         <p:nvSpPr>
           <p:cNvPr id="2" name="Slide Image Placeholder 1"/>
           <p:cNvSpPr>
-            <a:spLocks noGrp="1" noRot="1" noChangeAspect="1"/>
+            <a:spLocks noGrp="1"/>
           </p:cNvSpPr>
           <p:nvPr>
             <p:ph type="sldImg" idx="2"/>
@@ -1000,7 +1206,7 @@
             <a:spLocks noGrp="1"/>
           </p:cNvSpPr>
           <p:nvPr>
-            <p:ph type="body" sz="quarter" idx="3"/>
+            <p:ph type="body" idx="3" sz="quarter"/>
           </p:nvPr>
         </p:nvSpPr>
         <p:spPr/>
@@ -1021,7 +1227,7 @@
             <a:spLocks noGrp="1"/>
           </p:cNvSpPr>
           <p:nvPr>
-            <p:ph type="sldNum" sz="quarter" idx="5"/>
+            <p:ph type="sldNum" idx="5" sz="quarter"/>
           </p:nvPr>
         </p:nvSpPr>
         <p:spPr/>
@@ -1035,7 +1241,7 @@
 </file>
 
 <file path=ppt/notesSlides/notesSlide7.xml><?xml version="1.0" encoding="utf-8"?>
-<p:notes xmlns:a="http://schemas.openxmlformats.org/drawingml/2006/main" xmlns:r="http://schemas.openxmlformats.org/officeDocument/2006/relationships" xmlns:p="http://schemas.openxmlformats.org/presentationml/2006/main">
+<p:notes xmlns:a="http://schemas.openxmlformats.org/drawingml/2006/main" xmlns:p="http://schemas.openxmlformats.org/presentationml/2006/main" xmlns:r="http://schemas.openxmlformats.org/officeDocument/2006/relationships">
   <p:cSld>
     <p:spTree>
       <p:nvGrpSpPr>
@@ -1055,7 +1261,7 @@
         <p:nvSpPr>
           <p:cNvPr id="2" name="Slide Image Placeholder 1"/>
           <p:cNvSpPr>
-            <a:spLocks noGrp="1" noRot="1" noChangeAspect="1"/>
+            <a:spLocks noGrp="1"/>
           </p:cNvSpPr>
           <p:nvPr>
             <p:ph type="sldImg" idx="2"/>
@@ -1070,7 +1276,7 @@
             <a:spLocks noGrp="1"/>
           </p:cNvSpPr>
           <p:nvPr>
-            <p:ph type="body" sz="quarter" idx="3"/>
+            <p:ph type="body" idx="3" sz="quarter"/>
           </p:nvPr>
         </p:nvSpPr>
         <p:spPr/>
@@ -1091,7 +1297,7 @@
             <a:spLocks noGrp="1"/>
           </p:cNvSpPr>
           <p:nvPr>
-            <p:ph type="sldNum" sz="quarter" idx="5"/>
+            <p:ph type="sldNum" idx="5" sz="quarter"/>
           </p:nvPr>
         </p:nvSpPr>
         <p:spPr/>
@@ -1105,7 +1311,7 @@
 </file>
 
 <file path=ppt/notesSlides/notesSlide8.xml><?xml version="1.0" encoding="utf-8"?>
-<p:notes xmlns:a="http://schemas.openxmlformats.org/drawingml/2006/main" xmlns:r="http://schemas.openxmlformats.org/officeDocument/2006/relationships" xmlns:p="http://schemas.openxmlformats.org/presentationml/2006/main">
+<p:notes xmlns:a="http://schemas.openxmlformats.org/drawingml/2006/main" xmlns:p="http://schemas.openxmlformats.org/presentationml/2006/main" xmlns:r="http://schemas.openxmlformats.org/officeDocument/2006/relationships">
   <p:cSld>
     <p:spTree>
       <p:nvGrpSpPr>
@@ -1125,7 +1331,7 @@
         <p:nvSpPr>
           <p:cNvPr id="2" name="Slide Image Placeholder 1"/>
           <p:cNvSpPr>
-            <a:spLocks noGrp="1" noRot="1" noChangeAspect="1"/>
+            <a:spLocks noGrp="1"/>
           </p:cNvSpPr>
           <p:nvPr>
             <p:ph type="sldImg" idx="2"/>
@@ -1140,7 +1346,7 @@
             <a:spLocks noGrp="1"/>
           </p:cNvSpPr>
           <p:nvPr>
-            <p:ph type="body" sz="quarter" idx="3"/>
+            <p:ph type="body" idx="3" sz="quarter"/>
           </p:nvPr>
         </p:nvSpPr>
         <p:spPr/>
@@ -1161,7 +1367,7 @@
             <a:spLocks noGrp="1"/>
           </p:cNvSpPr>
           <p:nvPr>
-            <p:ph type="sldNum" sz="quarter" idx="5"/>
+            <p:ph type="sldNum" idx="5" sz="quarter"/>
           </p:nvPr>
         </p:nvSpPr>
         <p:spPr/>
@@ -1175,7 +1381,7 @@
 </file>
 
 <file path=ppt/notesSlides/notesSlide9.xml><?xml version="1.0" encoding="utf-8"?>
-<p:notes xmlns:a="http://schemas.openxmlformats.org/drawingml/2006/main" xmlns:r="http://schemas.openxmlformats.org/officeDocument/2006/relationships" xmlns:p="http://schemas.openxmlformats.org/presentationml/2006/main">
+<p:notes xmlns:a="http://schemas.openxmlformats.org/drawingml/2006/main" xmlns:p="http://schemas.openxmlformats.org/presentationml/2006/main" xmlns:r="http://schemas.openxmlformats.org/officeDocument/2006/relationships">
   <p:cSld>
     <p:spTree>
       <p:nvGrpSpPr>
@@ -1195,7 +1401,7 @@
         <p:nvSpPr>
           <p:cNvPr id="2" name="Slide Image Placeholder 1"/>
           <p:cNvSpPr>
-            <a:spLocks noGrp="1" noRot="1" noChangeAspect="1"/>
+            <a:spLocks noGrp="1"/>
           </p:cNvSpPr>
           <p:nvPr>
             <p:ph type="sldImg" idx="2"/>
@@ -1210,7 +1416,7 @@
             <a:spLocks noGrp="1"/>
           </p:cNvSpPr>
           <p:nvPr>
-            <p:ph type="body" sz="quarter" idx="3"/>
+            <p:ph type="body" idx="3" sz="quarter"/>
           </p:nvPr>
         </p:nvSpPr>
         <p:spPr/>
@@ -1231,7 +1437,7 @@
             <a:spLocks noGrp="1"/>
           </p:cNvSpPr>
           <p:nvPr>
-            <p:ph type="sldNum" sz="quarter" idx="5"/>
+            <p:ph type="sldNum" idx="5" sz="quarter"/>
           </p:nvPr>
         </p:nvSpPr>
         <p:spPr/>
@@ -1282,9 +1488,10 @@
           <a:lstStyle/>
           <a:p>
             <a:r>
-              <a:rPr lang="en-US"/>
+              <a:rPr lang="en-US" smtClean="0"/>
               <a:t>Click to edit Master title style</a:t>
             </a:r>
+            <a:endParaRPr lang="en-US"/>
           </a:p>
         </p:txBody>
       </p:sp>
@@ -1400,9 +1607,10 @@
           </a:lstStyle>
           <a:p>
             <a:r>
-              <a:rPr lang="en-US"/>
+              <a:rPr lang="en-US" smtClean="0"/>
               <a:t>Click to edit Master subtitle style</a:t>
             </a:r>
+            <a:endParaRPr lang="en-US"/>
           </a:p>
         </p:txBody>
       </p:sp>
@@ -1423,7 +1631,7 @@
           <a:p>
             <a:fld id="{5BCAD085-E8A6-8845-BD4E-CB4CCA059FC4}" type="datetimeFigureOut">
               <a:rPr lang="en-US" smtClean="0"/>
-              <a:t>6/21/26</a:t>
+              <a:t>1/27/13</a:t>
             </a:fld>
             <a:endParaRPr lang="en-US"/>
           </a:p>
@@ -1517,9 +1725,10 @@
           <a:lstStyle/>
           <a:p>
             <a:r>
-              <a:rPr lang="en-US"/>
+              <a:rPr lang="en-US" smtClean="0"/>
               <a:t>Click to edit Master title style</a:t>
             </a:r>
+            <a:endParaRPr lang="en-US"/>
           </a:p>
         </p:txBody>
       </p:sp>
@@ -1540,37 +1749,38 @@
           <a:p>
             <a:pPr lvl="0"/>
             <a:r>
-              <a:rPr lang="en-US"/>
+              <a:rPr lang="en-US" smtClean="0"/>
               <a:t>Click to edit Master text styles</a:t>
             </a:r>
           </a:p>
           <a:p>
             <a:pPr lvl="1"/>
             <a:r>
-              <a:rPr lang="en-US"/>
+              <a:rPr lang="en-US" smtClean="0"/>
               <a:t>Second level</a:t>
             </a:r>
           </a:p>
           <a:p>
             <a:pPr lvl="2"/>
             <a:r>
-              <a:rPr lang="en-US"/>
+              <a:rPr lang="en-US" smtClean="0"/>
               <a:t>Third level</a:t>
             </a:r>
           </a:p>
           <a:p>
             <a:pPr lvl="3"/>
             <a:r>
-              <a:rPr lang="en-US"/>
+              <a:rPr lang="en-US" smtClean="0"/>
               <a:t>Fourth level</a:t>
             </a:r>
           </a:p>
           <a:p>
             <a:pPr lvl="4"/>
             <a:r>
-              <a:rPr lang="en-US"/>
+              <a:rPr lang="en-US" smtClean="0"/>
               <a:t>Fifth level</a:t>
             </a:r>
+            <a:endParaRPr lang="en-US"/>
           </a:p>
         </p:txBody>
       </p:sp>
@@ -1591,7 +1801,7 @@
           <a:p>
             <a:fld id="{5BCAD085-E8A6-8845-BD4E-CB4CCA059FC4}" type="datetimeFigureOut">
               <a:rPr lang="en-US" smtClean="0"/>
-              <a:t>6/21/26</a:t>
+              <a:t>1/27/13</a:t>
             </a:fld>
             <a:endParaRPr lang="en-US"/>
           </a:p>
@@ -1690,9 +1900,10 @@
           <a:lstStyle/>
           <a:p>
             <a:r>
-              <a:rPr lang="en-US"/>
+              <a:rPr lang="en-US" smtClean="0"/>
               <a:t>Click to edit Master title style</a:t>
             </a:r>
+            <a:endParaRPr lang="en-US"/>
           </a:p>
         </p:txBody>
       </p:sp>
@@ -1718,37 +1929,38 @@
           <a:p>
             <a:pPr lvl="0"/>
             <a:r>
-              <a:rPr lang="en-US"/>
+              <a:rPr lang="en-US" smtClean="0"/>
               <a:t>Click to edit Master text styles</a:t>
             </a:r>
           </a:p>
           <a:p>
             <a:pPr lvl="1"/>
             <a:r>
-              <a:rPr lang="en-US"/>
+              <a:rPr lang="en-US" smtClean="0"/>
               <a:t>Second level</a:t>
             </a:r>
           </a:p>
           <a:p>
             <a:pPr lvl="2"/>
             <a:r>
-              <a:rPr lang="en-US"/>
+              <a:rPr lang="en-US" smtClean="0"/>
               <a:t>Third level</a:t>
             </a:r>
           </a:p>
           <a:p>
             <a:pPr lvl="3"/>
             <a:r>
-              <a:rPr lang="en-US"/>
+              <a:rPr lang="en-US" smtClean="0"/>
               <a:t>Fourth level</a:t>
             </a:r>
           </a:p>
           <a:p>
             <a:pPr lvl="4"/>
             <a:r>
-              <a:rPr lang="en-US"/>
+              <a:rPr lang="en-US" smtClean="0"/>
               <a:t>Fifth level</a:t>
             </a:r>
+            <a:endParaRPr lang="en-US"/>
           </a:p>
         </p:txBody>
       </p:sp>
@@ -1769,7 +1981,7 @@
           <a:p>
             <a:fld id="{5BCAD085-E8A6-8845-BD4E-CB4CCA059FC4}" type="datetimeFigureOut">
               <a:rPr lang="en-US" smtClean="0"/>
-              <a:t>6/21/26</a:t>
+              <a:t>1/27/13</a:t>
             </a:fld>
             <a:endParaRPr lang="en-US"/>
           </a:p>
@@ -1863,9 +2075,10 @@
           <a:lstStyle/>
           <a:p>
             <a:r>
-              <a:rPr lang="en-US"/>
+              <a:rPr lang="en-US" smtClean="0"/>
               <a:t>Click to edit Master title style</a:t>
             </a:r>
+            <a:endParaRPr lang="en-US"/>
           </a:p>
         </p:txBody>
       </p:sp>
@@ -1886,37 +2099,38 @@
           <a:p>
             <a:pPr lvl="0"/>
             <a:r>
-              <a:rPr lang="en-US"/>
+              <a:rPr lang="en-US" smtClean="0"/>
               <a:t>Click to edit Master text styles</a:t>
             </a:r>
           </a:p>
           <a:p>
             <a:pPr lvl="1"/>
             <a:r>
-              <a:rPr lang="en-US"/>
+              <a:rPr lang="en-US" smtClean="0"/>
               <a:t>Second level</a:t>
             </a:r>
           </a:p>
           <a:p>
             <a:pPr lvl="2"/>
             <a:r>
-              <a:rPr lang="en-US"/>
+              <a:rPr lang="en-US" smtClean="0"/>
               <a:t>Third level</a:t>
             </a:r>
           </a:p>
           <a:p>
             <a:pPr lvl="3"/>
             <a:r>
-              <a:rPr lang="en-US"/>
+              <a:rPr lang="en-US" smtClean="0"/>
               <a:t>Fourth level</a:t>
             </a:r>
           </a:p>
           <a:p>
             <a:pPr lvl="4"/>
             <a:r>
-              <a:rPr lang="en-US"/>
+              <a:rPr lang="en-US" smtClean="0"/>
               <a:t>Fifth level</a:t>
             </a:r>
+            <a:endParaRPr lang="en-US"/>
           </a:p>
         </p:txBody>
       </p:sp>
@@ -1937,7 +2151,7 @@
           <a:p>
             <a:fld id="{5BCAD085-E8A6-8845-BD4E-CB4CCA059FC4}" type="datetimeFigureOut">
               <a:rPr lang="en-US" smtClean="0"/>
-              <a:t>6/21/26</a:t>
+              <a:t>1/27/13</a:t>
             </a:fld>
             <a:endParaRPr lang="en-US"/>
           </a:p>
@@ -2040,9 +2254,10 @@
           </a:lstStyle>
           <a:p>
             <a:r>
-              <a:rPr lang="en-US"/>
+              <a:rPr lang="en-US" smtClean="0"/>
               <a:t>Click to edit Master title style</a:t>
             </a:r>
+            <a:endParaRPr lang="en-US"/>
           </a:p>
         </p:txBody>
       </p:sp>
@@ -2159,7 +2374,7 @@
           <a:p>
             <a:pPr lvl="0"/>
             <a:r>
-              <a:rPr lang="en-US"/>
+              <a:rPr lang="en-US" smtClean="0"/>
               <a:t>Click to edit Master text styles</a:t>
             </a:r>
           </a:p>
@@ -2182,7 +2397,7 @@
           <a:p>
             <a:fld id="{5BCAD085-E8A6-8845-BD4E-CB4CCA059FC4}" type="datetimeFigureOut">
               <a:rPr lang="en-US" smtClean="0"/>
-              <a:t>6/21/26</a:t>
+              <a:t>1/27/13</a:t>
             </a:fld>
             <a:endParaRPr lang="en-US"/>
           </a:p>
@@ -2276,9 +2491,10 @@
           <a:lstStyle/>
           <a:p>
             <a:r>
-              <a:rPr lang="en-US"/>
+              <a:rPr lang="en-US" smtClean="0"/>
               <a:t>Click to edit Master title style</a:t>
             </a:r>
+            <a:endParaRPr lang="en-US"/>
           </a:p>
         </p:txBody>
       </p:sp>
@@ -2332,37 +2548,38 @@
           <a:p>
             <a:pPr lvl="0"/>
             <a:r>
-              <a:rPr lang="en-US"/>
+              <a:rPr lang="en-US" smtClean="0"/>
               <a:t>Click to edit Master text styles</a:t>
             </a:r>
           </a:p>
           <a:p>
             <a:pPr lvl="1"/>
             <a:r>
-              <a:rPr lang="en-US"/>
+              <a:rPr lang="en-US" smtClean="0"/>
               <a:t>Second level</a:t>
             </a:r>
           </a:p>
           <a:p>
             <a:pPr lvl="2"/>
             <a:r>
-              <a:rPr lang="en-US"/>
+              <a:rPr lang="en-US" smtClean="0"/>
               <a:t>Third level</a:t>
             </a:r>
           </a:p>
           <a:p>
             <a:pPr lvl="3"/>
             <a:r>
-              <a:rPr lang="en-US"/>
+              <a:rPr lang="en-US" smtClean="0"/>
               <a:t>Fourth level</a:t>
             </a:r>
           </a:p>
           <a:p>
             <a:pPr lvl="4"/>
             <a:r>
-              <a:rPr lang="en-US"/>
+              <a:rPr lang="en-US" smtClean="0"/>
               <a:t>Fifth level</a:t>
             </a:r>
+            <a:endParaRPr lang="en-US"/>
           </a:p>
         </p:txBody>
       </p:sp>
@@ -2416,37 +2633,38 @@
           <a:p>
             <a:pPr lvl="0"/>
             <a:r>
-              <a:rPr lang="en-US"/>
+              <a:rPr lang="en-US" smtClean="0"/>
               <a:t>Click to edit Master text styles</a:t>
             </a:r>
           </a:p>
           <a:p>
             <a:pPr lvl="1"/>
             <a:r>
-              <a:rPr lang="en-US"/>
+              <a:rPr lang="en-US" smtClean="0"/>
               <a:t>Second level</a:t>
             </a:r>
           </a:p>
           <a:p>
             <a:pPr lvl="2"/>
             <a:r>
-              <a:rPr lang="en-US"/>
+              <a:rPr lang="en-US" smtClean="0"/>
               <a:t>Third level</a:t>
             </a:r>
           </a:p>
           <a:p>
             <a:pPr lvl="3"/>
             <a:r>
-              <a:rPr lang="en-US"/>
+              <a:rPr lang="en-US" smtClean="0"/>
               <a:t>Fourth level</a:t>
             </a:r>
           </a:p>
           <a:p>
             <a:pPr lvl="4"/>
             <a:r>
-              <a:rPr lang="en-US"/>
+              <a:rPr lang="en-US" smtClean="0"/>
               <a:t>Fifth level</a:t>
             </a:r>
+            <a:endParaRPr lang="en-US"/>
           </a:p>
         </p:txBody>
       </p:sp>
@@ -2467,7 +2685,7 @@
           <a:p>
             <a:fld id="{5BCAD085-E8A6-8845-BD4E-CB4CCA059FC4}" type="datetimeFigureOut">
               <a:rPr lang="en-US" smtClean="0"/>
-              <a:t>6/21/26</a:t>
+              <a:t>1/27/13</a:t>
             </a:fld>
             <a:endParaRPr lang="en-US"/>
           </a:p>
@@ -2565,9 +2783,10 @@
           </a:lstStyle>
           <a:p>
             <a:r>
-              <a:rPr lang="en-US"/>
+              <a:rPr lang="en-US" smtClean="0"/>
               <a:t>Click to edit Master title style</a:t>
             </a:r>
+            <a:endParaRPr lang="en-US"/>
           </a:p>
         </p:txBody>
       </p:sp>
@@ -2630,7 +2849,7 @@
           <a:p>
             <a:pPr lvl="0"/>
             <a:r>
-              <a:rPr lang="en-US"/>
+              <a:rPr lang="en-US" smtClean="0"/>
               <a:t>Click to edit Master text styles</a:t>
             </a:r>
           </a:p>
@@ -2686,37 +2905,38 @@
           <a:p>
             <a:pPr lvl="0"/>
             <a:r>
-              <a:rPr lang="en-US"/>
+              <a:rPr lang="en-US" smtClean="0"/>
               <a:t>Click to edit Master text styles</a:t>
             </a:r>
           </a:p>
           <a:p>
             <a:pPr lvl="1"/>
             <a:r>
-              <a:rPr lang="en-US"/>
+              <a:rPr lang="en-US" smtClean="0"/>
               <a:t>Second level</a:t>
             </a:r>
           </a:p>
           <a:p>
             <a:pPr lvl="2"/>
             <a:r>
-              <a:rPr lang="en-US"/>
+              <a:rPr lang="en-US" smtClean="0"/>
               <a:t>Third level</a:t>
             </a:r>
           </a:p>
           <a:p>
             <a:pPr lvl="3"/>
             <a:r>
-              <a:rPr lang="en-US"/>
+              <a:rPr lang="en-US" smtClean="0"/>
               <a:t>Fourth level</a:t>
             </a:r>
           </a:p>
           <a:p>
             <a:pPr lvl="4"/>
             <a:r>
-              <a:rPr lang="en-US"/>
+              <a:rPr lang="en-US" smtClean="0"/>
               <a:t>Fifth level</a:t>
             </a:r>
+            <a:endParaRPr lang="en-US"/>
           </a:p>
         </p:txBody>
       </p:sp>
@@ -2779,7 +2999,7 @@
           <a:p>
             <a:pPr lvl="0"/>
             <a:r>
-              <a:rPr lang="en-US"/>
+              <a:rPr lang="en-US" smtClean="0"/>
               <a:t>Click to edit Master text styles</a:t>
             </a:r>
           </a:p>
@@ -2835,37 +3055,38 @@
           <a:p>
             <a:pPr lvl="0"/>
             <a:r>
-              <a:rPr lang="en-US"/>
+              <a:rPr lang="en-US" smtClean="0"/>
               <a:t>Click to edit Master text styles</a:t>
             </a:r>
           </a:p>
           <a:p>
             <a:pPr lvl="1"/>
             <a:r>
-              <a:rPr lang="en-US"/>
+              <a:rPr lang="en-US" smtClean="0"/>
               <a:t>Second level</a:t>
             </a:r>
           </a:p>
           <a:p>
             <a:pPr lvl="2"/>
             <a:r>
-              <a:rPr lang="en-US"/>
+              <a:rPr lang="en-US" smtClean="0"/>
               <a:t>Third level</a:t>
             </a:r>
           </a:p>
           <a:p>
             <a:pPr lvl="3"/>
             <a:r>
-              <a:rPr lang="en-US"/>
+              <a:rPr lang="en-US" smtClean="0"/>
               <a:t>Fourth level</a:t>
             </a:r>
           </a:p>
           <a:p>
             <a:pPr lvl="4"/>
             <a:r>
-              <a:rPr lang="en-US"/>
+              <a:rPr lang="en-US" smtClean="0"/>
               <a:t>Fifth level</a:t>
             </a:r>
+            <a:endParaRPr lang="en-US"/>
           </a:p>
         </p:txBody>
       </p:sp>
@@ -2886,7 +3107,7 @@
           <a:p>
             <a:fld id="{5BCAD085-E8A6-8845-BD4E-CB4CCA059FC4}" type="datetimeFigureOut">
               <a:rPr lang="en-US" smtClean="0"/>
-              <a:t>6/21/26</a:t>
+              <a:t>1/27/13</a:t>
             </a:fld>
             <a:endParaRPr lang="en-US"/>
           </a:p>
@@ -2980,9 +3201,10 @@
           <a:lstStyle/>
           <a:p>
             <a:r>
-              <a:rPr lang="en-US"/>
+              <a:rPr lang="en-US" smtClean="0"/>
               <a:t>Click to edit Master title style</a:t>
             </a:r>
+            <a:endParaRPr lang="en-US"/>
           </a:p>
         </p:txBody>
       </p:sp>
@@ -3003,7 +3225,7 @@
           <a:p>
             <a:fld id="{5BCAD085-E8A6-8845-BD4E-CB4CCA059FC4}" type="datetimeFigureOut">
               <a:rPr lang="en-US" smtClean="0"/>
-              <a:t>6/21/26</a:t>
+              <a:t>1/27/13</a:t>
             </a:fld>
             <a:endParaRPr lang="en-US"/>
           </a:p>
@@ -3098,7 +3320,7 @@
           <a:p>
             <a:fld id="{5BCAD085-E8A6-8845-BD4E-CB4CCA059FC4}" type="datetimeFigureOut">
               <a:rPr lang="en-US" smtClean="0"/>
-              <a:t>6/21/26</a:t>
+              <a:t>1/27/13</a:t>
             </a:fld>
             <a:endParaRPr lang="en-US"/>
           </a:p>
@@ -3201,9 +3423,10 @@
           </a:lstStyle>
           <a:p>
             <a:r>
-              <a:rPr lang="en-US"/>
+              <a:rPr lang="en-US" smtClean="0"/>
               <a:t>Click to edit Master title style</a:t>
             </a:r>
+            <a:endParaRPr lang="en-US"/>
           </a:p>
         </p:txBody>
       </p:sp>
@@ -3257,37 +3480,38 @@
           <a:p>
             <a:pPr lvl="0"/>
             <a:r>
-              <a:rPr lang="en-US"/>
+              <a:rPr lang="en-US" smtClean="0"/>
               <a:t>Click to edit Master text styles</a:t>
             </a:r>
           </a:p>
           <a:p>
             <a:pPr lvl="1"/>
             <a:r>
-              <a:rPr lang="en-US"/>
+              <a:rPr lang="en-US" smtClean="0"/>
               <a:t>Second level</a:t>
             </a:r>
           </a:p>
           <a:p>
             <a:pPr lvl="2"/>
             <a:r>
-              <a:rPr lang="en-US"/>
+              <a:rPr lang="en-US" smtClean="0"/>
               <a:t>Third level</a:t>
             </a:r>
           </a:p>
           <a:p>
             <a:pPr lvl="3"/>
             <a:r>
-              <a:rPr lang="en-US"/>
+              <a:rPr lang="en-US" smtClean="0"/>
               <a:t>Fourth level</a:t>
             </a:r>
           </a:p>
           <a:p>
             <a:pPr lvl="4"/>
             <a:r>
-              <a:rPr lang="en-US"/>
+              <a:rPr lang="en-US" smtClean="0"/>
               <a:t>Fifth level</a:t>
             </a:r>
+            <a:endParaRPr lang="en-US"/>
           </a:p>
         </p:txBody>
       </p:sp>
@@ -3350,7 +3574,7 @@
           <a:p>
             <a:pPr lvl="0"/>
             <a:r>
-              <a:rPr lang="en-US"/>
+              <a:rPr lang="en-US" smtClean="0"/>
               <a:t>Click to edit Master text styles</a:t>
             </a:r>
           </a:p>
@@ -3373,7 +3597,7 @@
           <a:p>
             <a:fld id="{5BCAD085-E8A6-8845-BD4E-CB4CCA059FC4}" type="datetimeFigureOut">
               <a:rPr lang="en-US" smtClean="0"/>
-              <a:t>6/21/26</a:t>
+              <a:t>1/27/13</a:t>
             </a:fld>
             <a:endParaRPr lang="en-US"/>
           </a:p>
@@ -3476,9 +3700,10 @@
           </a:lstStyle>
           <a:p>
             <a:r>
-              <a:rPr lang="en-US"/>
+              <a:rPr lang="en-US" smtClean="0"/>
               <a:t>Click to edit Master title style</a:t>
             </a:r>
+            <a:endParaRPr lang="en-US"/>
           </a:p>
         </p:txBody>
       </p:sp>
@@ -3602,7 +3827,7 @@
           <a:p>
             <a:pPr lvl="0"/>
             <a:r>
-              <a:rPr lang="en-US"/>
+              <a:rPr lang="en-US" smtClean="0"/>
               <a:t>Click to edit Master text styles</a:t>
             </a:r>
           </a:p>
@@ -3625,7 +3850,7 @@
           <a:p>
             <a:fld id="{5BCAD085-E8A6-8845-BD4E-CB4CCA059FC4}" type="datetimeFigureOut">
               <a:rPr lang="en-US" smtClean="0"/>
-              <a:t>6/21/26</a:t>
+              <a:t>1/27/13</a:t>
             </a:fld>
             <a:endParaRPr lang="en-US"/>
           </a:p>
@@ -3734,9 +3959,10 @@
           <a:lstStyle/>
           <a:p>
             <a:r>
-              <a:rPr lang="en-US"/>
+              <a:rPr lang="en-US" smtClean="0"/>
               <a:t>Click to edit Master title style</a:t>
             </a:r>
+            <a:endParaRPr lang="en-US"/>
           </a:p>
         </p:txBody>
       </p:sp>
@@ -3767,37 +3993,38 @@
           <a:p>
             <a:pPr lvl="0"/>
             <a:r>
-              <a:rPr lang="en-US"/>
+              <a:rPr lang="en-US" smtClean="0"/>
               <a:t>Click to edit Master text styles</a:t>
             </a:r>
           </a:p>
           <a:p>
             <a:pPr lvl="1"/>
             <a:r>
-              <a:rPr lang="en-US"/>
+              <a:rPr lang="en-US" smtClean="0"/>
               <a:t>Second level</a:t>
             </a:r>
           </a:p>
           <a:p>
             <a:pPr lvl="2"/>
             <a:r>
-              <a:rPr lang="en-US"/>
+              <a:rPr lang="en-US" smtClean="0"/>
               <a:t>Third level</a:t>
             </a:r>
           </a:p>
           <a:p>
             <a:pPr lvl="3"/>
             <a:r>
-              <a:rPr lang="en-US"/>
+              <a:rPr lang="en-US" smtClean="0"/>
               <a:t>Fourth level</a:t>
             </a:r>
           </a:p>
           <a:p>
             <a:pPr lvl="4"/>
             <a:r>
-              <a:rPr lang="en-US"/>
+              <a:rPr lang="en-US" smtClean="0"/>
               <a:t>Fifth level</a:t>
             </a:r>
+            <a:endParaRPr lang="en-US"/>
           </a:p>
         </p:txBody>
       </p:sp>
@@ -3836,7 +4063,7 @@
           <a:p>
             <a:fld id="{5BCAD085-E8A6-8845-BD4E-CB4CCA059FC4}" type="datetimeFigureOut">
               <a:rPr lang="en-US" smtClean="0"/>
-              <a:t>6/21/26</a:t>
+              <a:t>1/27/13</a:t>
             </a:fld>
             <a:endParaRPr lang="en-US"/>
           </a:p>
@@ -4195,7 +4422,7 @@
 </file>
 
 <file path=ppt/slides/slide1.xml><?xml version="1.0" encoding="utf-8"?>
-<p:sld xmlns:a="http://schemas.openxmlformats.org/drawingml/2006/main" xmlns:r="http://schemas.openxmlformats.org/officeDocument/2006/relationships" xmlns:p="http://schemas.openxmlformats.org/presentationml/2006/main">
+<p:sld xmlns:a="http://schemas.openxmlformats.org/drawingml/2006/main" xmlns:p="http://schemas.openxmlformats.org/presentationml/2006/main" xmlns:r="http://schemas.openxmlformats.org/officeDocument/2006/relationships">
   <p:cSld>
     <p:spTree>
       <p:nvGrpSpPr>
@@ -4203,14 +4430,7 @@
         <p:cNvGrpSpPr/>
         <p:nvPr/>
       </p:nvGrpSpPr>
-      <p:grpSpPr>
-        <a:xfrm>
-          <a:off x="0" y="0"/>
-          <a:ext cx="0" cy="0"/>
-          <a:chOff x="0" y="0"/>
-          <a:chExt cx="0" cy="0"/>
-        </a:xfrm>
-      </p:grpSpPr>
+      <p:grpSpPr/>
       <p:sp>
         <p:nvSpPr>
           <p:cNvPr id="2" name="Rectangle 1"/>
@@ -4252,7 +4472,6 @@
           <a:lstStyle/>
           <a:p>
             <a:pPr algn="ctr"/>
-            <a:endParaRPr/>
           </a:p>
         </p:txBody>
       </p:sp>
@@ -4297,7 +4516,6 @@
           <a:lstStyle/>
           <a:p>
             <a:pPr algn="ctr"/>
-            <a:endParaRPr/>
           </a:p>
         </p:txBody>
       </p:sp>
@@ -4342,7 +4560,6 @@
           <a:lstStyle/>
           <a:p>
             <a:pPr algn="ctr"/>
-            <a:endParaRPr/>
           </a:p>
         </p:txBody>
       </p:sp>
@@ -4457,7 +4674,7 @@
               </a:spcAft>
             </a:pPr>
             <a:r>
-              <a:rPr sz="1500" b="1" dirty="0">
+              <a:rPr sz="1500" b="1">
                 <a:solidFill>
                   <a:srgbClr val="FFFFFF"/>
                 </a:solidFill>
@@ -4476,7 +4693,7 @@
               </a:spcAft>
             </a:pPr>
             <a:r>
-              <a:rPr sz="1300" b="0" dirty="0">
+              <a:rPr sz="1300" b="0">
                 <a:solidFill>
                   <a:srgbClr val="B8C4D0"/>
                 </a:solidFill>
@@ -4496,7 +4713,7 @@
 </file>
 
 <file path=ppt/slides/slide10.xml><?xml version="1.0" encoding="utf-8"?>
-<p:sld xmlns:a="http://schemas.openxmlformats.org/drawingml/2006/main" xmlns:r="http://schemas.openxmlformats.org/officeDocument/2006/relationships" xmlns:p="http://schemas.openxmlformats.org/presentationml/2006/main">
+<p:sld xmlns:a="http://schemas.openxmlformats.org/drawingml/2006/main" xmlns:p="http://schemas.openxmlformats.org/presentationml/2006/main" xmlns:r="http://schemas.openxmlformats.org/officeDocument/2006/relationships">
   <p:cSld>
     <p:spTree>
       <p:nvGrpSpPr>
@@ -4504,14 +4721,7 @@
         <p:cNvGrpSpPr/>
         <p:nvPr/>
       </p:nvGrpSpPr>
-      <p:grpSpPr>
-        <a:xfrm>
-          <a:off x="0" y="0"/>
-          <a:ext cx="0" cy="0"/>
-          <a:chOff x="0" y="0"/>
-          <a:chExt cx="0" cy="0"/>
-        </a:xfrm>
-      </p:grpSpPr>
+      <p:grpSpPr/>
       <p:sp>
         <p:nvSpPr>
           <p:cNvPr id="2" name="Rectangle 1"/>
@@ -4553,7 +4763,6 @@
           <a:lstStyle/>
           <a:p>
             <a:pPr algn="ctr"/>
-            <a:endParaRPr/>
           </a:p>
         </p:txBody>
       </p:sp>
@@ -4598,7 +4807,6 @@
           <a:lstStyle/>
           <a:p>
             <a:pPr algn="ctr"/>
-            <a:endParaRPr/>
           </a:p>
         </p:txBody>
       </p:sp>
@@ -4704,7 +4912,6 @@
           <a:lstStyle/>
           <a:p>
             <a:pPr algn="ctr"/>
-            <a:endParaRPr/>
           </a:p>
         </p:txBody>
       </p:sp>
@@ -4749,7 +4956,6 @@
           <a:lstStyle/>
           <a:p>
             <a:pPr algn="ctr"/>
-            <a:endParaRPr/>
           </a:p>
         </p:txBody>
       </p:sp>
@@ -4828,7 +5034,7 @@
                 </a:solidFill>
                 <a:latin typeface="Calibri"/>
               </a:rPr>
-              <a:t>~500 devices  ≈</a:t>
+              <a:t>~10,000 devices  ≈</a:t>
             </a:r>
           </a:p>
           <a:p>
@@ -4847,7 +5053,7 @@
                 </a:solidFill>
                 <a:latin typeface="Calibri"/>
               </a:rPr>
-              <a:t>$18,000–42,000 / year</a:t>
+              <a:t>$360k–$840k / year</a:t>
             </a:r>
           </a:p>
           <a:p>
@@ -4866,7 +5072,7 @@
                 </a:solidFill>
                 <a:latin typeface="Calibri"/>
               </a:rPr>
-              <a:t>Ongoing per-seat fees,</a:t>
+              <a:t>per-seat, forever;</a:t>
             </a:r>
           </a:p>
           <a:p>
@@ -4885,7 +5091,7 @@
                 </a:solidFill>
                 <a:latin typeface="Calibri"/>
               </a:rPr>
-              <a:t>rising as we grow.</a:t>
+              <a:t>grows with the fleet.</a:t>
             </a:r>
           </a:p>
         </p:txBody>
@@ -4931,7 +5137,6 @@
           <a:lstStyle/>
           <a:p>
             <a:pPr algn="ctr"/>
-            <a:endParaRPr/>
           </a:p>
         </p:txBody>
       </p:sp>
@@ -4976,7 +5181,6 @@
           <a:lstStyle/>
           <a:p>
             <a:pPr algn="ctr"/>
-            <a:endParaRPr/>
           </a:p>
         </p:txBody>
       </p:sp>
@@ -5017,7 +5221,7 @@
                 </a:solidFill>
                 <a:latin typeface="Calibri"/>
               </a:rPr>
-              <a:t>This solution — AWS</a:t>
+              <a:t>This solution — hosted</a:t>
             </a:r>
           </a:p>
           <a:p>
@@ -5036,7 +5240,7 @@
                 </a:solidFill>
                 <a:latin typeface="Calibri Light"/>
               </a:rPr>
-              <a:t>~$100 / month</a:t>
+              <a:t>~$1.5–3.5k / mo</a:t>
             </a:r>
           </a:p>
           <a:p>
@@ -5055,7 +5259,7 @@
                 </a:solidFill>
                 <a:latin typeface="Calibri"/>
               </a:rPr>
-              <a:t>≈ $1,200 / year</a:t>
+              <a:t>≈ $18k–42k / year</a:t>
             </a:r>
           </a:p>
           <a:p>
@@ -5074,7 +5278,7 @@
                 </a:solidFill>
                 <a:latin typeface="Calibri"/>
               </a:rPr>
-              <a:t>+ existing IT staff time</a:t>
+              <a:t>at 10k, highly available</a:t>
             </a:r>
           </a:p>
           <a:p>
@@ -5112,7 +5316,7 @@
                 </a:solidFill>
                 <a:latin typeface="Calibri"/>
               </a:rPr>
-              <a:t>scales to 500+ at flat cost.</a:t>
+              <a:t>needs a sizing pass.</a:t>
             </a:r>
           </a:p>
         </p:txBody>
@@ -5158,7 +5362,6 @@
           <a:lstStyle/>
           <a:p>
             <a:pPr algn="ctr"/>
-            <a:endParaRPr/>
           </a:p>
         </p:txBody>
       </p:sp>
@@ -5203,7 +5406,6 @@
           <a:lstStyle/>
           <a:p>
             <a:pPr algn="ctr"/>
-            <a:endParaRPr/>
           </a:p>
         </p:txBody>
       </p:sp>
@@ -5263,7 +5465,7 @@
                 </a:solidFill>
                 <a:latin typeface="Calibri Light"/>
               </a:rPr>
-              <a:t>$0 hosting</a:t>
+              <a:t>$0 licensing</a:t>
             </a:r>
           </a:p>
           <a:p>
@@ -5282,7 +5484,7 @@
                 </a:solidFill>
                 <a:latin typeface="Calibri"/>
               </a:rPr>
-              <a:t>Repurpose a server</a:t>
+              <a:t>Runs on our own</a:t>
             </a:r>
           </a:p>
           <a:p>
@@ -5301,7 +5503,7 @@
                 </a:solidFill>
                 <a:latin typeface="Calibri"/>
               </a:rPr>
-              <a:t>we already own</a:t>
+              <a:t>servers / VMs</a:t>
             </a:r>
           </a:p>
           <a:p>
@@ -5320,7 +5522,7 @@
                 </a:solidFill>
                 <a:latin typeface="Calibri"/>
               </a:rPr>
-              <a:t>No new hardware or licensing</a:t>
+              <a:t>No cloud required;</a:t>
             </a:r>
           </a:p>
           <a:p>
@@ -5339,7 +5541,7 @@
                 </a:solidFill>
                 <a:latin typeface="Calibri"/>
               </a:rPr>
-              <a:t>— just our IT staff time.</a:t>
+              <a:t>just compute + IT time.</a:t>
             </a:r>
           </a:p>
         </p:txBody>
@@ -5381,7 +5583,7 @@
                 </a:solidFill>
                 <a:latin typeface="Calibri"/>
               </a:rPr>
-              <a:t>Illustrative figures. We trade software licensing cost for a modest amount of our own IT time — and we keep full control of our data. Repurposing existing on-prem hardware removes even the hosting cost.</a:t>
+              <a:t>Illustrative figures at ~10,000 devices — not quotes; production cost needs a sizing pass. Commercial pricing is per-device (six figures/yr, forever); ours is infrastructure-based, so the gap widens as we grow. Data stays in-house either way.</a:t>
             </a:r>
           </a:p>
         </p:txBody>
@@ -5479,7 +5681,7 @@
 </file>
 
 <file path=ppt/slides/slide11.xml><?xml version="1.0" encoding="utf-8"?>
-<p:sld xmlns:a="http://schemas.openxmlformats.org/drawingml/2006/main" xmlns:r="http://schemas.openxmlformats.org/officeDocument/2006/relationships" xmlns:p="http://schemas.openxmlformats.org/presentationml/2006/main">
+<p:sld xmlns:a="http://schemas.openxmlformats.org/drawingml/2006/main" xmlns:p="http://schemas.openxmlformats.org/presentationml/2006/main" xmlns:r="http://schemas.openxmlformats.org/officeDocument/2006/relationships">
   <p:cSld>
     <p:spTree>
       <p:nvGrpSpPr>
@@ -5487,14 +5689,7 @@
         <p:cNvGrpSpPr/>
         <p:nvPr/>
       </p:nvGrpSpPr>
-      <p:grpSpPr>
-        <a:xfrm>
-          <a:off x="0" y="0"/>
-          <a:ext cx="0" cy="0"/>
-          <a:chOff x="0" y="0"/>
-          <a:chExt cx="0" cy="0"/>
-        </a:xfrm>
-      </p:grpSpPr>
+      <p:grpSpPr/>
       <p:sp>
         <p:nvSpPr>
           <p:cNvPr id="2" name="Rectangle 1"/>
@@ -5536,7 +5731,6 @@
           <a:lstStyle/>
           <a:p>
             <a:pPr algn="ctr"/>
-            <a:endParaRPr/>
           </a:p>
         </p:txBody>
       </p:sp>
@@ -5581,7 +5775,6 @@
           <a:lstStyle/>
           <a:p>
             <a:pPr algn="ctr"/>
-            <a:endParaRPr/>
           </a:p>
         </p:txBody>
       </p:sp>
@@ -5687,7 +5880,6 @@
           <a:lstStyle/>
           <a:p>
             <a:pPr algn="ctr"/>
-            <a:endParaRPr/>
           </a:p>
         </p:txBody>
       </p:sp>
@@ -5732,7 +5924,6 @@
           <a:lstStyle/>
           <a:p>
             <a:pPr algn="ctr"/>
-            <a:endParaRPr/>
           </a:p>
         </p:txBody>
       </p:sp>
@@ -5773,7 +5964,7 @@
                 </a:solidFill>
                 <a:latin typeface="Calibri"/>
               </a:rPr>
-              <a:t>Phase 1  ·  4–6 weeks</a:t>
+              <a:t>Phase 1  ·  2–4 weeks</a:t>
             </a:r>
           </a:p>
         </p:txBody>
@@ -5815,7 +6006,7 @@
                 </a:solidFill>
                 <a:latin typeface="Calibri"/>
               </a:rPr>
-              <a:t>Proof of Concept</a:t>
+              <a:t>Pilot</a:t>
             </a:r>
           </a:p>
           <a:p>
@@ -5834,7 +6025,7 @@
                 </a:solidFill>
                 <a:latin typeface="Calibri"/>
               </a:rPr>
-              <a:t>2 test laptops. Prove the full loop: see, prove, fix. Near-zero cost.</a:t>
+              <a:t>50 devices. Validate the full loop end to end and tune our security policies. (POC already proven.)</a:t>
             </a:r>
           </a:p>
         </p:txBody>
@@ -5880,7 +6071,6 @@
           <a:lstStyle/>
           <a:p>
             <a:pPr algn="ctr"/>
-            <a:endParaRPr/>
           </a:p>
         </p:txBody>
       </p:sp>
@@ -5925,7 +6115,6 @@
           <a:lstStyle/>
           <a:p>
             <a:pPr algn="ctr"/>
-            <a:endParaRPr/>
           </a:p>
         </p:txBody>
       </p:sp>
@@ -5970,7 +6159,6 @@
           <a:lstStyle/>
           <a:p>
             <a:pPr algn="ctr"/>
-            <a:endParaRPr/>
           </a:p>
         </p:txBody>
       </p:sp>
@@ -6011,7 +6199,7 @@
                 </a:solidFill>
                 <a:latin typeface="Calibri"/>
               </a:rPr>
-              <a:t>Phase 2  ·  1–2 months</a:t>
+              <a:t>Phase 2  ·  Phased</a:t>
             </a:r>
           </a:p>
         </p:txBody>
@@ -6053,7 +6241,7 @@
                 </a:solidFill>
                 <a:latin typeface="Calibri"/>
               </a:rPr>
-              <a:t>Pilot</a:t>
+              <a:t>First milestone</a:t>
             </a:r>
           </a:p>
           <a:p>
@@ -6072,7 +6260,7 @@
                 </a:solidFill>
                 <a:latin typeface="Calibri"/>
               </a:rPr>
-              <a:t>~50 real devices across teams. Validate at scale and refine our policies.</a:t>
+              <a:t>~1,000 newly acquired computers, shipped agent-ready — zero-touch, enrolled on first boot.</a:t>
             </a:r>
           </a:p>
         </p:txBody>
@@ -6118,7 +6306,6 @@
           <a:lstStyle/>
           <a:p>
             <a:pPr algn="ctr"/>
-            <a:endParaRPr/>
           </a:p>
         </p:txBody>
       </p:sp>
@@ -6163,7 +6350,6 @@
           <a:lstStyle/>
           <a:p>
             <a:pPr algn="ctr"/>
-            <a:endParaRPr/>
           </a:p>
         </p:txBody>
       </p:sp>
@@ -6208,7 +6394,6 @@
           <a:lstStyle/>
           <a:p>
             <a:pPr algn="ctr"/>
-            <a:endParaRPr/>
           </a:p>
         </p:txBody>
       </p:sp>
@@ -6249,7 +6434,7 @@
                 </a:solidFill>
                 <a:latin typeface="Calibri"/>
               </a:rPr>
-              <a:t>Phase 3  ·  Phased</a:t>
+              <a:t>Phase 3  ·  Phased, months</a:t>
             </a:r>
           </a:p>
         </p:txBody>
@@ -6291,7 +6476,7 @@
                 </a:solidFill>
                 <a:latin typeface="Calibri"/>
               </a:rPr>
-              <a:t>Fleet rollout</a:t>
+              <a:t>Scale to fleet</a:t>
             </a:r>
           </a:p>
           <a:p>
@@ -6310,7 +6495,7 @@
                 </a:solidFill>
                 <a:latin typeface="Calibri"/>
               </a:rPr>
-              <a:t>Roll out to all ~500 devices, group by group, with full reporting.</a:t>
+              <a:t>Onboard existing devices in waves, toward ~10,000 total, with full reporting.</a:t>
             </a:r>
           </a:p>
         </p:txBody>
@@ -6450,7 +6635,7 @@
 </file>
 
 <file path=ppt/slides/slide12.xml><?xml version="1.0" encoding="utf-8"?>
-<p:sld xmlns:a="http://schemas.openxmlformats.org/drawingml/2006/main" xmlns:r="http://schemas.openxmlformats.org/officeDocument/2006/relationships" xmlns:p="http://schemas.openxmlformats.org/presentationml/2006/main">
+<p:sld xmlns:a="http://schemas.openxmlformats.org/drawingml/2006/main" xmlns:p="http://schemas.openxmlformats.org/presentationml/2006/main" xmlns:r="http://schemas.openxmlformats.org/officeDocument/2006/relationships">
   <p:cSld>
     <p:spTree>
       <p:nvGrpSpPr>
@@ -6458,14 +6643,7 @@
         <p:cNvGrpSpPr/>
         <p:nvPr/>
       </p:nvGrpSpPr>
-      <p:grpSpPr>
-        <a:xfrm>
-          <a:off x="0" y="0"/>
-          <a:ext cx="0" cy="0"/>
-          <a:chOff x="0" y="0"/>
-          <a:chExt cx="0" cy="0"/>
-        </a:xfrm>
-      </p:grpSpPr>
+      <p:grpSpPr/>
       <p:sp>
         <p:nvSpPr>
           <p:cNvPr id="2" name="Rectangle 1"/>
@@ -6507,7 +6685,6 @@
           <a:lstStyle/>
           <a:p>
             <a:pPr algn="ctr"/>
-            <a:endParaRPr/>
           </a:p>
         </p:txBody>
       </p:sp>
@@ -6552,7 +6729,6 @@
           <a:lstStyle/>
           <a:p>
             <a:pPr algn="ctr"/>
-            <a:endParaRPr/>
           </a:p>
         </p:txBody>
       </p:sp>
@@ -6658,7 +6834,6 @@
           <a:lstStyle/>
           <a:p>
             <a:pPr algn="ctr"/>
-            <a:endParaRPr/>
           </a:p>
         </p:txBody>
       </p:sp>
@@ -6745,7 +6920,6 @@
           <a:lstStyle/>
           <a:p>
             <a:pPr algn="ctr"/>
-            <a:endParaRPr/>
           </a:p>
         </p:txBody>
       </p:sp>
@@ -6832,7 +7006,6 @@
           <a:lstStyle/>
           <a:p>
             <a:pPr algn="ctr"/>
-            <a:endParaRPr/>
           </a:p>
         </p:txBody>
       </p:sp>
@@ -6919,7 +7092,6 @@
           <a:lstStyle/>
           <a:p>
             <a:pPr algn="ctr"/>
-            <a:endParaRPr/>
           </a:p>
         </p:txBody>
       </p:sp>
@@ -7006,7 +7178,6 @@
           <a:lstStyle/>
           <a:p>
             <a:pPr algn="ctr"/>
-            <a:endParaRPr/>
           </a:p>
         </p:txBody>
       </p:sp>
@@ -7093,7 +7264,6 @@
           <a:lstStyle/>
           <a:p>
             <a:pPr algn="ctr"/>
-            <a:endParaRPr/>
           </a:p>
         </p:txBody>
       </p:sp>
@@ -7180,7 +7350,6 @@
           <a:lstStyle/>
           <a:p>
             <a:pPr algn="ctr"/>
-            <a:endParaRPr/>
           </a:p>
         </p:txBody>
       </p:sp>
@@ -7267,7 +7436,6 @@
           <a:lstStyle/>
           <a:p>
             <a:pPr algn="ctr"/>
-            <a:endParaRPr/>
           </a:p>
         </p:txBody>
       </p:sp>
@@ -7406,7 +7574,7 @@
 </file>
 
 <file path=ppt/slides/slide13.xml><?xml version="1.0" encoding="utf-8"?>
-<p:sld xmlns:a="http://schemas.openxmlformats.org/drawingml/2006/main" xmlns:r="http://schemas.openxmlformats.org/officeDocument/2006/relationships" xmlns:p="http://schemas.openxmlformats.org/presentationml/2006/main">
+<p:sld xmlns:a="http://schemas.openxmlformats.org/drawingml/2006/main" xmlns:p="http://schemas.openxmlformats.org/presentationml/2006/main" xmlns:r="http://schemas.openxmlformats.org/officeDocument/2006/relationships">
   <p:cSld>
     <p:spTree>
       <p:nvGrpSpPr>
@@ -7414,14 +7582,7 @@
         <p:cNvGrpSpPr/>
         <p:nvPr/>
       </p:nvGrpSpPr>
-      <p:grpSpPr>
-        <a:xfrm>
-          <a:off x="0" y="0"/>
-          <a:ext cx="0" cy="0"/>
-          <a:chOff x="0" y="0"/>
-          <a:chExt cx="0" cy="0"/>
-        </a:xfrm>
-      </p:grpSpPr>
+      <p:grpSpPr/>
       <p:sp>
         <p:nvSpPr>
           <p:cNvPr id="2" name="Rectangle 1"/>
@@ -7463,7 +7624,6 @@
           <a:lstStyle/>
           <a:p>
             <a:pPr algn="ctr"/>
-            <a:endParaRPr/>
           </a:p>
         </p:txBody>
       </p:sp>
@@ -7508,7 +7668,6 @@
           <a:lstStyle/>
           <a:p>
             <a:pPr algn="ctr"/>
-            <a:endParaRPr/>
           </a:p>
         </p:txBody>
       </p:sp>
@@ -7553,7 +7712,6 @@
           <a:lstStyle/>
           <a:p>
             <a:pPr algn="ctr"/>
-            <a:endParaRPr/>
           </a:p>
         </p:txBody>
       </p:sp>
@@ -7852,7 +8010,7 @@
 </file>
 
 <file path=ppt/slides/slide14.xml><?xml version="1.0" encoding="utf-8"?>
-<p:sld xmlns:a="http://schemas.openxmlformats.org/drawingml/2006/main" xmlns:r="http://schemas.openxmlformats.org/officeDocument/2006/relationships" xmlns:p="http://schemas.openxmlformats.org/presentationml/2006/main">
+<p:sld xmlns:a="http://schemas.openxmlformats.org/drawingml/2006/main" xmlns:p="http://schemas.openxmlformats.org/presentationml/2006/main" xmlns:r="http://schemas.openxmlformats.org/officeDocument/2006/relationships">
   <p:cSld>
     <p:spTree>
       <p:nvGrpSpPr>
@@ -7860,14 +8018,7 @@
         <p:cNvGrpSpPr/>
         <p:nvPr/>
       </p:nvGrpSpPr>
-      <p:grpSpPr>
-        <a:xfrm>
-          <a:off x="0" y="0"/>
-          <a:ext cx="0" cy="0"/>
-          <a:chOff x="0" y="0"/>
-          <a:chExt cx="0" cy="0"/>
-        </a:xfrm>
-      </p:grpSpPr>
+      <p:grpSpPr/>
       <p:sp>
         <p:nvSpPr>
           <p:cNvPr id="2" name="Rectangle 1"/>
@@ -7909,7 +8060,6 @@
           <a:lstStyle/>
           <a:p>
             <a:pPr algn="ctr"/>
-            <a:endParaRPr/>
           </a:p>
         </p:txBody>
       </p:sp>
@@ -7954,7 +8104,6 @@
           <a:lstStyle/>
           <a:p>
             <a:pPr algn="ctr"/>
-            <a:endParaRPr/>
           </a:p>
         </p:txBody>
       </p:sp>
@@ -8028,7 +8177,7 @@
 </file>
 
 <file path=ppt/slides/slide2.xml><?xml version="1.0" encoding="utf-8"?>
-<p:sld xmlns:a="http://schemas.openxmlformats.org/drawingml/2006/main" xmlns:r="http://schemas.openxmlformats.org/officeDocument/2006/relationships" xmlns:p="http://schemas.openxmlformats.org/presentationml/2006/main">
+<p:sld xmlns:a="http://schemas.openxmlformats.org/drawingml/2006/main" xmlns:p="http://schemas.openxmlformats.org/presentationml/2006/main" xmlns:r="http://schemas.openxmlformats.org/officeDocument/2006/relationships">
   <p:cSld>
     <p:spTree>
       <p:nvGrpSpPr>
@@ -8036,14 +8185,7 @@
         <p:cNvGrpSpPr/>
         <p:nvPr/>
       </p:nvGrpSpPr>
-      <p:grpSpPr>
-        <a:xfrm>
-          <a:off x="0" y="0"/>
-          <a:ext cx="0" cy="0"/>
-          <a:chOff x="0" y="0"/>
-          <a:chExt cx="0" cy="0"/>
-        </a:xfrm>
-      </p:grpSpPr>
+      <p:grpSpPr/>
       <p:sp>
         <p:nvSpPr>
           <p:cNvPr id="2" name="Rectangle 1"/>
@@ -8085,7 +8227,6 @@
           <a:lstStyle/>
           <a:p>
             <a:pPr algn="ctr"/>
-            <a:endParaRPr/>
           </a:p>
         </p:txBody>
       </p:sp>
@@ -8130,7 +8271,6 @@
           <a:lstStyle/>
           <a:p>
             <a:pPr algn="ctr"/>
-            <a:endParaRPr/>
           </a:p>
         </p:txBody>
       </p:sp>
@@ -8288,7 +8428,7 @@
 </file>
 
 <file path=ppt/slides/slide3.xml><?xml version="1.0" encoding="utf-8"?>
-<p:sld xmlns:a="http://schemas.openxmlformats.org/drawingml/2006/main" xmlns:r="http://schemas.openxmlformats.org/officeDocument/2006/relationships" xmlns:p="http://schemas.openxmlformats.org/presentationml/2006/main">
+<p:sld xmlns:a="http://schemas.openxmlformats.org/drawingml/2006/main" xmlns:p="http://schemas.openxmlformats.org/presentationml/2006/main" xmlns:r="http://schemas.openxmlformats.org/officeDocument/2006/relationships">
   <p:cSld>
     <p:spTree>
       <p:nvGrpSpPr>
@@ -8296,14 +8436,7 @@
         <p:cNvGrpSpPr/>
         <p:nvPr/>
       </p:nvGrpSpPr>
-      <p:grpSpPr>
-        <a:xfrm>
-          <a:off x="0" y="0"/>
-          <a:ext cx="0" cy="0"/>
-          <a:chOff x="0" y="0"/>
-          <a:chExt cx="0" cy="0"/>
-        </a:xfrm>
-      </p:grpSpPr>
+      <p:grpSpPr/>
       <p:sp>
         <p:nvSpPr>
           <p:cNvPr id="2" name="Rectangle 1"/>
@@ -8345,7 +8478,6 @@
           <a:lstStyle/>
           <a:p>
             <a:pPr algn="ctr"/>
-            <a:endParaRPr/>
           </a:p>
         </p:txBody>
       </p:sp>
@@ -8390,7 +8522,6 @@
           <a:lstStyle/>
           <a:p>
             <a:pPr algn="ctr"/>
-            <a:endParaRPr/>
           </a:p>
         </p:txBody>
       </p:sp>
@@ -8492,7 +8623,7 @@
                 </a:solidFill>
                 <a:latin typeface="Calibri"/>
               </a:rPr>
-              <a:t>•   ~500 Windows devices — roughly 350 in-office desktops and 150 laptops that leave the building.</a:t>
+              <a:t>•   ~10,000 Windows devices across the organization — desktops in offices and laptops in the field.</a:t>
             </a:r>
           </a:p>
           <a:p>
@@ -8568,7 +8699,7 @@
                 </a:solidFill>
                 <a:latin typeface="Calibri"/>
               </a:rPr>
-              <a:t>•   No budget for commercial tools — Intune, Tanium, and the like are priced per device.</a:t>
+              <a:t>•   Commercial tools are priced per device — at this scale, that's six figures a year.</a:t>
             </a:r>
           </a:p>
         </p:txBody>
@@ -8666,7 +8797,7 @@
 </file>
 
 <file path=ppt/slides/slide4.xml><?xml version="1.0" encoding="utf-8"?>
-<p:sld xmlns:a="http://schemas.openxmlformats.org/drawingml/2006/main" xmlns:r="http://schemas.openxmlformats.org/officeDocument/2006/relationships" xmlns:p="http://schemas.openxmlformats.org/presentationml/2006/main">
+<p:sld xmlns:a="http://schemas.openxmlformats.org/drawingml/2006/main" xmlns:p="http://schemas.openxmlformats.org/presentationml/2006/main" xmlns:r="http://schemas.openxmlformats.org/officeDocument/2006/relationships">
   <p:cSld>
     <p:spTree>
       <p:nvGrpSpPr>
@@ -8674,14 +8805,7 @@
         <p:cNvGrpSpPr/>
         <p:nvPr/>
       </p:nvGrpSpPr>
-      <p:grpSpPr>
-        <a:xfrm>
-          <a:off x="0" y="0"/>
-          <a:ext cx="0" cy="0"/>
-          <a:chOff x="0" y="0"/>
-          <a:chExt cx="0" cy="0"/>
-        </a:xfrm>
-      </p:grpSpPr>
+      <p:grpSpPr/>
       <p:sp>
         <p:nvSpPr>
           <p:cNvPr id="2" name="Rectangle 1"/>
@@ -8723,7 +8847,6 @@
           <a:lstStyle/>
           <a:p>
             <a:pPr algn="ctr"/>
-            <a:endParaRPr/>
           </a:p>
         </p:txBody>
       </p:sp>
@@ -8768,7 +8891,6 @@
           <a:lstStyle/>
           <a:p>
             <a:pPr algn="ctr"/>
-            <a:endParaRPr/>
           </a:p>
         </p:txBody>
       </p:sp>
@@ -8874,7 +8996,6 @@
           <a:lstStyle/>
           <a:p>
             <a:pPr algn="ctr"/>
-            <a:endParaRPr/>
           </a:p>
         </p:txBody>
       </p:sp>
@@ -8919,7 +9040,6 @@
           <a:lstStyle/>
           <a:p>
             <a:pPr algn="ctr"/>
-            <a:endParaRPr/>
           </a:p>
         </p:txBody>
       </p:sp>
@@ -9025,7 +9145,6 @@
           <a:lstStyle/>
           <a:p>
             <a:pPr algn="ctr"/>
-            <a:endParaRPr/>
           </a:p>
         </p:txBody>
       </p:sp>
@@ -9070,7 +9189,6 @@
           <a:lstStyle/>
           <a:p>
             <a:pPr algn="ctr"/>
-            <a:endParaRPr/>
           </a:p>
         </p:txBody>
       </p:sp>
@@ -9176,7 +9294,6 @@
           <a:lstStyle/>
           <a:p>
             <a:pPr algn="ctr"/>
-            <a:endParaRPr/>
           </a:p>
         </p:txBody>
       </p:sp>
@@ -9221,7 +9338,6 @@
           <a:lstStyle/>
           <a:p>
             <a:pPr algn="ctr"/>
-            <a:endParaRPr/>
           </a:p>
         </p:txBody>
       </p:sp>
@@ -9379,7 +9495,7 @@
 </file>
 
 <file path=ppt/slides/slide5.xml><?xml version="1.0" encoding="utf-8"?>
-<p:sld xmlns:a="http://schemas.openxmlformats.org/drawingml/2006/main" xmlns:r="http://schemas.openxmlformats.org/officeDocument/2006/relationships" xmlns:p="http://schemas.openxmlformats.org/presentationml/2006/main">
+<p:sld xmlns:a="http://schemas.openxmlformats.org/drawingml/2006/main" xmlns:p="http://schemas.openxmlformats.org/presentationml/2006/main" xmlns:r="http://schemas.openxmlformats.org/officeDocument/2006/relationships">
   <p:cSld>
     <p:spTree>
       <p:nvGrpSpPr>
@@ -9387,14 +9503,7 @@
         <p:cNvGrpSpPr/>
         <p:nvPr/>
       </p:nvGrpSpPr>
-      <p:grpSpPr>
-        <a:xfrm>
-          <a:off x="0" y="0"/>
-          <a:ext cx="0" cy="0"/>
-          <a:chOff x="0" y="0"/>
-          <a:chExt cx="0" cy="0"/>
-        </a:xfrm>
-      </p:grpSpPr>
+      <p:grpSpPr/>
       <p:sp>
         <p:nvSpPr>
           <p:cNvPr id="2" name="Rectangle 1"/>
@@ -9436,7 +9545,6 @@
           <a:lstStyle/>
           <a:p>
             <a:pPr algn="ctr"/>
-            <a:endParaRPr/>
           </a:p>
         </p:txBody>
       </p:sp>
@@ -9481,7 +9589,6 @@
           <a:lstStyle/>
           <a:p>
             <a:pPr algn="ctr"/>
-            <a:endParaRPr/>
           </a:p>
         </p:txBody>
       </p:sp>
@@ -9658,7 +9765,7 @@
 </file>
 
 <file path=ppt/slides/slide6.xml><?xml version="1.0" encoding="utf-8"?>
-<p:sld xmlns:a="http://schemas.openxmlformats.org/drawingml/2006/main" xmlns:r="http://schemas.openxmlformats.org/officeDocument/2006/relationships" xmlns:p="http://schemas.openxmlformats.org/presentationml/2006/main">
+<p:sld xmlns:a="http://schemas.openxmlformats.org/drawingml/2006/main" xmlns:p="http://schemas.openxmlformats.org/presentationml/2006/main" xmlns:r="http://schemas.openxmlformats.org/officeDocument/2006/relationships">
   <p:cSld>
     <p:spTree>
       <p:nvGrpSpPr>
@@ -9666,14 +9773,7 @@
         <p:cNvGrpSpPr/>
         <p:nvPr/>
       </p:nvGrpSpPr>
-      <p:grpSpPr>
-        <a:xfrm>
-          <a:off x="0" y="0"/>
-          <a:ext cx="0" cy="0"/>
-          <a:chOff x="0" y="0"/>
-          <a:chExt cx="0" cy="0"/>
-        </a:xfrm>
-      </p:grpSpPr>
+      <p:grpSpPr/>
       <p:sp>
         <p:nvSpPr>
           <p:cNvPr id="2" name="Rectangle 1"/>
@@ -9715,7 +9815,6 @@
           <a:lstStyle/>
           <a:p>
             <a:pPr algn="ctr"/>
-            <a:endParaRPr/>
           </a:p>
         </p:txBody>
       </p:sp>
@@ -9760,7 +9859,6 @@
           <a:lstStyle/>
           <a:p>
             <a:pPr algn="ctr"/>
-            <a:endParaRPr/>
           </a:p>
         </p:txBody>
       </p:sp>
@@ -9866,7 +9964,6 @@
           <a:lstStyle/>
           <a:p>
             <a:pPr algn="ctr"/>
-            <a:endParaRPr/>
           </a:p>
         </p:txBody>
       </p:sp>
@@ -9911,7 +10008,6 @@
           <a:lstStyle/>
           <a:p>
             <a:pPr algn="ctr"/>
-            <a:endParaRPr/>
           </a:p>
         </p:txBody>
       </p:sp>
@@ -10097,7 +10193,6 @@
           <a:lstStyle/>
           <a:p>
             <a:pPr algn="ctr"/>
-            <a:endParaRPr/>
           </a:p>
         </p:txBody>
       </p:sp>
@@ -10142,7 +10237,6 @@
           <a:lstStyle/>
           <a:p>
             <a:pPr algn="ctr"/>
-            <a:endParaRPr/>
           </a:p>
         </p:txBody>
       </p:sp>
@@ -10328,7 +10422,6 @@
           <a:lstStyle/>
           <a:p>
             <a:pPr algn="ctr"/>
-            <a:endParaRPr/>
           </a:p>
         </p:txBody>
       </p:sp>
@@ -10373,7 +10466,6 @@
           <a:lstStyle/>
           <a:p>
             <a:pPr algn="ctr"/>
-            <a:endParaRPr/>
           </a:p>
         </p:txBody>
       </p:sp>
@@ -10611,7 +10703,7 @@
 </file>
 
 <file path=ppt/slides/slide7.xml><?xml version="1.0" encoding="utf-8"?>
-<p:sld xmlns:a="http://schemas.openxmlformats.org/drawingml/2006/main" xmlns:r="http://schemas.openxmlformats.org/officeDocument/2006/relationships" xmlns:p="http://schemas.openxmlformats.org/presentationml/2006/main">
+<p:sld xmlns:a="http://schemas.openxmlformats.org/drawingml/2006/main" xmlns:p="http://schemas.openxmlformats.org/presentationml/2006/main" xmlns:r="http://schemas.openxmlformats.org/officeDocument/2006/relationships">
   <p:cSld>
     <p:spTree>
       <p:nvGrpSpPr>
@@ -10619,14 +10711,7 @@
         <p:cNvGrpSpPr/>
         <p:nvPr/>
       </p:nvGrpSpPr>
-      <p:grpSpPr>
-        <a:xfrm>
-          <a:off x="0" y="0"/>
-          <a:ext cx="0" cy="0"/>
-          <a:chOff x="0" y="0"/>
-          <a:chExt cx="0" cy="0"/>
-        </a:xfrm>
-      </p:grpSpPr>
+      <p:grpSpPr/>
       <p:sp>
         <p:nvSpPr>
           <p:cNvPr id="2" name="Rectangle 1"/>
@@ -10668,7 +10753,6 @@
           <a:lstStyle/>
           <a:p>
             <a:pPr algn="ctr"/>
-            <a:endParaRPr/>
           </a:p>
         </p:txBody>
       </p:sp>
@@ -10713,7 +10797,6 @@
           <a:lstStyle/>
           <a:p>
             <a:pPr algn="ctr"/>
-            <a:endParaRPr/>
           </a:p>
         </p:txBody>
       </p:sp>
@@ -10819,7 +10902,6 @@
           <a:lstStyle/>
           <a:p>
             <a:pPr algn="ctr"/>
-            <a:endParaRPr/>
           </a:p>
         </p:txBody>
       </p:sp>
@@ -10864,7 +10946,6 @@
           <a:lstStyle/>
           <a:p>
             <a:pPr algn="ctr"/>
-            <a:endParaRPr/>
           </a:p>
         </p:txBody>
       </p:sp>
@@ -11008,7 +11089,6 @@
           <a:lstStyle/>
           <a:p>
             <a:pPr algn="ctr"/>
-            <a:endParaRPr/>
           </a:p>
         </p:txBody>
       </p:sp>
@@ -11095,7 +11175,6 @@
           <a:lstStyle/>
           <a:p>
             <a:pPr algn="ctr"/>
-            <a:endParaRPr/>
           </a:p>
         </p:txBody>
       </p:sp>
@@ -11140,7 +11219,6 @@
           <a:lstStyle/>
           <a:p>
             <a:pPr algn="ctr"/>
-            <a:endParaRPr/>
           </a:p>
         </p:txBody>
       </p:sp>
@@ -11153,7 +11231,7 @@
         <p:spPr>
           <a:xfrm>
             <a:off x="5303520" y="2468880"/>
-            <a:ext cx="2651760" cy="1220847"/>
+            <a:ext cx="2651760" cy="2011680"/>
           </a:xfrm>
           <a:prstGeom prst="rect">
             <a:avLst/>
@@ -11175,29 +11253,14 @@
               </a:spcAft>
             </a:pPr>
             <a:r>
-              <a:rPr sz="1600" b="1" dirty="0">
+              <a:rPr sz="1600" b="1">
                 <a:solidFill>
                   <a:srgbClr val="FFFFFF"/>
                 </a:solidFill>
                 <a:latin typeface="Calibri"/>
               </a:rPr>
-              <a:t>Our cloud</a:t>
-            </a:r>
-            <a:r>
-              <a:rPr lang="en-US" sz="1600" b="1" dirty="0">
-                <a:solidFill>
-                  <a:srgbClr val="FFFFFF"/>
-                </a:solidFill>
-                <a:latin typeface="Calibri"/>
-              </a:rPr>
-              <a:t> OR Datacenter</a:t>
-            </a:r>
-            <a:endParaRPr sz="1600" b="1" dirty="0">
-              <a:solidFill>
-                <a:srgbClr val="FFFFFF"/>
-              </a:solidFill>
-              <a:latin typeface="Calibri"/>
-            </a:endParaRPr>
+              <a:t>Our cloud (AWS)</a:t>
+            </a:r>
           </a:p>
           <a:p>
             <a:pPr algn="l">
@@ -11209,7 +11272,7 @@
               </a:spcAft>
             </a:pPr>
             <a:r>
-              <a:rPr sz="1300" b="0" dirty="0">
+              <a:rPr sz="1300" b="0">
                 <a:solidFill>
                   <a:srgbClr val="C8D4E0"/>
                 </a:solidFill>
@@ -11228,7 +11291,7 @@
               </a:spcAft>
             </a:pPr>
             <a:r>
-              <a:rPr sz="1300" b="0" dirty="0">
+              <a:rPr sz="1300" b="0">
                 <a:solidFill>
                   <a:srgbClr val="C8D4E0"/>
                 </a:solidFill>
@@ -11247,7 +11310,7 @@
               </a:spcAft>
             </a:pPr>
             <a:r>
-              <a:rPr sz="1300" b="0" dirty="0">
+              <a:rPr sz="1300" b="0">
                 <a:solidFill>
                   <a:srgbClr val="C8D4E0"/>
                 </a:solidFill>
@@ -11299,7 +11362,6 @@
           <a:lstStyle/>
           <a:p>
             <a:pPr algn="ctr"/>
-            <a:endParaRPr/>
           </a:p>
         </p:txBody>
       </p:sp>
@@ -11344,7 +11406,6 @@
           <a:lstStyle/>
           <a:p>
             <a:pPr algn="ctr"/>
-            <a:endParaRPr/>
           </a:p>
         </p:txBody>
       </p:sp>
@@ -11389,7 +11450,6 @@
           <a:lstStyle/>
           <a:p>
             <a:pPr algn="ctr"/>
-            <a:endParaRPr/>
           </a:p>
         </p:txBody>
       </p:sp>
@@ -11627,7 +11687,7 @@
 </file>
 
 <file path=ppt/slides/slide8.xml><?xml version="1.0" encoding="utf-8"?>
-<p:sld xmlns:a="http://schemas.openxmlformats.org/drawingml/2006/main" xmlns:r="http://schemas.openxmlformats.org/officeDocument/2006/relationships" xmlns:p="http://schemas.openxmlformats.org/presentationml/2006/main">
+<p:sld xmlns:a="http://schemas.openxmlformats.org/drawingml/2006/main" xmlns:p="http://schemas.openxmlformats.org/presentationml/2006/main" xmlns:r="http://schemas.openxmlformats.org/officeDocument/2006/relationships">
   <p:cSld>
     <p:spTree>
       <p:nvGrpSpPr>
@@ -11635,14 +11695,7 @@
         <p:cNvGrpSpPr/>
         <p:nvPr/>
       </p:nvGrpSpPr>
-      <p:grpSpPr>
-        <a:xfrm>
-          <a:off x="0" y="0"/>
-          <a:ext cx="0" cy="0"/>
-          <a:chOff x="0" y="0"/>
-          <a:chExt cx="0" cy="0"/>
-        </a:xfrm>
-      </p:grpSpPr>
+      <p:grpSpPr/>
       <p:sp>
         <p:nvSpPr>
           <p:cNvPr id="2" name="Rectangle 1"/>
@@ -11684,7 +11737,6 @@
           <a:lstStyle/>
           <a:p>
             <a:pPr algn="ctr"/>
-            <a:endParaRPr/>
           </a:p>
         </p:txBody>
       </p:sp>
@@ -11729,7 +11781,6 @@
           <a:lstStyle/>
           <a:p>
             <a:pPr algn="ctr"/>
-            <a:endParaRPr/>
           </a:p>
         </p:txBody>
       </p:sp>
@@ -11835,7 +11886,6 @@
           <a:lstStyle/>
           <a:p>
             <a:pPr algn="ctr"/>
-            <a:endParaRPr/>
           </a:p>
         </p:txBody>
       </p:sp>
@@ -11880,7 +11930,6 @@
           <a:lstStyle/>
           <a:p>
             <a:pPr algn="ctr"/>
-            <a:endParaRPr/>
           </a:p>
         </p:txBody>
       </p:sp>
@@ -12024,7 +12073,6 @@
           <a:lstStyle/>
           <a:p>
             <a:pPr algn="ctr"/>
-            <a:endParaRPr/>
           </a:p>
         </p:txBody>
       </p:sp>
@@ -12069,7 +12117,6 @@
           <a:lstStyle/>
           <a:p>
             <a:pPr algn="ctr"/>
-            <a:endParaRPr/>
           </a:p>
         </p:txBody>
       </p:sp>
@@ -12213,7 +12260,6 @@
           <a:lstStyle/>
           <a:p>
             <a:pPr algn="ctr"/>
-            <a:endParaRPr/>
           </a:p>
         </p:txBody>
       </p:sp>
@@ -12258,7 +12304,6 @@
           <a:lstStyle/>
           <a:p>
             <a:pPr algn="ctr"/>
-            <a:endParaRPr/>
           </a:p>
         </p:txBody>
       </p:sp>
@@ -12496,7 +12541,7 @@
 </file>
 
 <file path=ppt/slides/slide9.xml><?xml version="1.0" encoding="utf-8"?>
-<p:sld xmlns:a="http://schemas.openxmlformats.org/drawingml/2006/main" xmlns:r="http://schemas.openxmlformats.org/officeDocument/2006/relationships" xmlns:p="http://schemas.openxmlformats.org/presentationml/2006/main">
+<p:sld xmlns:a="http://schemas.openxmlformats.org/drawingml/2006/main" xmlns:p="http://schemas.openxmlformats.org/presentationml/2006/main" xmlns:r="http://schemas.openxmlformats.org/officeDocument/2006/relationships">
   <p:cSld>
     <p:spTree>
       <p:nvGrpSpPr>
@@ -12504,14 +12549,7 @@
         <p:cNvGrpSpPr/>
         <p:nvPr/>
       </p:nvGrpSpPr>
-      <p:grpSpPr>
-        <a:xfrm>
-          <a:off x="0" y="0"/>
-          <a:ext cx="0" cy="0"/>
-          <a:chOff x="0" y="0"/>
-          <a:chExt cx="0" cy="0"/>
-        </a:xfrm>
-      </p:grpSpPr>
+      <p:grpSpPr/>
       <p:sp>
         <p:nvSpPr>
           <p:cNvPr id="2" name="Rectangle 1"/>
@@ -12553,7 +12591,6 @@
           <a:lstStyle/>
           <a:p>
             <a:pPr algn="ctr"/>
-            <a:endParaRPr/>
           </a:p>
         </p:txBody>
       </p:sp>
@@ -12598,7 +12635,6 @@
           <a:lstStyle/>
           <a:p>
             <a:pPr algn="ctr"/>
-            <a:endParaRPr/>
           </a:p>
         </p:txBody>
       </p:sp>
@@ -12704,7 +12740,6 @@
           <a:lstStyle/>
           <a:p>
             <a:pPr algn="ctr"/>
-            <a:endParaRPr/>
           </a:p>
         </p:txBody>
       </p:sp>
@@ -12833,7 +12868,6 @@
           <a:lstStyle/>
           <a:p>
             <a:pPr algn="ctr"/>
-            <a:endParaRPr/>
           </a:p>
         </p:txBody>
       </p:sp>
@@ -12962,7 +12996,6 @@
           <a:lstStyle/>
           <a:p>
             <a:pPr algn="ctr"/>
-            <a:endParaRPr/>
           </a:p>
         </p:txBody>
       </p:sp>
@@ -13091,7 +13124,6 @@
           <a:lstStyle/>
           <a:p>
             <a:pPr algn="ctr"/>
-            <a:endParaRPr/>
           </a:p>
         </p:txBody>
       </p:sp>
@@ -13220,7 +13252,6 @@
           <a:lstStyle/>
           <a:p>
             <a:pPr algn="ctr"/>
-            <a:endParaRPr/>
           </a:p>
         </p:txBody>
       </p:sp>
@@ -13349,7 +13380,6 @@
           <a:lstStyle/>
           <a:p>
             <a:pPr algn="ctr"/>
-            <a:endParaRPr/>
           </a:p>
         </p:txBody>
       </p:sp>
@@ -13478,7 +13508,6 @@
           <a:lstStyle/>
           <a:p>
             <a:pPr algn="ctr"/>
-            <a:endParaRPr/>
           </a:p>
         </p:txBody>
       </p:sp>
@@ -13607,7 +13636,6 @@
           <a:lstStyle/>
           <a:p>
             <a:pPr algn="ctr"/>
-            <a:endParaRPr/>
           </a:p>
         </p:txBody>
       </p:sp>
@@ -14118,44 +14146,44 @@
         <a:sysClr val="window" lastClr="FFFFFF"/>
       </a:lt1>
       <a:dk2>
-        <a:srgbClr val="0E2841"/>
+        <a:srgbClr val="1F497D"/>
       </a:dk2>
       <a:lt2>
-        <a:srgbClr val="E8E8E8"/>
+        <a:srgbClr val="EEECE1"/>
       </a:lt2>
       <a:accent1>
-        <a:srgbClr val="156082"/>
+        <a:srgbClr val="4F81BD"/>
       </a:accent1>
       <a:accent2>
-        <a:srgbClr val="E97132"/>
+        <a:srgbClr val="C0504D"/>
       </a:accent2>
       <a:accent3>
-        <a:srgbClr val="196B24"/>
+        <a:srgbClr val="9BBB59"/>
       </a:accent3>
       <a:accent4>
-        <a:srgbClr val="0F9ED5"/>
+        <a:srgbClr val="8064A2"/>
       </a:accent4>
       <a:accent5>
-        <a:srgbClr val="A02B93"/>
+        <a:srgbClr val="4BACC6"/>
       </a:accent5>
       <a:accent6>
-        <a:srgbClr val="4EA72E"/>
+        <a:srgbClr val="F79646"/>
       </a:accent6>
       <a:hlink>
-        <a:srgbClr val="467886"/>
+        <a:srgbClr val="0000FF"/>
       </a:hlink>
       <a:folHlink>
-        <a:srgbClr val="96607D"/>
+        <a:srgbClr val="800080"/>
       </a:folHlink>
     </a:clrScheme>
     <a:fontScheme name="Office">
       <a:majorFont>
-        <a:latin typeface="Aptos Display" panose="02110004020202020204"/>
+        <a:latin typeface="Calibri"/>
         <a:ea typeface=""/>
         <a:cs typeface=""/>
-        <a:font script="Jpan" typeface="游ゴシック Light"/>
+        <a:font script="Jpan" typeface="ＭＳ Ｐゴシック"/>
         <a:font script="Hang" typeface="맑은 고딕"/>
-        <a:font script="Hans" typeface="等线 Light"/>
+        <a:font script="Hans" typeface="宋体"/>
         <a:font script="Hant" typeface="新細明體"/>
         <a:font script="Arab" typeface="Times New Roman"/>
         <a:font script="Hebr" typeface="Times New Roman"/>
@@ -14183,31 +14211,14 @@
         <a:font script="Viet" typeface="Times New Roman"/>
         <a:font script="Uigh" typeface="Microsoft Uighur"/>
         <a:font script="Geor" typeface="Sylfaen"/>
-        <a:font script="Armn" typeface="Arial"/>
-        <a:font script="Bugi" typeface="Leelawadee UI"/>
-        <a:font script="Bopo" typeface="Microsoft JhengHei"/>
-        <a:font script="Java" typeface="Javanese Text"/>
-        <a:font script="Lisu" typeface="Segoe UI"/>
-        <a:font script="Mymr" typeface="Myanmar Text"/>
-        <a:font script="Nkoo" typeface="Ebrima"/>
-        <a:font script="Olck" typeface="Nirmala UI"/>
-        <a:font script="Osma" typeface="Ebrima"/>
-        <a:font script="Phag" typeface="Phagspa"/>
-        <a:font script="Syrn" typeface="Estrangelo Edessa"/>
-        <a:font script="Syrj" typeface="Estrangelo Edessa"/>
-        <a:font script="Syre" typeface="Estrangelo Edessa"/>
-        <a:font script="Sora" typeface="Nirmala UI"/>
-        <a:font script="Tale" typeface="Microsoft Tai Le"/>
-        <a:font script="Talu" typeface="Microsoft New Tai Lue"/>
-        <a:font script="Tfng" typeface="Ebrima"/>
       </a:majorFont>
       <a:minorFont>
-        <a:latin typeface="Aptos" panose="02110004020202020204"/>
+        <a:latin typeface="Calibri"/>
         <a:ea typeface=""/>
         <a:cs typeface=""/>
-        <a:font script="Jpan" typeface="游ゴシック"/>
+        <a:font script="Jpan" typeface="ＭＳ Ｐゴシック"/>
         <a:font script="Hang" typeface="맑은 고딕"/>
-        <a:font script="Hans" typeface="等线"/>
+        <a:font script="Hans" typeface="宋体"/>
         <a:font script="Hant" typeface="新細明體"/>
         <a:font script="Arab" typeface="Arial"/>
         <a:font script="Hebr" typeface="Arial"/>
@@ -14235,23 +14246,6 @@
         <a:font script="Viet" typeface="Arial"/>
         <a:font script="Uigh" typeface="Microsoft Uighur"/>
         <a:font script="Geor" typeface="Sylfaen"/>
-        <a:font script="Armn" typeface="Arial"/>
-        <a:font script="Bugi" typeface="Leelawadee UI"/>
-        <a:font script="Bopo" typeface="Microsoft JhengHei"/>
-        <a:font script="Java" typeface="Javanese Text"/>
-        <a:font script="Lisu" typeface="Segoe UI"/>
-        <a:font script="Mymr" typeface="Myanmar Text"/>
-        <a:font script="Nkoo" typeface="Ebrima"/>
-        <a:font script="Olck" typeface="Nirmala UI"/>
-        <a:font script="Osma" typeface="Ebrima"/>
-        <a:font script="Phag" typeface="Phagspa"/>
-        <a:font script="Syrn" typeface="Estrangelo Edessa"/>
-        <a:font script="Syrj" typeface="Estrangelo Edessa"/>
-        <a:font script="Syre" typeface="Estrangelo Edessa"/>
-        <a:font script="Sora" typeface="Nirmala UI"/>
-        <a:font script="Tale" typeface="Microsoft Tai Le"/>
-        <a:font script="Talu" typeface="Microsoft New Tai Lue"/>
-        <a:font script="Tfng" typeface="Ebrima"/>
       </a:minorFont>
     </a:fontScheme>
     <a:fmtScheme name="Office">
@@ -14263,136 +14257,180 @@
           <a:gsLst>
             <a:gs pos="0">
               <a:schemeClr val="phClr">
-                <a:lumMod val="110000"/>
-                <a:satMod val="105000"/>
-                <a:tint val="67000"/>
+                <a:tint val="50000"/>
+                <a:satMod val="300000"/>
               </a:schemeClr>
             </a:gs>
-            <a:gs pos="50000">
+            <a:gs pos="35000">
               <a:schemeClr val="phClr">
-                <a:lumMod val="105000"/>
-                <a:satMod val="103000"/>
-                <a:tint val="73000"/>
+                <a:tint val="37000"/>
+                <a:satMod val="300000"/>
               </a:schemeClr>
             </a:gs>
             <a:gs pos="100000">
               <a:schemeClr val="phClr">
-                <a:lumMod val="105000"/>
-                <a:satMod val="109000"/>
-                <a:tint val="81000"/>
+                <a:tint val="15000"/>
+                <a:satMod val="350000"/>
               </a:schemeClr>
             </a:gs>
           </a:gsLst>
-          <a:lin ang="5400000" scaled="0"/>
+          <a:lin ang="16200000" scaled="1"/>
         </a:gradFill>
         <a:gradFill rotWithShape="1">
           <a:gsLst>
             <a:gs pos="0">
               <a:schemeClr val="phClr">
-                <a:satMod val="103000"/>
-                <a:lumMod val="102000"/>
-                <a:tint val="94000"/>
-              </a:schemeClr>
-            </a:gs>
-            <a:gs pos="50000">
-              <a:schemeClr val="phClr">
-                <a:satMod val="110000"/>
-                <a:lumMod val="100000"/>
+                <a:tint val="100000"/>
                 <a:shade val="100000"/>
+                <a:satMod val="130000"/>
               </a:schemeClr>
             </a:gs>
             <a:gs pos="100000">
               <a:schemeClr val="phClr">
-                <a:lumMod val="99000"/>
-                <a:satMod val="120000"/>
-                <a:shade val="78000"/>
+                <a:tint val="50000"/>
+                <a:shade val="100000"/>
+                <a:satMod val="350000"/>
               </a:schemeClr>
             </a:gs>
           </a:gsLst>
-          <a:lin ang="5400000" scaled="0"/>
+          <a:lin ang="16200000" scaled="0"/>
         </a:gradFill>
       </a:fillStyleLst>
       <a:lnStyleLst>
-        <a:ln w="12700" cap="flat" cmpd="sng" algn="ctr">
+        <a:ln w="9525" cap="flat" cmpd="sng" algn="ctr">
           <a:solidFill>
-            <a:schemeClr val="phClr"/>
+            <a:schemeClr val="phClr">
+              <a:shade val="95000"/>
+              <a:satMod val="105000"/>
+            </a:schemeClr>
           </a:solidFill>
           <a:prstDash val="solid"/>
-          <a:miter lim="800000"/>
-        </a:ln>
-        <a:ln w="19050" cap="flat" cmpd="sng" algn="ctr">
-          <a:solidFill>
-            <a:schemeClr val="phClr"/>
-          </a:solidFill>
-          <a:prstDash val="solid"/>
-          <a:miter lim="800000"/>
         </a:ln>
         <a:ln w="25400" cap="flat" cmpd="sng" algn="ctr">
           <a:solidFill>
             <a:schemeClr val="phClr"/>
           </a:solidFill>
           <a:prstDash val="solid"/>
-          <a:miter lim="800000"/>
+        </a:ln>
+        <a:ln w="38100" cap="flat" cmpd="sng" algn="ctr">
+          <a:solidFill>
+            <a:schemeClr val="phClr"/>
+          </a:solidFill>
+          <a:prstDash val="solid"/>
         </a:ln>
       </a:lnStyleLst>
       <a:effectStyleLst>
         <a:effectStyle>
-          <a:effectLst/>
-        </a:effectStyle>
-        <a:effectStyle>
-          <a:effectLst/>
+          <a:effectLst>
+            <a:outerShdw blurRad="40000" dist="20000" dir="5400000" rotWithShape="0">
+              <a:srgbClr val="000000">
+                <a:alpha val="38000"/>
+              </a:srgbClr>
+            </a:outerShdw>
+          </a:effectLst>
         </a:effectStyle>
         <a:effectStyle>
           <a:effectLst>
-            <a:outerShdw blurRad="57150" dist="19050" dir="5400000" algn="ctr" rotWithShape="0">
+            <a:outerShdw blurRad="40000" dist="23000" dir="5400000" rotWithShape="0">
               <a:srgbClr val="000000">
-                <a:alpha val="63000"/>
+                <a:alpha val="35000"/>
               </a:srgbClr>
             </a:outerShdw>
           </a:effectLst>
+        </a:effectStyle>
+        <a:effectStyle>
+          <a:effectLst>
+            <a:outerShdw blurRad="40000" dist="23000" dir="5400000" rotWithShape="0">
+              <a:srgbClr val="000000">
+                <a:alpha val="35000"/>
+              </a:srgbClr>
+            </a:outerShdw>
+          </a:effectLst>
+          <a:scene3d>
+            <a:camera prst="orthographicFront">
+              <a:rot lat="0" lon="0" rev="0"/>
+            </a:camera>
+            <a:lightRig rig="threePt" dir="t">
+              <a:rot lat="0" lon="0" rev="1200000"/>
+            </a:lightRig>
+          </a:scene3d>
+          <a:sp3d>
+            <a:bevelT w="63500" h="25400"/>
+          </a:sp3d>
         </a:effectStyle>
       </a:effectStyleLst>
       <a:bgFillStyleLst>
         <a:solidFill>
           <a:schemeClr val="phClr"/>
         </a:solidFill>
-        <a:solidFill>
-          <a:schemeClr val="phClr">
-            <a:tint val="95000"/>
-            <a:satMod val="170000"/>
-          </a:schemeClr>
-        </a:solidFill>
         <a:gradFill rotWithShape="1">
           <a:gsLst>
             <a:gs pos="0">
               <a:schemeClr val="phClr">
-                <a:tint val="93000"/>
-                <a:satMod val="150000"/>
-                <a:shade val="98000"/>
-                <a:lumMod val="102000"/>
+                <a:tint val="40000"/>
+                <a:satMod val="350000"/>
               </a:schemeClr>
             </a:gs>
-            <a:gs pos="50000">
+            <a:gs pos="40000">
               <a:schemeClr val="phClr">
-                <a:tint val="98000"/>
-                <a:satMod val="130000"/>
-                <a:shade val="90000"/>
-                <a:lumMod val="103000"/>
+                <a:tint val="45000"/>
+                <a:shade val="99000"/>
+                <a:satMod val="350000"/>
               </a:schemeClr>
             </a:gs>
             <a:gs pos="100000">
               <a:schemeClr val="phClr">
-                <a:shade val="63000"/>
-                <a:satMod val="120000"/>
+                <a:shade val="20000"/>
+                <a:satMod val="255000"/>
               </a:schemeClr>
             </a:gs>
           </a:gsLst>
-          <a:lin ang="5400000" scaled="0"/>
+          <a:path path="circle">
+            <a:fillToRect l="50000" t="-80000" r="50000" b="180000"/>
+          </a:path>
+        </a:gradFill>
+        <a:gradFill rotWithShape="1">
+          <a:gsLst>
+            <a:gs pos="0">
+              <a:schemeClr val="phClr">
+                <a:tint val="80000"/>
+                <a:satMod val="300000"/>
+              </a:schemeClr>
+            </a:gs>
+            <a:gs pos="100000">
+              <a:schemeClr val="phClr">
+                <a:shade val="30000"/>
+                <a:satMod val="200000"/>
+              </a:schemeClr>
+            </a:gs>
+          </a:gsLst>
+          <a:path path="circle">
+            <a:fillToRect l="50000" t="50000" r="50000" b="50000"/>
+          </a:path>
         </a:gradFill>
       </a:bgFillStyleLst>
     </a:fmtScheme>
   </a:themeElements>
   <a:objectDefaults>
+    <a:spDef>
+      <a:spPr/>
+      <a:bodyPr/>
+      <a:lstStyle/>
+      <a:style>
+        <a:lnRef idx="1">
+          <a:schemeClr val="accent1"/>
+        </a:lnRef>
+        <a:fillRef idx="3">
+          <a:schemeClr val="accent1"/>
+        </a:fillRef>
+        <a:effectRef idx="2">
+          <a:schemeClr val="accent1"/>
+        </a:effectRef>
+        <a:fontRef idx="minor">
+          <a:schemeClr val="lt1"/>
+        </a:fontRef>
+      </a:style>
+    </a:spDef>
     <a:lnDef>
       <a:spPr/>
       <a:bodyPr/>
@@ -14414,10 +14452,5 @@
     </a:lnDef>
   </a:objectDefaults>
   <a:extraClrSchemeLst/>
-  <a:extLst>
-    <a:ext uri="{05A4C25C-085E-4340-85A3-A5531E510DB2}">
-      <thm15:themeFamily xmlns:thm15="http://schemas.microsoft.com/office/thememl/2012/main" name="Office Theme" id="{2E142A2C-CD16-42D6-873A-C26D2A0506FA}" vid="{1BDDFF52-6CD6-40A5-AB3C-68EB2F1E4D0A}"/>
-    </a:ext>
-  </a:extLst>
 </a:theme>
 </file>
</xml_diff>